<commit_message>
docs(pitch): 補 #15 的兩件事——MAX Skill 修正＋AI-native 對照（18→20 頁）
不等 Drive 上那份 14 頁原檔，直接把該修的做進新簡報。

## 1. MAX Skill 誤標為執行模組（#15 第 1 點）

新增「開發工具鏈」一頁，逐項標明什麼在產品 runtime 裡、什麼不在：
  - max-api-skill＝給 AI 看的 API 文件包，不執行任何交易
  - max-mcp-server＝開發期工具（.kiro/settings/mcp.json 的 autoApprove
    只給唯讀的 ticker/depth/kline）
  - Kiro IDE＝開發環境
  - OrderFunction → MAX Private API＝唯一真正送單的路徑

證據落在頁面上：.kiro/settings/mcp.json 與 backend/handlers/order.py:56。
特別寫明為什麼要澄清——把開發工具畫進 runtime，等於把一個不存在的攻擊面
畫給評審看，而整套安全敘事的地基就是「送單路徑只有一條」。

## 2. AI-native 應用對照（#15 第 2 點）

用「誠實地逐項問一次：哪些部分其實不需要 AI？」的方式寫，而不是宣稱
到處都是 AI：行為健檢數字與三方案金額**不需要**生成式 AI（那是
precompute.py 與 scenarios.py 的確定性計算）；需要的是聽懂自由語句、
在恐慌當下把個人紀錄講成人話、同一組數字換三種語氣、防詐意圖判讀＋RAG。

結論句：沒有生成式 AI 這產品會退化成一個儀表板，而儀表板攔不住正在
恐慌的人。

（模型選擇與成本效益本來就有，在「模型分工」與「單位經濟學」兩頁。）

## 順帶

- md() 支援反引號 → <code>，檔案路徑用等寬字跟敘述分開；pptx 端把記號去掉
- table 版型支援 lead 引言
- 收緊架構頁的層距：新增頁後在 1280x720 下溢出 21px。已在 1280x720 與
  1920x1080 兩種投影解析度確認 20 頁全部不溢出

Co-Authored-By: Claude Opus 5 <noreply@anthropic.com>
</commit_message>
<xml_diff>
--- a/docs/MaiMate_提案簡報_20260731.pptx
+++ b/docs/MaiMate_提案簡報_20260731.pptx
@@ -23,9 +23,11 @@
     <p:sldId id="271" r:id="rId17"/>
     <p:sldId id="272" r:id="rId18"/>
     <p:sldId id="273" r:id="rId19"/>
+    <p:sldId id="274" r:id="rId20"/>
+    <p:sldId id="275" r:id="rId21"/>
   </p:sldIdLst>
   <p:notesMasterIdLst>
-    <p:notesMasterId r:id="rId20"/>
+    <p:notesMasterId r:id="rId22"/>
   </p:notesMasterIdLst>
   <p:sldSz cx="12192000" cy="6858000"/>
   <p:notesSz cx="6858000" cy="12192000"/>
@@ -1353,6 +1355,94 @@
 </p:notes>
 </file>
 
+<file path=ppt/notesSlides/notesSlide19.xml><?xml version="1.0" encoding="utf-8"?>
+<p:notes xmlns:a="http://schemas.openxmlformats.org/drawingml/2006/main" xmlns:r="http://schemas.openxmlformats.org/officeDocument/2006/relationships" xmlns:p="http://schemas.openxmlformats.org/presentationml/2006/main">
+  <p:cSld>
+    <p:spTree>
+      <p:nvGrpSpPr>
+        <p:cNvPr id="1" name=""/>
+        <p:cNvGrpSpPr/>
+        <p:nvPr/>
+      </p:nvGrpSpPr>
+      <p:grpSpPr>
+        <a:xfrm>
+          <a:off x="0" y="0"/>
+          <a:ext cx="0" cy="0"/>
+          <a:chOff x="0" y="0"/>
+          <a:chExt cx="0" cy="0"/>
+        </a:xfrm>
+      </p:grpSpPr>
+      <p:sp>
+        <p:nvSpPr>
+          <p:cNvPr id="2" name="Slide Image Placeholder 1"/>
+          <p:cNvSpPr>
+            <a:spLocks noGrp="1" noRot="1" noChangeAspect="1"/>
+          </p:cNvSpPr>
+          <p:nvPr>
+            <p:ph type="sldImg"/>
+          </p:nvPr>
+        </p:nvSpPr>
+        <p:spPr/>
+      </p:sp>
+      <p:sp>
+        <p:nvSpPr>
+          <p:cNvPr id="3" name="Notes Placeholder 2"/>
+          <p:cNvSpPr>
+            <a:spLocks noGrp="1"/>
+          </p:cNvSpPr>
+          <p:nvPr>
+            <p:ph type="body" idx="1"/>
+          </p:nvPr>
+        </p:nvSpPr>
+        <p:spPr/>
+        <p:txBody>
+          <a:bodyPr/>
+          <a:lstStyle/>
+          <a:p>
+            <a:r>
+              <a:rPr lang="en-US" dirty="0"/>
+              <a:t/>
+            </a:r>
+            <a:endParaRPr lang="en-US" dirty="0"/>
+          </a:p>
+        </p:txBody>
+      </p:sp>
+      <p:sp>
+        <p:nvSpPr>
+          <p:cNvPr id="4" name="Slide Number Placeholder 3"/>
+          <p:cNvSpPr>
+            <a:spLocks noGrp="1"/>
+          </p:cNvSpPr>
+          <p:nvPr>
+            <p:ph type="sldNum" sz="quarter" idx="10"/>
+          </p:nvPr>
+        </p:nvSpPr>
+        <p:spPr/>
+        <p:txBody>
+          <a:bodyPr/>
+          <a:lstStyle/>
+          <a:p>
+            <a:fld id="{F7021451-1387-4CA6-816F-3879F97B5CBC}" type="slidenum">
+              <a:rPr lang="en-US"/>
+              <a:t>19</a:t>
+            </a:fld>
+            <a:endParaRPr lang="en-US"/>
+          </a:p>
+        </p:txBody>
+      </p:sp>
+    </p:spTree>
+    <p:extLst>
+      <p:ext uri="{BB962C8B-B14F-4D97-AF65-F5344CB8AC3E}">
+        <p14:creationId xmlns:p14="http://schemas.microsoft.com/office/powerpoint/2010/main" val="1024086991"/>
+      </p:ext>
+    </p:extLst>
+  </p:cSld>
+  <p:clrMapOvr>
+    <a:masterClrMapping/>
+  </p:clrMapOvr>
+</p:notes>
+</file>
+
 <file path=ppt/notesSlides/notesSlide2.xml><?xml version="1.0" encoding="utf-8"?>
 <p:notes xmlns:a="http://schemas.openxmlformats.org/drawingml/2006/main" xmlns:r="http://schemas.openxmlformats.org/officeDocument/2006/relationships" xmlns:p="http://schemas.openxmlformats.org/presentationml/2006/main">
   <p:cSld>
@@ -1423,6 +1513,94 @@
             <a:fld id="{F7021451-1387-4CA6-816F-3879F97B5CBC}" type="slidenum">
               <a:rPr lang="en-US"/>
               <a:t>2</a:t>
+            </a:fld>
+            <a:endParaRPr lang="en-US"/>
+          </a:p>
+        </p:txBody>
+      </p:sp>
+    </p:spTree>
+    <p:extLst>
+      <p:ext uri="{BB962C8B-B14F-4D97-AF65-F5344CB8AC3E}">
+        <p14:creationId xmlns:p14="http://schemas.microsoft.com/office/powerpoint/2010/main" val="1024086991"/>
+      </p:ext>
+    </p:extLst>
+  </p:cSld>
+  <p:clrMapOvr>
+    <a:masterClrMapping/>
+  </p:clrMapOvr>
+</p:notes>
+</file>
+
+<file path=ppt/notesSlides/notesSlide20.xml><?xml version="1.0" encoding="utf-8"?>
+<p:notes xmlns:a="http://schemas.openxmlformats.org/drawingml/2006/main" xmlns:r="http://schemas.openxmlformats.org/officeDocument/2006/relationships" xmlns:p="http://schemas.openxmlformats.org/presentationml/2006/main">
+  <p:cSld>
+    <p:spTree>
+      <p:nvGrpSpPr>
+        <p:cNvPr id="1" name=""/>
+        <p:cNvGrpSpPr/>
+        <p:nvPr/>
+      </p:nvGrpSpPr>
+      <p:grpSpPr>
+        <a:xfrm>
+          <a:off x="0" y="0"/>
+          <a:ext cx="0" cy="0"/>
+          <a:chOff x="0" y="0"/>
+          <a:chExt cx="0" cy="0"/>
+        </a:xfrm>
+      </p:grpSpPr>
+      <p:sp>
+        <p:nvSpPr>
+          <p:cNvPr id="2" name="Slide Image Placeholder 1"/>
+          <p:cNvSpPr>
+            <a:spLocks noGrp="1" noRot="1" noChangeAspect="1"/>
+          </p:cNvSpPr>
+          <p:nvPr>
+            <p:ph type="sldImg"/>
+          </p:nvPr>
+        </p:nvSpPr>
+        <p:spPr/>
+      </p:sp>
+      <p:sp>
+        <p:nvSpPr>
+          <p:cNvPr id="3" name="Notes Placeholder 2"/>
+          <p:cNvSpPr>
+            <a:spLocks noGrp="1"/>
+          </p:cNvSpPr>
+          <p:nvPr>
+            <p:ph type="body" idx="1"/>
+          </p:nvPr>
+        </p:nvSpPr>
+        <p:spPr/>
+        <p:txBody>
+          <a:bodyPr/>
+          <a:lstStyle/>
+          <a:p>
+            <a:r>
+              <a:rPr lang="en-US" dirty="0"/>
+              <a:t/>
+            </a:r>
+            <a:endParaRPr lang="en-US" dirty="0"/>
+          </a:p>
+        </p:txBody>
+      </p:sp>
+      <p:sp>
+        <p:nvSpPr>
+          <p:cNvPr id="4" name="Slide Number Placeholder 3"/>
+          <p:cNvSpPr>
+            <a:spLocks noGrp="1"/>
+          </p:cNvSpPr>
+          <p:nvPr>
+            <p:ph type="sldNum" sz="quarter" idx="10"/>
+          </p:nvPr>
+        </p:nvSpPr>
+        <p:spPr/>
+        <p:txBody>
+          <a:bodyPr/>
+          <a:lstStyle/>
+          <a:p>
+            <a:fld id="{F7021451-1387-4CA6-816F-3879F97B5CBC}" type="slidenum">
+              <a:rPr lang="en-US"/>
+              <a:t>20</a:t>
             </a:fld>
             <a:endParaRPr lang="en-US"/>
           </a:p>
@@ -2570,7 +2748,7 @@
                 <a:ea typeface="Microsoft JhengHei" pitchFamily="34" charset="-122"/>
                 <a:cs typeface="Microsoft JhengHei" pitchFamily="34" charset="-120"/>
               </a:rPr>
-              <a:t>AI 設計</a:t>
+              <a:t>開發工具鏈</a:t>
             </a:r>
             <a:endParaRPr lang="en-US" sz="1200" dirty="0"/>
           </a:p>
@@ -2609,7 +2787,7 @@
                 <a:ea typeface="Microsoft JhengHei" pitchFamily="34" charset="-122"/>
                 <a:cs typeface="Microsoft JhengHei" pitchFamily="34" charset="-120"/>
               </a:rPr>
-              <a:t>模型分工：貴的只用在該用的地方</a:t>
+              <a:t>會下單的只有一條路，而它不在工具鏈上</a:t>
             </a:r>
             <a:endParaRPr lang="en-US" sz="3000" dirty="0"/>
           </a:p>
@@ -2618,6 +2796,1304 @@
       <p:graphicFrame>
         <p:nvGraphicFramePr>
           <p:cNvPr id="11" name="Table 0"/>
+          <p:cNvGraphicFramePr>
+            <a:graphicFrameLocks noGrp="1"/>
+          </p:cNvGraphicFramePr>
+          <p:nvPr>
+            <p:extLst>
+              <p:ext uri="{D42A27DB-BD31-4B8C-83A1-F6EECF244321}">
+                <p14:modId xmlns:p14="http://schemas.microsoft.com/office/powerpoint/2010/main" val="1579011935"/>
+              </p:ext>
+            </p:extLst>
+          </p:nvPr>
+        </p:nvGraphicFramePr>
+        <p:xfrm>
+          <a:off x="640080" y="1709928"/>
+          <a:ext cx="10908792" cy="914400"/>
+        </p:xfrm>
+        <a:graphic>
+          <a:graphicData uri="http://schemas.openxmlformats.org/drawingml/2006/table">
+            <a:tbl>
+              <a:tblPr/>
+              <a:tblGrid>
+                <a:gridCol w="3636264"/>
+                <a:gridCol w="3636264"/>
+                <a:gridCol w="3636264"/>
+              </a:tblGrid>
+              <a:tr h="0">
+                <a:tc>
+                  <a:txBody>
+                    <a:bodyPr/>
+                    <a:lstStyle/>
+                    <a:p>
+                      <a:pPr indent="0" marL="0">
+                        <a:buNone/>
+                      </a:pPr>
+                      <a:r>
+                        <a:rPr lang="en-US" sz="1100" b="1" dirty="0">
+                          <a:solidFill>
+                            <a:srgbClr val="E8A13A"/>
+                          </a:solidFill>
+                          <a:latin typeface="Microsoft JhengHei" pitchFamily="34" charset="0"/>
+                          <a:ea typeface="Microsoft JhengHei" pitchFamily="34" charset="-122"/>
+                          <a:cs typeface="Microsoft JhengHei" pitchFamily="34" charset="-120"/>
+                        </a:rPr>
+                        <a:t>元件</a:t>
+                      </a:r>
+                      <a:endParaRPr lang="en-US" sz="1100" dirty="0">
+                        <a:latin typeface="Microsoft JhengHei" charset="0"/>
+                        <a:ea typeface="Microsoft JhengHei" charset="0"/>
+                        <a:cs typeface="Microsoft JhengHei" charset="0"/>
+                      </a:endParaRPr>
+                    </a:p>
+                  </a:txBody>
+                  <a:tcPr marL="91440" marR="91440" marT="45720" marB="45720" anchor="t">
+                    <a:lnL w="6350" cap="flat" cmpd="sng" algn="ctr">
+                      <a:solidFill>
+                        <a:srgbClr val="2B3B72"/>
+                      </a:solidFill>
+                      <a:prstDash val="solid"/>
+                      <a:round/>
+                      <a:headEnd type="none" w="med" len="med"/>
+                      <a:tailEnd type="none" w="med" len="med"/>
+                    </a:lnL>
+                    <a:lnR w="6350" cap="flat" cmpd="sng" algn="ctr">
+                      <a:solidFill>
+                        <a:srgbClr val="2B3B72"/>
+                      </a:solidFill>
+                      <a:prstDash val="solid"/>
+                      <a:round/>
+                      <a:headEnd type="none" w="med" len="med"/>
+                      <a:tailEnd type="none" w="med" len="med"/>
+                    </a:lnR>
+                    <a:lnT w="6350" cap="flat" cmpd="sng" algn="ctr">
+                      <a:solidFill>
+                        <a:srgbClr val="2B3B72"/>
+                      </a:solidFill>
+                      <a:prstDash val="solid"/>
+                      <a:round/>
+                      <a:headEnd type="none" w="med" len="med"/>
+                      <a:tailEnd type="none" w="med" len="med"/>
+                    </a:lnT>
+                    <a:lnB w="6350" cap="flat" cmpd="sng" algn="ctr">
+                      <a:solidFill>
+                        <a:srgbClr val="2B3B72"/>
+                      </a:solidFill>
+                      <a:prstDash val="solid"/>
+                      <a:round/>
+                      <a:headEnd type="none" w="med" len="med"/>
+                      <a:tailEnd type="none" w="med" len="med"/>
+                    </a:lnB>
+                    <a:solidFill>
+                      <a:srgbClr val="1D2B5C"/>
+                    </a:solidFill>
+                  </a:tcPr>
+                </a:tc>
+                <a:tc>
+                  <a:txBody>
+                    <a:bodyPr/>
+                    <a:lstStyle/>
+                    <a:p>
+                      <a:pPr indent="0" marL="0">
+                        <a:buNone/>
+                      </a:pPr>
+                      <a:r>
+                        <a:rPr lang="en-US" sz="1100" b="1" dirty="0">
+                          <a:solidFill>
+                            <a:srgbClr val="E8A13A"/>
+                          </a:solidFill>
+                          <a:latin typeface="Microsoft JhengHei" pitchFamily="34" charset="0"/>
+                          <a:ea typeface="Microsoft JhengHei" pitchFamily="34" charset="-122"/>
+                          <a:cs typeface="Microsoft JhengHei" pitchFamily="34" charset="-120"/>
+                        </a:rPr>
+                        <a:t>實際是什麼</a:t>
+                      </a:r>
+                      <a:endParaRPr lang="en-US" sz="1100" dirty="0">
+                        <a:latin typeface="Microsoft JhengHei" charset="0"/>
+                        <a:ea typeface="Microsoft JhengHei" charset="0"/>
+                        <a:cs typeface="Microsoft JhengHei" charset="0"/>
+                      </a:endParaRPr>
+                    </a:p>
+                  </a:txBody>
+                  <a:tcPr marL="91440" marR="91440" marT="45720" marB="45720" anchor="t">
+                    <a:lnL w="6350" cap="flat" cmpd="sng" algn="ctr">
+                      <a:solidFill>
+                        <a:srgbClr val="2B3B72"/>
+                      </a:solidFill>
+                      <a:prstDash val="solid"/>
+                      <a:round/>
+                      <a:headEnd type="none" w="med" len="med"/>
+                      <a:tailEnd type="none" w="med" len="med"/>
+                    </a:lnL>
+                    <a:lnR w="6350" cap="flat" cmpd="sng" algn="ctr">
+                      <a:solidFill>
+                        <a:srgbClr val="2B3B72"/>
+                      </a:solidFill>
+                      <a:prstDash val="solid"/>
+                      <a:round/>
+                      <a:headEnd type="none" w="med" len="med"/>
+                      <a:tailEnd type="none" w="med" len="med"/>
+                    </a:lnR>
+                    <a:lnT w="6350" cap="flat" cmpd="sng" algn="ctr">
+                      <a:solidFill>
+                        <a:srgbClr val="2B3B72"/>
+                      </a:solidFill>
+                      <a:prstDash val="solid"/>
+                      <a:round/>
+                      <a:headEnd type="none" w="med" len="med"/>
+                      <a:tailEnd type="none" w="med" len="med"/>
+                    </a:lnT>
+                    <a:lnB w="6350" cap="flat" cmpd="sng" algn="ctr">
+                      <a:solidFill>
+                        <a:srgbClr val="2B3B72"/>
+                      </a:solidFill>
+                      <a:prstDash val="solid"/>
+                      <a:round/>
+                      <a:headEnd type="none" w="med" len="med"/>
+                      <a:tailEnd type="none" w="med" len="med"/>
+                    </a:lnB>
+                    <a:solidFill>
+                      <a:srgbClr val="1D2B5C"/>
+                    </a:solidFill>
+                  </a:tcPr>
+                </a:tc>
+                <a:tc>
+                  <a:txBody>
+                    <a:bodyPr/>
+                    <a:lstStyle/>
+                    <a:p>
+                      <a:pPr indent="0" marL="0">
+                        <a:buNone/>
+                      </a:pPr>
+                      <a:r>
+                        <a:rPr lang="en-US" sz="1100" b="1" dirty="0">
+                          <a:solidFill>
+                            <a:srgbClr val="E8A13A"/>
+                          </a:solidFill>
+                          <a:latin typeface="Microsoft JhengHei" pitchFamily="34" charset="0"/>
+                          <a:ea typeface="Microsoft JhengHei" pitchFamily="34" charset="-122"/>
+                          <a:cs typeface="Microsoft JhengHei" pitchFamily="34" charset="-120"/>
+                        </a:rPr>
+                        <a:t>在產品 runtime 裡嗎</a:t>
+                      </a:r>
+                      <a:endParaRPr lang="en-US" sz="1100" dirty="0">
+                        <a:latin typeface="Microsoft JhengHei" charset="0"/>
+                        <a:ea typeface="Microsoft JhengHei" charset="0"/>
+                        <a:cs typeface="Microsoft JhengHei" charset="0"/>
+                      </a:endParaRPr>
+                    </a:p>
+                  </a:txBody>
+                  <a:tcPr marL="91440" marR="91440" marT="45720" marB="45720" anchor="t">
+                    <a:lnL w="6350" cap="flat" cmpd="sng" algn="ctr">
+                      <a:solidFill>
+                        <a:srgbClr val="2B3B72"/>
+                      </a:solidFill>
+                      <a:prstDash val="solid"/>
+                      <a:round/>
+                      <a:headEnd type="none" w="med" len="med"/>
+                      <a:tailEnd type="none" w="med" len="med"/>
+                    </a:lnL>
+                    <a:lnR w="6350" cap="flat" cmpd="sng" algn="ctr">
+                      <a:solidFill>
+                        <a:srgbClr val="2B3B72"/>
+                      </a:solidFill>
+                      <a:prstDash val="solid"/>
+                      <a:round/>
+                      <a:headEnd type="none" w="med" len="med"/>
+                      <a:tailEnd type="none" w="med" len="med"/>
+                    </a:lnR>
+                    <a:lnT w="6350" cap="flat" cmpd="sng" algn="ctr">
+                      <a:solidFill>
+                        <a:srgbClr val="2B3B72"/>
+                      </a:solidFill>
+                      <a:prstDash val="solid"/>
+                      <a:round/>
+                      <a:headEnd type="none" w="med" len="med"/>
+                      <a:tailEnd type="none" w="med" len="med"/>
+                    </a:lnT>
+                    <a:lnB w="6350" cap="flat" cmpd="sng" algn="ctr">
+                      <a:solidFill>
+                        <a:srgbClr val="2B3B72"/>
+                      </a:solidFill>
+                      <a:prstDash val="solid"/>
+                      <a:round/>
+                      <a:headEnd type="none" w="med" len="med"/>
+                      <a:tailEnd type="none" w="med" len="med"/>
+                    </a:lnB>
+                    <a:solidFill>
+                      <a:srgbClr val="1D2B5C"/>
+                    </a:solidFill>
+                  </a:tcPr>
+                </a:tc>
+              </a:tr>
+              <a:tr h="0">
+                <a:tc>
+                  <a:txBody>
+                    <a:bodyPr/>
+                    <a:lstStyle/>
+                    <a:p>
+                      <a:pPr indent="0" marL="0">
+                        <a:buNone/>
+                      </a:pPr>
+                      <a:r>
+                        <a:rPr lang="en-US" sz="1100" dirty="0">
+                          <a:solidFill>
+                            <a:srgbClr val="EAF0FB"/>
+                          </a:solidFill>
+                          <a:latin typeface="Microsoft JhengHei" pitchFamily="34" charset="0"/>
+                          <a:ea typeface="Microsoft JhengHei" pitchFamily="34" charset="-122"/>
+                          <a:cs typeface="Microsoft JhengHei" pitchFamily="34" charset="-120"/>
+                        </a:rPr>
+                        <a:t>max-api-skill</a:t>
+                      </a:r>
+                      <a:endParaRPr lang="en-US" sz="1100" dirty="0">
+                        <a:latin typeface="Microsoft JhengHei" charset="0"/>
+                        <a:ea typeface="Microsoft JhengHei" charset="0"/>
+                        <a:cs typeface="Microsoft JhengHei" charset="0"/>
+                      </a:endParaRPr>
+                    </a:p>
+                  </a:txBody>
+                  <a:tcPr marL="91440" marR="91440" marT="45720" marB="45720" anchor="t">
+                    <a:lnL w="6350" cap="flat" cmpd="sng" algn="ctr">
+                      <a:solidFill>
+                        <a:srgbClr val="2B3B72"/>
+                      </a:solidFill>
+                      <a:prstDash val="solid"/>
+                      <a:round/>
+                      <a:headEnd type="none" w="med" len="med"/>
+                      <a:tailEnd type="none" w="med" len="med"/>
+                    </a:lnL>
+                    <a:lnR w="6350" cap="flat" cmpd="sng" algn="ctr">
+                      <a:solidFill>
+                        <a:srgbClr val="2B3B72"/>
+                      </a:solidFill>
+                      <a:prstDash val="solid"/>
+                      <a:round/>
+                      <a:headEnd type="none" w="med" len="med"/>
+                      <a:tailEnd type="none" w="med" len="med"/>
+                    </a:lnR>
+                    <a:lnT w="6350" cap="flat" cmpd="sng" algn="ctr">
+                      <a:solidFill>
+                        <a:srgbClr val="2B3B72"/>
+                      </a:solidFill>
+                      <a:prstDash val="solid"/>
+                      <a:round/>
+                      <a:headEnd type="none" w="med" len="med"/>
+                      <a:tailEnd type="none" w="med" len="med"/>
+                    </a:lnT>
+                    <a:lnB w="6350" cap="flat" cmpd="sng" algn="ctr">
+                      <a:solidFill>
+                        <a:srgbClr val="2B3B72"/>
+                      </a:solidFill>
+                      <a:prstDash val="solid"/>
+                      <a:round/>
+                      <a:headEnd type="none" w="med" len="med"/>
+                      <a:tailEnd type="none" w="med" len="med"/>
+                    </a:lnB>
+                  </a:tcPr>
+                </a:tc>
+                <a:tc>
+                  <a:txBody>
+                    <a:bodyPr/>
+                    <a:lstStyle/>
+                    <a:p>
+                      <a:pPr indent="0" marL="0">
+                        <a:buNone/>
+                      </a:pPr>
+                      <a:r>
+                        <a:rPr lang="en-US" sz="1100" dirty="0">
+                          <a:solidFill>
+                            <a:srgbClr val="EAF0FB"/>
+                          </a:solidFill>
+                          <a:latin typeface="Microsoft JhengHei" pitchFamily="34" charset="0"/>
+                          <a:ea typeface="Microsoft JhengHei" pitchFamily="34" charset="-122"/>
+                          <a:cs typeface="Microsoft JhengHei" pitchFamily="34" charset="-120"/>
+                        </a:rPr>
+                        <a:t>給 AI 看的 API 文件包——它不執行任何交易</a:t>
+                      </a:r>
+                      <a:endParaRPr lang="en-US" sz="1100" dirty="0">
+                        <a:latin typeface="Microsoft JhengHei" charset="0"/>
+                        <a:ea typeface="Microsoft JhengHei" charset="0"/>
+                        <a:cs typeface="Microsoft JhengHei" charset="0"/>
+                      </a:endParaRPr>
+                    </a:p>
+                  </a:txBody>
+                  <a:tcPr marL="91440" marR="91440" marT="45720" marB="45720" anchor="t">
+                    <a:lnL w="6350" cap="flat" cmpd="sng" algn="ctr">
+                      <a:solidFill>
+                        <a:srgbClr val="2B3B72"/>
+                      </a:solidFill>
+                      <a:prstDash val="solid"/>
+                      <a:round/>
+                      <a:headEnd type="none" w="med" len="med"/>
+                      <a:tailEnd type="none" w="med" len="med"/>
+                    </a:lnL>
+                    <a:lnR w="6350" cap="flat" cmpd="sng" algn="ctr">
+                      <a:solidFill>
+                        <a:srgbClr val="2B3B72"/>
+                      </a:solidFill>
+                      <a:prstDash val="solid"/>
+                      <a:round/>
+                      <a:headEnd type="none" w="med" len="med"/>
+                      <a:tailEnd type="none" w="med" len="med"/>
+                    </a:lnR>
+                    <a:lnT w="6350" cap="flat" cmpd="sng" algn="ctr">
+                      <a:solidFill>
+                        <a:srgbClr val="2B3B72"/>
+                      </a:solidFill>
+                      <a:prstDash val="solid"/>
+                      <a:round/>
+                      <a:headEnd type="none" w="med" len="med"/>
+                      <a:tailEnd type="none" w="med" len="med"/>
+                    </a:lnT>
+                    <a:lnB w="6350" cap="flat" cmpd="sng" algn="ctr">
+                      <a:solidFill>
+                        <a:srgbClr val="2B3B72"/>
+                      </a:solidFill>
+                      <a:prstDash val="solid"/>
+                      <a:round/>
+                      <a:headEnd type="none" w="med" len="med"/>
+                      <a:tailEnd type="none" w="med" len="med"/>
+                    </a:lnB>
+                  </a:tcPr>
+                </a:tc>
+                <a:tc>
+                  <a:txBody>
+                    <a:bodyPr/>
+                    <a:lstStyle/>
+                    <a:p>
+                      <a:pPr indent="0" marL="0">
+                        <a:buNone/>
+                      </a:pPr>
+                      <a:r>
+                        <a:rPr lang="en-US" sz="1100" dirty="0">
+                          <a:solidFill>
+                            <a:srgbClr val="EAF0FB"/>
+                          </a:solidFill>
+                          <a:latin typeface="Microsoft JhengHei" pitchFamily="34" charset="0"/>
+                          <a:ea typeface="Microsoft JhengHei" pitchFamily="34" charset="-122"/>
+                          <a:cs typeface="Microsoft JhengHei" pitchFamily="34" charset="-120"/>
+                        </a:rPr>
+                        <a:t>否</a:t>
+                      </a:r>
+                      <a:endParaRPr lang="en-US" sz="1100" dirty="0">
+                        <a:latin typeface="Microsoft JhengHei" charset="0"/>
+                        <a:ea typeface="Microsoft JhengHei" charset="0"/>
+                        <a:cs typeface="Microsoft JhengHei" charset="0"/>
+                      </a:endParaRPr>
+                    </a:p>
+                  </a:txBody>
+                  <a:tcPr marL="91440" marR="91440" marT="45720" marB="45720" anchor="t">
+                    <a:lnL w="6350" cap="flat" cmpd="sng" algn="ctr">
+                      <a:solidFill>
+                        <a:srgbClr val="2B3B72"/>
+                      </a:solidFill>
+                      <a:prstDash val="solid"/>
+                      <a:round/>
+                      <a:headEnd type="none" w="med" len="med"/>
+                      <a:tailEnd type="none" w="med" len="med"/>
+                    </a:lnL>
+                    <a:lnR w="6350" cap="flat" cmpd="sng" algn="ctr">
+                      <a:solidFill>
+                        <a:srgbClr val="2B3B72"/>
+                      </a:solidFill>
+                      <a:prstDash val="solid"/>
+                      <a:round/>
+                      <a:headEnd type="none" w="med" len="med"/>
+                      <a:tailEnd type="none" w="med" len="med"/>
+                    </a:lnR>
+                    <a:lnT w="6350" cap="flat" cmpd="sng" algn="ctr">
+                      <a:solidFill>
+                        <a:srgbClr val="2B3B72"/>
+                      </a:solidFill>
+                      <a:prstDash val="solid"/>
+                      <a:round/>
+                      <a:headEnd type="none" w="med" len="med"/>
+                      <a:tailEnd type="none" w="med" len="med"/>
+                    </a:lnT>
+                    <a:lnB w="6350" cap="flat" cmpd="sng" algn="ctr">
+                      <a:solidFill>
+                        <a:srgbClr val="2B3B72"/>
+                      </a:solidFill>
+                      <a:prstDash val="solid"/>
+                      <a:round/>
+                      <a:headEnd type="none" w="med" len="med"/>
+                      <a:tailEnd type="none" w="med" len="med"/>
+                    </a:lnB>
+                  </a:tcPr>
+                </a:tc>
+              </a:tr>
+              <a:tr h="0">
+                <a:tc>
+                  <a:txBody>
+                    <a:bodyPr/>
+                    <a:lstStyle/>
+                    <a:p>
+                      <a:pPr indent="0" marL="0">
+                        <a:buNone/>
+                      </a:pPr>
+                      <a:r>
+                        <a:rPr lang="en-US" sz="1100" dirty="0">
+                          <a:solidFill>
+                            <a:srgbClr val="EAF0FB"/>
+                          </a:solidFill>
+                          <a:latin typeface="Microsoft JhengHei" pitchFamily="34" charset="0"/>
+                          <a:ea typeface="Microsoft JhengHei" pitchFamily="34" charset="-122"/>
+                          <a:cs typeface="Microsoft JhengHei" pitchFamily="34" charset="-120"/>
+                        </a:rPr>
+                        <a:t>max-mcp-server</a:t>
+                      </a:r>
+                      <a:endParaRPr lang="en-US" sz="1100" dirty="0">
+                        <a:latin typeface="Microsoft JhengHei" charset="0"/>
+                        <a:ea typeface="Microsoft JhengHei" charset="0"/>
+                        <a:cs typeface="Microsoft JhengHei" charset="0"/>
+                      </a:endParaRPr>
+                    </a:p>
+                  </a:txBody>
+                  <a:tcPr marL="91440" marR="91440" marT="45720" marB="45720" anchor="t">
+                    <a:lnL w="6350" cap="flat" cmpd="sng" algn="ctr">
+                      <a:solidFill>
+                        <a:srgbClr val="2B3B72"/>
+                      </a:solidFill>
+                      <a:prstDash val="solid"/>
+                      <a:round/>
+                      <a:headEnd type="none" w="med" len="med"/>
+                      <a:tailEnd type="none" w="med" len="med"/>
+                    </a:lnL>
+                    <a:lnR w="6350" cap="flat" cmpd="sng" algn="ctr">
+                      <a:solidFill>
+                        <a:srgbClr val="2B3B72"/>
+                      </a:solidFill>
+                      <a:prstDash val="solid"/>
+                      <a:round/>
+                      <a:headEnd type="none" w="med" len="med"/>
+                      <a:tailEnd type="none" w="med" len="med"/>
+                    </a:lnR>
+                    <a:lnT w="6350" cap="flat" cmpd="sng" algn="ctr">
+                      <a:solidFill>
+                        <a:srgbClr val="2B3B72"/>
+                      </a:solidFill>
+                      <a:prstDash val="solid"/>
+                      <a:round/>
+                      <a:headEnd type="none" w="med" len="med"/>
+                      <a:tailEnd type="none" w="med" len="med"/>
+                    </a:lnT>
+                    <a:lnB w="6350" cap="flat" cmpd="sng" algn="ctr">
+                      <a:solidFill>
+                        <a:srgbClr val="2B3B72"/>
+                      </a:solidFill>
+                      <a:prstDash val="solid"/>
+                      <a:round/>
+                      <a:headEnd type="none" w="med" len="med"/>
+                      <a:tailEnd type="none" w="med" len="med"/>
+                    </a:lnB>
+                  </a:tcPr>
+                </a:tc>
+                <a:tc>
+                  <a:txBody>
+                    <a:bodyPr/>
+                    <a:lstStyle/>
+                    <a:p>
+                      <a:pPr indent="0" marL="0">
+                        <a:buNone/>
+                      </a:pPr>
+                      <a:r>
+                        <a:rPr lang="en-US" sz="1100" dirty="0">
+                          <a:solidFill>
+                            <a:srgbClr val="EAF0FB"/>
+                          </a:solidFill>
+                          <a:latin typeface="Microsoft JhengHei" pitchFamily="34" charset="0"/>
+                          <a:ea typeface="Microsoft JhengHei" pitchFamily="34" charset="-122"/>
+                          <a:cs typeface="Microsoft JhengHei" pitchFamily="34" charset="-120"/>
+                        </a:rPr>
+                        <a:t>開發期工具，接在 Kiro 裡查行情用；設定檔的 autoApprove 只給唯讀的 ticker／depth／kline</a:t>
+                      </a:r>
+                      <a:endParaRPr lang="en-US" sz="1100" dirty="0">
+                        <a:latin typeface="Microsoft JhengHei" charset="0"/>
+                        <a:ea typeface="Microsoft JhengHei" charset="0"/>
+                        <a:cs typeface="Microsoft JhengHei" charset="0"/>
+                      </a:endParaRPr>
+                    </a:p>
+                  </a:txBody>
+                  <a:tcPr marL="91440" marR="91440" marT="45720" marB="45720" anchor="t">
+                    <a:lnL w="6350" cap="flat" cmpd="sng" algn="ctr">
+                      <a:solidFill>
+                        <a:srgbClr val="2B3B72"/>
+                      </a:solidFill>
+                      <a:prstDash val="solid"/>
+                      <a:round/>
+                      <a:headEnd type="none" w="med" len="med"/>
+                      <a:tailEnd type="none" w="med" len="med"/>
+                    </a:lnL>
+                    <a:lnR w="6350" cap="flat" cmpd="sng" algn="ctr">
+                      <a:solidFill>
+                        <a:srgbClr val="2B3B72"/>
+                      </a:solidFill>
+                      <a:prstDash val="solid"/>
+                      <a:round/>
+                      <a:headEnd type="none" w="med" len="med"/>
+                      <a:tailEnd type="none" w="med" len="med"/>
+                    </a:lnR>
+                    <a:lnT w="6350" cap="flat" cmpd="sng" algn="ctr">
+                      <a:solidFill>
+                        <a:srgbClr val="2B3B72"/>
+                      </a:solidFill>
+                      <a:prstDash val="solid"/>
+                      <a:round/>
+                      <a:headEnd type="none" w="med" len="med"/>
+                      <a:tailEnd type="none" w="med" len="med"/>
+                    </a:lnT>
+                    <a:lnB w="6350" cap="flat" cmpd="sng" algn="ctr">
+                      <a:solidFill>
+                        <a:srgbClr val="2B3B72"/>
+                      </a:solidFill>
+                      <a:prstDash val="solid"/>
+                      <a:round/>
+                      <a:headEnd type="none" w="med" len="med"/>
+                      <a:tailEnd type="none" w="med" len="med"/>
+                    </a:lnB>
+                  </a:tcPr>
+                </a:tc>
+                <a:tc>
+                  <a:txBody>
+                    <a:bodyPr/>
+                    <a:lstStyle/>
+                    <a:p>
+                      <a:pPr indent="0" marL="0">
+                        <a:buNone/>
+                      </a:pPr>
+                      <a:r>
+                        <a:rPr lang="en-US" sz="1100" dirty="0">
+                          <a:solidFill>
+                            <a:srgbClr val="EAF0FB"/>
+                          </a:solidFill>
+                          <a:latin typeface="Microsoft JhengHei" pitchFamily="34" charset="0"/>
+                          <a:ea typeface="Microsoft JhengHei" pitchFamily="34" charset="-122"/>
+                          <a:cs typeface="Microsoft JhengHei" pitchFamily="34" charset="-120"/>
+                        </a:rPr>
+                        <a:t>否</a:t>
+                      </a:r>
+                      <a:endParaRPr lang="en-US" sz="1100" dirty="0">
+                        <a:latin typeface="Microsoft JhengHei" charset="0"/>
+                        <a:ea typeface="Microsoft JhengHei" charset="0"/>
+                        <a:cs typeface="Microsoft JhengHei" charset="0"/>
+                      </a:endParaRPr>
+                    </a:p>
+                  </a:txBody>
+                  <a:tcPr marL="91440" marR="91440" marT="45720" marB="45720" anchor="t">
+                    <a:lnL w="6350" cap="flat" cmpd="sng" algn="ctr">
+                      <a:solidFill>
+                        <a:srgbClr val="2B3B72"/>
+                      </a:solidFill>
+                      <a:prstDash val="solid"/>
+                      <a:round/>
+                      <a:headEnd type="none" w="med" len="med"/>
+                      <a:tailEnd type="none" w="med" len="med"/>
+                    </a:lnL>
+                    <a:lnR w="6350" cap="flat" cmpd="sng" algn="ctr">
+                      <a:solidFill>
+                        <a:srgbClr val="2B3B72"/>
+                      </a:solidFill>
+                      <a:prstDash val="solid"/>
+                      <a:round/>
+                      <a:headEnd type="none" w="med" len="med"/>
+                      <a:tailEnd type="none" w="med" len="med"/>
+                    </a:lnR>
+                    <a:lnT w="6350" cap="flat" cmpd="sng" algn="ctr">
+                      <a:solidFill>
+                        <a:srgbClr val="2B3B72"/>
+                      </a:solidFill>
+                      <a:prstDash val="solid"/>
+                      <a:round/>
+                      <a:headEnd type="none" w="med" len="med"/>
+                      <a:tailEnd type="none" w="med" len="med"/>
+                    </a:lnT>
+                    <a:lnB w="6350" cap="flat" cmpd="sng" algn="ctr">
+                      <a:solidFill>
+                        <a:srgbClr val="2B3B72"/>
+                      </a:solidFill>
+                      <a:prstDash val="solid"/>
+                      <a:round/>
+                      <a:headEnd type="none" w="med" len="med"/>
+                      <a:tailEnd type="none" w="med" len="med"/>
+                    </a:lnB>
+                  </a:tcPr>
+                </a:tc>
+              </a:tr>
+              <a:tr h="0">
+                <a:tc>
+                  <a:txBody>
+                    <a:bodyPr/>
+                    <a:lstStyle/>
+                    <a:p>
+                      <a:pPr indent="0" marL="0">
+                        <a:buNone/>
+                      </a:pPr>
+                      <a:r>
+                        <a:rPr lang="en-US" sz="1100" dirty="0">
+                          <a:solidFill>
+                            <a:srgbClr val="EAF0FB"/>
+                          </a:solidFill>
+                          <a:latin typeface="Microsoft JhengHei" pitchFamily="34" charset="0"/>
+                          <a:ea typeface="Microsoft JhengHei" pitchFamily="34" charset="-122"/>
+                          <a:cs typeface="Microsoft JhengHei" pitchFamily="34" charset="-120"/>
+                        </a:rPr>
+                        <a:t>Kiro IDE</a:t>
+                      </a:r>
+                      <a:endParaRPr lang="en-US" sz="1100" dirty="0">
+                        <a:latin typeface="Microsoft JhengHei" charset="0"/>
+                        <a:ea typeface="Microsoft JhengHei" charset="0"/>
+                        <a:cs typeface="Microsoft JhengHei" charset="0"/>
+                      </a:endParaRPr>
+                    </a:p>
+                  </a:txBody>
+                  <a:tcPr marL="91440" marR="91440" marT="45720" marB="45720" anchor="t">
+                    <a:lnL w="6350" cap="flat" cmpd="sng" algn="ctr">
+                      <a:solidFill>
+                        <a:srgbClr val="2B3B72"/>
+                      </a:solidFill>
+                      <a:prstDash val="solid"/>
+                      <a:round/>
+                      <a:headEnd type="none" w="med" len="med"/>
+                      <a:tailEnd type="none" w="med" len="med"/>
+                    </a:lnL>
+                    <a:lnR w="6350" cap="flat" cmpd="sng" algn="ctr">
+                      <a:solidFill>
+                        <a:srgbClr val="2B3B72"/>
+                      </a:solidFill>
+                      <a:prstDash val="solid"/>
+                      <a:round/>
+                      <a:headEnd type="none" w="med" len="med"/>
+                      <a:tailEnd type="none" w="med" len="med"/>
+                    </a:lnR>
+                    <a:lnT w="6350" cap="flat" cmpd="sng" algn="ctr">
+                      <a:solidFill>
+                        <a:srgbClr val="2B3B72"/>
+                      </a:solidFill>
+                      <a:prstDash val="solid"/>
+                      <a:round/>
+                      <a:headEnd type="none" w="med" len="med"/>
+                      <a:tailEnd type="none" w="med" len="med"/>
+                    </a:lnT>
+                    <a:lnB w="6350" cap="flat" cmpd="sng" algn="ctr">
+                      <a:solidFill>
+                        <a:srgbClr val="2B3B72"/>
+                      </a:solidFill>
+                      <a:prstDash val="solid"/>
+                      <a:round/>
+                      <a:headEnd type="none" w="med" len="med"/>
+                      <a:tailEnd type="none" w="med" len="med"/>
+                    </a:lnB>
+                  </a:tcPr>
+                </a:tc>
+                <a:tc>
+                  <a:txBody>
+                    <a:bodyPr/>
+                    <a:lstStyle/>
+                    <a:p>
+                      <a:pPr indent="0" marL="0">
+                        <a:buNone/>
+                      </a:pPr>
+                      <a:r>
+                        <a:rPr lang="en-US" sz="1100" dirty="0">
+                          <a:solidFill>
+                            <a:srgbClr val="EAF0FB"/>
+                          </a:solidFill>
+                          <a:latin typeface="Microsoft JhengHei" pitchFamily="34" charset="0"/>
+                          <a:ea typeface="Microsoft JhengHei" pitchFamily="34" charset="-122"/>
+                          <a:cs typeface="Microsoft JhengHei" pitchFamily="34" charset="-120"/>
+                        </a:rPr>
+                        <a:t>開發環境（spec／steering／task 執行）</a:t>
+                      </a:r>
+                      <a:endParaRPr lang="en-US" sz="1100" dirty="0">
+                        <a:latin typeface="Microsoft JhengHei" charset="0"/>
+                        <a:ea typeface="Microsoft JhengHei" charset="0"/>
+                        <a:cs typeface="Microsoft JhengHei" charset="0"/>
+                      </a:endParaRPr>
+                    </a:p>
+                  </a:txBody>
+                  <a:tcPr marL="91440" marR="91440" marT="45720" marB="45720" anchor="t">
+                    <a:lnL w="6350" cap="flat" cmpd="sng" algn="ctr">
+                      <a:solidFill>
+                        <a:srgbClr val="2B3B72"/>
+                      </a:solidFill>
+                      <a:prstDash val="solid"/>
+                      <a:round/>
+                      <a:headEnd type="none" w="med" len="med"/>
+                      <a:tailEnd type="none" w="med" len="med"/>
+                    </a:lnL>
+                    <a:lnR w="6350" cap="flat" cmpd="sng" algn="ctr">
+                      <a:solidFill>
+                        <a:srgbClr val="2B3B72"/>
+                      </a:solidFill>
+                      <a:prstDash val="solid"/>
+                      <a:round/>
+                      <a:headEnd type="none" w="med" len="med"/>
+                      <a:tailEnd type="none" w="med" len="med"/>
+                    </a:lnR>
+                    <a:lnT w="6350" cap="flat" cmpd="sng" algn="ctr">
+                      <a:solidFill>
+                        <a:srgbClr val="2B3B72"/>
+                      </a:solidFill>
+                      <a:prstDash val="solid"/>
+                      <a:round/>
+                      <a:headEnd type="none" w="med" len="med"/>
+                      <a:tailEnd type="none" w="med" len="med"/>
+                    </a:lnT>
+                    <a:lnB w="6350" cap="flat" cmpd="sng" algn="ctr">
+                      <a:solidFill>
+                        <a:srgbClr val="2B3B72"/>
+                      </a:solidFill>
+                      <a:prstDash val="solid"/>
+                      <a:round/>
+                      <a:headEnd type="none" w="med" len="med"/>
+                      <a:tailEnd type="none" w="med" len="med"/>
+                    </a:lnB>
+                  </a:tcPr>
+                </a:tc>
+                <a:tc>
+                  <a:txBody>
+                    <a:bodyPr/>
+                    <a:lstStyle/>
+                    <a:p>
+                      <a:pPr indent="0" marL="0">
+                        <a:buNone/>
+                      </a:pPr>
+                      <a:r>
+                        <a:rPr lang="en-US" sz="1100" dirty="0">
+                          <a:solidFill>
+                            <a:srgbClr val="EAF0FB"/>
+                          </a:solidFill>
+                          <a:latin typeface="Microsoft JhengHei" pitchFamily="34" charset="0"/>
+                          <a:ea typeface="Microsoft JhengHei" pitchFamily="34" charset="-122"/>
+                          <a:cs typeface="Microsoft JhengHei" pitchFamily="34" charset="-120"/>
+                        </a:rPr>
+                        <a:t>否</a:t>
+                      </a:r>
+                      <a:endParaRPr lang="en-US" sz="1100" dirty="0">
+                        <a:latin typeface="Microsoft JhengHei" charset="0"/>
+                        <a:ea typeface="Microsoft JhengHei" charset="0"/>
+                        <a:cs typeface="Microsoft JhengHei" charset="0"/>
+                      </a:endParaRPr>
+                    </a:p>
+                  </a:txBody>
+                  <a:tcPr marL="91440" marR="91440" marT="45720" marB="45720" anchor="t">
+                    <a:lnL w="6350" cap="flat" cmpd="sng" algn="ctr">
+                      <a:solidFill>
+                        <a:srgbClr val="2B3B72"/>
+                      </a:solidFill>
+                      <a:prstDash val="solid"/>
+                      <a:round/>
+                      <a:headEnd type="none" w="med" len="med"/>
+                      <a:tailEnd type="none" w="med" len="med"/>
+                    </a:lnL>
+                    <a:lnR w="6350" cap="flat" cmpd="sng" algn="ctr">
+                      <a:solidFill>
+                        <a:srgbClr val="2B3B72"/>
+                      </a:solidFill>
+                      <a:prstDash val="solid"/>
+                      <a:round/>
+                      <a:headEnd type="none" w="med" len="med"/>
+                      <a:tailEnd type="none" w="med" len="med"/>
+                    </a:lnR>
+                    <a:lnT w="6350" cap="flat" cmpd="sng" algn="ctr">
+                      <a:solidFill>
+                        <a:srgbClr val="2B3B72"/>
+                      </a:solidFill>
+                      <a:prstDash val="solid"/>
+                      <a:round/>
+                      <a:headEnd type="none" w="med" len="med"/>
+                      <a:tailEnd type="none" w="med" len="med"/>
+                    </a:lnT>
+                    <a:lnB w="6350" cap="flat" cmpd="sng" algn="ctr">
+                      <a:solidFill>
+                        <a:srgbClr val="2B3B72"/>
+                      </a:solidFill>
+                      <a:prstDash val="solid"/>
+                      <a:round/>
+                      <a:headEnd type="none" w="med" len="med"/>
+                      <a:tailEnd type="none" w="med" len="med"/>
+                    </a:lnB>
+                  </a:tcPr>
+                </a:tc>
+              </a:tr>
+              <a:tr h="0">
+                <a:tc>
+                  <a:txBody>
+                    <a:bodyPr/>
+                    <a:lstStyle/>
+                    <a:p>
+                      <a:pPr indent="0" marL="0">
+                        <a:buNone/>
+                      </a:pPr>
+                      <a:r>
+                        <a:rPr lang="en-US" sz="1100" dirty="0">
+                          <a:solidFill>
+                            <a:srgbClr val="EAF0FB"/>
+                          </a:solidFill>
+                          <a:latin typeface="Microsoft JhengHei" pitchFamily="34" charset="0"/>
+                          <a:ea typeface="Microsoft JhengHei" pitchFamily="34" charset="-122"/>
+                          <a:cs typeface="Microsoft JhengHei" pitchFamily="34" charset="-120"/>
+                        </a:rPr>
+                        <a:t>OrderFunction → MAX Private API</a:t>
+                      </a:r>
+                      <a:endParaRPr lang="en-US" sz="1100" dirty="0">
+                        <a:latin typeface="Microsoft JhengHei" charset="0"/>
+                        <a:ea typeface="Microsoft JhengHei" charset="0"/>
+                        <a:cs typeface="Microsoft JhengHei" charset="0"/>
+                      </a:endParaRPr>
+                    </a:p>
+                  </a:txBody>
+                  <a:tcPr marL="91440" marR="91440" marT="45720" marB="45720" anchor="t">
+                    <a:lnL w="6350" cap="flat" cmpd="sng" algn="ctr">
+                      <a:solidFill>
+                        <a:srgbClr val="2B3B72"/>
+                      </a:solidFill>
+                      <a:prstDash val="solid"/>
+                      <a:round/>
+                      <a:headEnd type="none" w="med" len="med"/>
+                      <a:tailEnd type="none" w="med" len="med"/>
+                    </a:lnL>
+                    <a:lnR w="6350" cap="flat" cmpd="sng" algn="ctr">
+                      <a:solidFill>
+                        <a:srgbClr val="2B3B72"/>
+                      </a:solidFill>
+                      <a:prstDash val="solid"/>
+                      <a:round/>
+                      <a:headEnd type="none" w="med" len="med"/>
+                      <a:tailEnd type="none" w="med" len="med"/>
+                    </a:lnR>
+                    <a:lnT w="6350" cap="flat" cmpd="sng" algn="ctr">
+                      <a:solidFill>
+                        <a:srgbClr val="2B3B72"/>
+                      </a:solidFill>
+                      <a:prstDash val="solid"/>
+                      <a:round/>
+                      <a:headEnd type="none" w="med" len="med"/>
+                      <a:tailEnd type="none" w="med" len="med"/>
+                    </a:lnT>
+                    <a:lnB w="6350" cap="flat" cmpd="sng" algn="ctr">
+                      <a:solidFill>
+                        <a:srgbClr val="2B3B72"/>
+                      </a:solidFill>
+                      <a:prstDash val="solid"/>
+                      <a:round/>
+                      <a:headEnd type="none" w="med" len="med"/>
+                      <a:tailEnd type="none" w="med" len="med"/>
+                    </a:lnB>
+                  </a:tcPr>
+                </a:tc>
+                <a:tc>
+                  <a:txBody>
+                    <a:bodyPr/>
+                    <a:lstStyle/>
+                    <a:p>
+                      <a:pPr indent="0" marL="0">
+                        <a:buNone/>
+                      </a:pPr>
+                      <a:r>
+                        <a:rPr lang="en-US" sz="1100" dirty="0">
+                          <a:solidFill>
+                            <a:srgbClr val="EAF0FB"/>
+                          </a:solidFill>
+                          <a:latin typeface="Microsoft JhengHei" pitchFamily="34" charset="0"/>
+                          <a:ea typeface="Microsoft JhengHei" pitchFamily="34" charset="-122"/>
+                          <a:cs typeface="Microsoft JhengHei" pitchFamily="34" charset="-120"/>
+                        </a:rPr>
+                        <a:t>使用者按下確認後唯一真正送單的路徑</a:t>
+                      </a:r>
+                      <a:endParaRPr lang="en-US" sz="1100" dirty="0">
+                        <a:latin typeface="Microsoft JhengHei" charset="0"/>
+                        <a:ea typeface="Microsoft JhengHei" charset="0"/>
+                        <a:cs typeface="Microsoft JhengHei" charset="0"/>
+                      </a:endParaRPr>
+                    </a:p>
+                  </a:txBody>
+                  <a:tcPr marL="91440" marR="91440" marT="45720" marB="45720" anchor="t">
+                    <a:lnL w="6350" cap="flat" cmpd="sng" algn="ctr">
+                      <a:solidFill>
+                        <a:srgbClr val="2B3B72"/>
+                      </a:solidFill>
+                      <a:prstDash val="solid"/>
+                      <a:round/>
+                      <a:headEnd type="none" w="med" len="med"/>
+                      <a:tailEnd type="none" w="med" len="med"/>
+                    </a:lnL>
+                    <a:lnR w="6350" cap="flat" cmpd="sng" algn="ctr">
+                      <a:solidFill>
+                        <a:srgbClr val="2B3B72"/>
+                      </a:solidFill>
+                      <a:prstDash val="solid"/>
+                      <a:round/>
+                      <a:headEnd type="none" w="med" len="med"/>
+                      <a:tailEnd type="none" w="med" len="med"/>
+                    </a:lnR>
+                    <a:lnT w="6350" cap="flat" cmpd="sng" algn="ctr">
+                      <a:solidFill>
+                        <a:srgbClr val="2B3B72"/>
+                      </a:solidFill>
+                      <a:prstDash val="solid"/>
+                      <a:round/>
+                      <a:headEnd type="none" w="med" len="med"/>
+                      <a:tailEnd type="none" w="med" len="med"/>
+                    </a:lnT>
+                    <a:lnB w="6350" cap="flat" cmpd="sng" algn="ctr">
+                      <a:solidFill>
+                        <a:srgbClr val="2B3B72"/>
+                      </a:solidFill>
+                      <a:prstDash val="solid"/>
+                      <a:round/>
+                      <a:headEnd type="none" w="med" len="med"/>
+                      <a:tailEnd type="none" w="med" len="med"/>
+                    </a:lnB>
+                  </a:tcPr>
+                </a:tc>
+                <a:tc>
+                  <a:txBody>
+                    <a:bodyPr/>
+                    <a:lstStyle/>
+                    <a:p>
+                      <a:pPr indent="0" marL="0">
+                        <a:buNone/>
+                      </a:pPr>
+                      <a:r>
+                        <a:rPr lang="en-US" sz="1100" dirty="0">
+                          <a:solidFill>
+                            <a:srgbClr val="EAF0FB"/>
+                          </a:solidFill>
+                          <a:latin typeface="Microsoft JhengHei" pitchFamily="34" charset="0"/>
+                          <a:ea typeface="Microsoft JhengHei" pitchFamily="34" charset="-122"/>
+                          <a:cs typeface="Microsoft JhengHei" pitchFamily="34" charset="-120"/>
+                        </a:rPr>
+                        <a:t>是，只有這條</a:t>
+                      </a:r>
+                      <a:endParaRPr lang="en-US" sz="1100" dirty="0">
+                        <a:latin typeface="Microsoft JhengHei" charset="0"/>
+                        <a:ea typeface="Microsoft JhengHei" charset="0"/>
+                        <a:cs typeface="Microsoft JhengHei" charset="0"/>
+                      </a:endParaRPr>
+                    </a:p>
+                  </a:txBody>
+                  <a:tcPr marL="91440" marR="91440" marT="45720" marB="45720" anchor="t">
+                    <a:lnL w="6350" cap="flat" cmpd="sng" algn="ctr">
+                      <a:solidFill>
+                        <a:srgbClr val="2B3B72"/>
+                      </a:solidFill>
+                      <a:prstDash val="solid"/>
+                      <a:round/>
+                      <a:headEnd type="none" w="med" len="med"/>
+                      <a:tailEnd type="none" w="med" len="med"/>
+                    </a:lnL>
+                    <a:lnR w="6350" cap="flat" cmpd="sng" algn="ctr">
+                      <a:solidFill>
+                        <a:srgbClr val="2B3B72"/>
+                      </a:solidFill>
+                      <a:prstDash val="solid"/>
+                      <a:round/>
+                      <a:headEnd type="none" w="med" len="med"/>
+                      <a:tailEnd type="none" w="med" len="med"/>
+                    </a:lnR>
+                    <a:lnT w="6350" cap="flat" cmpd="sng" algn="ctr">
+                      <a:solidFill>
+                        <a:srgbClr val="2B3B72"/>
+                      </a:solidFill>
+                      <a:prstDash val="solid"/>
+                      <a:round/>
+                      <a:headEnd type="none" w="med" len="med"/>
+                      <a:tailEnd type="none" w="med" len="med"/>
+                    </a:lnT>
+                    <a:lnB w="6350" cap="flat" cmpd="sng" algn="ctr">
+                      <a:solidFill>
+                        <a:srgbClr val="2B3B72"/>
+                      </a:solidFill>
+                      <a:prstDash val="solid"/>
+                      <a:round/>
+                      <a:headEnd type="none" w="med" len="med"/>
+                      <a:tailEnd type="none" w="med" len="med"/>
+                    </a:lnB>
+                  </a:tcPr>
+                </a:tc>
+              </a:tr>
+            </a:tbl>
+          </a:graphicData>
+        </a:graphic>
+      </p:graphicFrame>
+      <p:sp>
+        <p:nvSpPr>
+          <p:cNvPr id="5" name="Shape 2"/>
+          <p:cNvSpPr/>
+          <p:nvPr/>
+        </p:nvSpPr>
+        <p:spPr>
+          <a:xfrm>
+            <a:off x="640080" y="4315968"/>
+            <a:ext cx="41148" cy="685800"/>
+          </a:xfrm>
+          <a:prstGeom prst="rect">
+            <a:avLst/>
+          </a:prstGeom>
+          <a:solidFill>
+            <a:srgbClr val="E8A13A"/>
+          </a:solidFill>
+          <a:ln/>
+        </p:spPr>
+      </p:sp>
+      <p:sp>
+        <p:nvSpPr>
+          <p:cNvPr id="6" name="Text 3"/>
+          <p:cNvSpPr/>
+          <p:nvPr/>
+        </p:nvSpPr>
+        <p:spPr>
+          <a:xfrm>
+            <a:off x="804672" y="4315968"/>
+            <a:ext cx="10744200" cy="822960"/>
+          </a:xfrm>
+          <a:prstGeom prst="rect">
+            <a:avLst/>
+          </a:prstGeom>
+          <a:noFill/>
+          <a:ln/>
+        </p:spPr>
+        <p:txBody>
+          <a:bodyPr wrap="square" rtlCol="0" anchor="t"/>
+          <a:lstStyle/>
+          <a:p>
+            <a:pPr indent="0" marL="0">
+              <a:lnSpc>
+                <a:spcPts val="1800"/>
+              </a:lnSpc>
+              <a:buNone/>
+            </a:pPr>
+            <a:r>
+              <a:rPr lang="en-US" sz="1150" dirty="0">
+                <a:solidFill>
+                  <a:srgbClr val="B9C6E0"/>
+                </a:solidFill>
+                <a:latin typeface="Microsoft JhengHei" pitchFamily="34" charset="0"/>
+                <a:ea typeface="Microsoft JhengHei" pitchFamily="34" charset="-122"/>
+                <a:cs typeface="Microsoft JhengHei" pitchFamily="34" charset="-120"/>
+              </a:rPr>
+              <a:t>這頁是修正：先前版本把 MAX Skill 標成執行模組。文件包不會下單。</a:t>
+            </a:r>
+            <a:endParaRPr lang="en-US" sz="1150" dirty="0"/>
+          </a:p>
+          <a:p>
+            <a:pPr indent="0" marL="0">
+              <a:lnSpc>
+                <a:spcPts val="1800"/>
+              </a:lnSpc>
+              <a:buNone/>
+            </a:pPr>
+            <a:r>
+              <a:rPr lang="en-US" sz="1150" dirty="0">
+                <a:solidFill>
+                  <a:srgbClr val="B9C6E0"/>
+                </a:solidFill>
+                <a:latin typeface="Microsoft JhengHei" pitchFamily="34" charset="0"/>
+                <a:ea typeface="Microsoft JhengHei" pitchFamily="34" charset="-122"/>
+                <a:cs typeface="Microsoft JhengHei" pitchFamily="34" charset="-120"/>
+              </a:rPr>
+              <a:t>證據：.kiro/settings/mcp.json（開發期設定，唯讀白名單）、backend/handlers/order.py:56（唯一送單點）。</a:t>
+            </a:r>
+            <a:endParaRPr lang="en-US" sz="1150" dirty="0"/>
+          </a:p>
+        </p:txBody>
+      </p:sp>
+      <p:sp>
+        <p:nvSpPr>
+          <p:cNvPr id="7" name="Text 4"/>
+          <p:cNvSpPr/>
+          <p:nvPr/>
+        </p:nvSpPr>
+        <p:spPr>
+          <a:xfrm>
+            <a:off x="640080" y="6172200"/>
+            <a:ext cx="10908792" cy="502920"/>
+          </a:xfrm>
+          <a:prstGeom prst="rect">
+            <a:avLst/>
+          </a:prstGeom>
+          <a:noFill/>
+          <a:ln/>
+        </p:spPr>
+        <p:txBody>
+          <a:bodyPr wrap="square" rtlCol="0" anchor="t"/>
+          <a:lstStyle/>
+          <a:p>
+            <a:pPr indent="0" marL="0">
+              <a:lnSpc>
+                <a:spcPts val="1400"/>
+              </a:lnSpc>
+              <a:buNone/>
+            </a:pPr>
+            <a:r>
+              <a:rPr lang="en-US" sz="950" dirty="0">
+                <a:solidFill>
+                  <a:srgbClr val="8FA0C0"/>
+                </a:solidFill>
+                <a:latin typeface="Microsoft JhengHei" pitchFamily="34" charset="0"/>
+                <a:ea typeface="Microsoft JhengHei" pitchFamily="34" charset="-122"/>
+                <a:cs typeface="Microsoft JhengHei" pitchFamily="34" charset="-120"/>
+              </a:rPr>
+              <a:t>為什麼要特別澄清：把開發工具畫進 runtime，等於把一個不存在的攻擊面畫給評審看——而我們整套安全敘事的地基就是「送單路徑只有一條」。</a:t>
+            </a:r>
+            <a:endParaRPr lang="en-US" sz="950" dirty="0"/>
+          </a:p>
+        </p:txBody>
+      </p:sp>
+      <p:sp>
+        <p:nvSpPr>
+          <p:cNvPr id="8" name="Text 5"/>
+          <p:cNvSpPr/>
+          <p:nvPr/>
+        </p:nvSpPr>
+        <p:spPr>
+          <a:xfrm>
+            <a:off x="11457432" y="6446520"/>
+            <a:ext cx="365760" cy="228600"/>
+          </a:xfrm>
+          <a:prstGeom prst="rect">
+            <a:avLst/>
+          </a:prstGeom>
+          <a:noFill/>
+          <a:ln/>
+        </p:spPr>
+        <p:txBody>
+          <a:bodyPr wrap="square" rtlCol="0" anchor="ctr"/>
+          <a:lstStyle/>
+          <a:p>
+            <a:pPr algn="r" indent="0" marL="0">
+              <a:buNone/>
+            </a:pPr>
+            <a:r>
+              <a:rPr lang="en-US" sz="900" dirty="0">
+                <a:solidFill>
+                  <a:srgbClr val="6B7280"/>
+                </a:solidFill>
+                <a:latin typeface="Microsoft JhengHei" pitchFamily="34" charset="0"/>
+                <a:ea typeface="Microsoft JhengHei" pitchFamily="34" charset="-122"/>
+                <a:cs typeface="Microsoft JhengHei" pitchFamily="34" charset="-120"/>
+              </a:rPr>
+              <a:t>10</a:t>
+            </a:r>
+            <a:endParaRPr lang="en-US" sz="900" dirty="0"/>
+          </a:p>
+        </p:txBody>
+      </p:sp>
+    </p:spTree>
+  </p:cSld>
+  <p:clrMapOvr>
+    <a:masterClrMapping/>
+  </p:clrMapOvr>
+</p:sld>
+</file>
+
+<file path=ppt/slides/slide11.xml><?xml version="1.0" encoding="utf-8"?>
+<p:sld xmlns:a="http://schemas.openxmlformats.org/drawingml/2006/main" xmlns:r="http://schemas.openxmlformats.org/officeDocument/2006/relationships" xmlns:p="http://schemas.openxmlformats.org/presentationml/2006/main">
+  <p:cSld name="Slide 11">
+    <p:bg>
+      <p:bgPr>
+        <a:solidFill>
+          <a:srgbClr val="16224D"/>
+        </a:solidFill>
+      </p:bgPr>
+    </p:bg>
+    <p:spTree>
+      <p:nvGrpSpPr>
+        <p:cNvPr id="1" name=""/>
+        <p:cNvGrpSpPr/>
+        <p:nvPr/>
+      </p:nvGrpSpPr>
+      <p:grpSpPr>
+        <a:xfrm>
+          <a:off x="0" y="0"/>
+          <a:ext cx="0" cy="0"/>
+          <a:chOff x="0" y="0"/>
+          <a:chExt cx="0" cy="0"/>
+        </a:xfrm>
+      </p:grpSpPr>
+      <p:sp>
+        <p:nvSpPr>
+          <p:cNvPr id="2" name="Text 0"/>
+          <p:cNvSpPr/>
+          <p:nvPr/>
+        </p:nvSpPr>
+        <p:spPr>
+          <a:xfrm>
+            <a:off x="640080" y="411480"/>
+            <a:ext cx="10908792" cy="274320"/>
+          </a:xfrm>
+          <a:prstGeom prst="rect">
+            <a:avLst/>
+          </a:prstGeom>
+          <a:noFill/>
+          <a:ln/>
+        </p:spPr>
+        <p:txBody>
+          <a:bodyPr wrap="square" rtlCol="0" anchor="ctr"/>
+          <a:lstStyle/>
+          <a:p>
+            <a:pPr indent="0" marL="0">
+              <a:buNone/>
+            </a:pPr>
+            <a:r>
+              <a:rPr lang="en-US" sz="1200" b="1" spc="150" kern="0" dirty="0">
+                <a:solidFill>
+                  <a:srgbClr val="E8A13A"/>
+                </a:solidFill>
+                <a:latin typeface="Microsoft JhengHei" pitchFamily="34" charset="0"/>
+                <a:ea typeface="Microsoft JhengHei" pitchFamily="34" charset="-122"/>
+                <a:cs typeface="Microsoft JhengHei" pitchFamily="34" charset="-120"/>
+              </a:rPr>
+              <a:t>AI 設計</a:t>
+            </a:r>
+            <a:endParaRPr lang="en-US" sz="1200" dirty="0"/>
+          </a:p>
+        </p:txBody>
+      </p:sp>
+      <p:sp>
+        <p:nvSpPr>
+          <p:cNvPr id="3" name="Text 1"/>
+          <p:cNvSpPr/>
+          <p:nvPr/>
+        </p:nvSpPr>
+        <p:spPr>
+          <a:xfrm>
+            <a:off x="640080" y="795528"/>
+            <a:ext cx="10908792" cy="777240"/>
+          </a:xfrm>
+          <a:prstGeom prst="rect">
+            <a:avLst/>
+          </a:prstGeom>
+          <a:noFill/>
+          <a:ln/>
+        </p:spPr>
+        <p:txBody>
+          <a:bodyPr wrap="square" rtlCol="0" anchor="t"/>
+          <a:lstStyle/>
+          <a:p>
+            <a:pPr indent="0" marL="0">
+              <a:buNone/>
+            </a:pPr>
+            <a:r>
+              <a:rPr lang="en-US" sz="3000" b="1" dirty="0">
+                <a:solidFill>
+                  <a:srgbClr val="FFFFFF"/>
+                </a:solidFill>
+                <a:latin typeface="Microsoft JhengHei" pitchFamily="34" charset="0"/>
+                <a:ea typeface="Microsoft JhengHei" pitchFamily="34" charset="-122"/>
+                <a:cs typeface="Microsoft JhengHei" pitchFamily="34" charset="-120"/>
+              </a:rPr>
+              <a:t>模型分工：貴的只用在該用的地方</a:t>
+            </a:r>
+            <a:endParaRPr lang="en-US" sz="3000" dirty="0"/>
+          </a:p>
+        </p:txBody>
+      </p:sp>
+      <p:graphicFrame>
+        <p:nvGraphicFramePr>
+          <p:cNvPr id="12" name="Table 0"/>
           <p:cNvGraphicFramePr>
             <a:graphicFrameLocks noGrp="1"/>
           </p:cNvGraphicFramePr>
@@ -3567,275 +5043,6 @@
                 <a:ea typeface="Microsoft JhengHei" pitchFamily="34" charset="-122"/>
                 <a:cs typeface="Microsoft JhengHei" pitchFamily="34" charset="-120"/>
               </a:rPr>
-              <a:t>10</a:t>
-            </a:r>
-            <a:endParaRPr lang="en-US" sz="900" dirty="0"/>
-          </a:p>
-        </p:txBody>
-      </p:sp>
-    </p:spTree>
-  </p:cSld>
-  <p:clrMapOvr>
-    <a:masterClrMapping/>
-  </p:clrMapOvr>
-</p:sld>
-</file>
-
-<file path=ppt/slides/slide11.xml><?xml version="1.0" encoding="utf-8"?>
-<p:sld xmlns:a="http://schemas.openxmlformats.org/drawingml/2006/main" xmlns:r="http://schemas.openxmlformats.org/officeDocument/2006/relationships" xmlns:p="http://schemas.openxmlformats.org/presentationml/2006/main">
-  <p:cSld name="Slide 11">
-    <p:bg>
-      <p:bgPr>
-        <a:solidFill>
-          <a:srgbClr val="16224D"/>
-        </a:solidFill>
-      </p:bgPr>
-    </p:bg>
-    <p:spTree>
-      <p:nvGrpSpPr>
-        <p:cNvPr id="1" name=""/>
-        <p:cNvGrpSpPr/>
-        <p:nvPr/>
-      </p:nvGrpSpPr>
-      <p:grpSpPr>
-        <a:xfrm>
-          <a:off x="0" y="0"/>
-          <a:ext cx="0" cy="0"/>
-          <a:chOff x="0" y="0"/>
-          <a:chExt cx="0" cy="0"/>
-        </a:xfrm>
-      </p:grpSpPr>
-      <p:sp>
-        <p:nvSpPr>
-          <p:cNvPr id="2" name="Text 0"/>
-          <p:cNvSpPr/>
-          <p:nvPr/>
-        </p:nvSpPr>
-        <p:spPr>
-          <a:xfrm>
-            <a:off x="640080" y="411480"/>
-            <a:ext cx="10908792" cy="274320"/>
-          </a:xfrm>
-          <a:prstGeom prst="rect">
-            <a:avLst/>
-          </a:prstGeom>
-          <a:noFill/>
-          <a:ln/>
-        </p:spPr>
-        <p:txBody>
-          <a:bodyPr wrap="square" rtlCol="0" anchor="ctr"/>
-          <a:lstStyle/>
-          <a:p>
-            <a:pPr indent="0" marL="0">
-              <a:buNone/>
-            </a:pPr>
-            <a:r>
-              <a:rPr lang="en-US" sz="1200" b="1" spc="150" kern="0" dirty="0">
-                <a:solidFill>
-                  <a:srgbClr val="E8A13A"/>
-                </a:solidFill>
-                <a:latin typeface="Microsoft JhengHei" pitchFamily="34" charset="0"/>
-                <a:ea typeface="Microsoft JhengHei" pitchFamily="34" charset="-122"/>
-                <a:cs typeface="Microsoft JhengHei" pitchFamily="34" charset="-120"/>
-              </a:rPr>
-              <a:t>AI 設計</a:t>
-            </a:r>
-            <a:endParaRPr lang="en-US" sz="1200" dirty="0"/>
-          </a:p>
-        </p:txBody>
-      </p:sp>
-      <p:sp>
-        <p:nvSpPr>
-          <p:cNvPr id="3" name="Text 1"/>
-          <p:cNvSpPr/>
-          <p:nvPr/>
-        </p:nvSpPr>
-        <p:spPr>
-          <a:xfrm>
-            <a:off x="640080" y="795528"/>
-            <a:ext cx="10908792" cy="777240"/>
-          </a:xfrm>
-          <a:prstGeom prst="rect">
-            <a:avLst/>
-          </a:prstGeom>
-          <a:noFill/>
-          <a:ln/>
-        </p:spPr>
-        <p:txBody>
-          <a:bodyPr wrap="square" rtlCol="0" anchor="t"/>
-          <a:lstStyle/>
-          <a:p>
-            <a:pPr indent="0" marL="0">
-              <a:buNone/>
-            </a:pPr>
-            <a:r>
-              <a:rPr lang="en-US" sz="3000" b="1" dirty="0">
-                <a:solidFill>
-                  <a:srgbClr val="FFFFFF"/>
-                </a:solidFill>
-                <a:latin typeface="Microsoft JhengHei" pitchFamily="34" charset="0"/>
-                <a:ea typeface="Microsoft JhengHei" pitchFamily="34" charset="-122"/>
-                <a:cs typeface="Microsoft JhengHei" pitchFamily="34" charset="-120"/>
-              </a:rPr>
-              <a:t>為什麼金融數字不能讓 LLM 算</a:t>
-            </a:r>
-            <a:endParaRPr lang="en-US" sz="3000" dirty="0"/>
-          </a:p>
-        </p:txBody>
-      </p:sp>
-      <p:sp>
-        <p:nvSpPr>
-          <p:cNvPr id="4" name="Text 2"/>
-          <p:cNvSpPr/>
-          <p:nvPr/>
-        </p:nvSpPr>
-        <p:spPr>
-          <a:xfrm>
-            <a:off x="640080" y="1984248"/>
-            <a:ext cx="10908792" cy="3108960"/>
-          </a:xfrm>
-          <a:prstGeom prst="rect">
-            <a:avLst/>
-          </a:prstGeom>
-          <a:noFill/>
-          <a:ln/>
-        </p:spPr>
-        <p:txBody>
-          <a:bodyPr wrap="square" rtlCol="0" anchor="t"/>
-          <a:lstStyle/>
-          <a:p>
-            <a:pPr indent="0" marL="0">
-              <a:lnSpc>
-                <a:spcPts val="3400"/>
-              </a:lnSpc>
-              <a:buNone/>
-            </a:pPr>
-            <a:r>
-              <a:rPr lang="en-US" sz="1900" dirty="0">
-                <a:solidFill>
-                  <a:srgbClr val="EAF0FB"/>
-                </a:solidFill>
-                <a:latin typeface="Microsoft JhengHei" pitchFamily="34" charset="0"/>
-                <a:ea typeface="Microsoft JhengHei" pitchFamily="34" charset="-122"/>
-                <a:cs typeface="Microsoft JhengHei" pitchFamily="34" charset="-120"/>
-              </a:rPr>
-              <a:t>手續費、賣後集中度、機會成本——全部由確定性程式計算。</a:t>
-            </a:r>
-            <a:endParaRPr lang="en-US" sz="1900" dirty="0"/>
-          </a:p>
-          <a:p>
-            <a:pPr indent="0" marL="0">
-              <a:lnSpc>
-                <a:spcPts val="3400"/>
-              </a:lnSpc>
-              <a:buNone/>
-            </a:pPr>
-            <a:endParaRPr lang="en-US" sz="1900" dirty="0"/>
-          </a:p>
-          <a:p>
-            <a:pPr indent="0" marL="0">
-              <a:lnSpc>
-                <a:spcPts val="3400"/>
-              </a:lnSpc>
-              <a:buNone/>
-            </a:pPr>
-            <a:r>
-              <a:rPr lang="en-US" sz="1900" dirty="0">
-                <a:solidFill>
-                  <a:srgbClr val="EAF0FB"/>
-                </a:solidFill>
-                <a:latin typeface="Microsoft JhengHei" pitchFamily="34" charset="0"/>
-                <a:ea typeface="Microsoft JhengHei" pitchFamily="34" charset="-122"/>
-                <a:cs typeface="Microsoft JhengHei" pitchFamily="34" charset="-120"/>
-              </a:rPr>
-              <a:t>LLM 算錯一次數字，使用者可能就照著它下了一筆真錢的單。</a:t>
-            </a:r>
-            <a:endParaRPr lang="en-US" sz="1900" dirty="0"/>
-          </a:p>
-          <a:p>
-            <a:pPr indent="0" marL="0">
-              <a:lnSpc>
-                <a:spcPts val="3400"/>
-              </a:lnSpc>
-              <a:buNone/>
-            </a:pPr>
-            <a:r>
-              <a:rPr lang="en-US" sz="1900" dirty="0">
-                <a:solidFill>
-                  <a:srgbClr val="EAF0FB"/>
-                </a:solidFill>
-                <a:latin typeface="Microsoft JhengHei" pitchFamily="34" charset="0"/>
-                <a:ea typeface="Microsoft JhengHei" pitchFamily="34" charset="-122"/>
-                <a:cs typeface="Microsoft JhengHei" pitchFamily="34" charset="-120"/>
-              </a:rPr>
-              <a:t>而 LLM 算術出錯是已知的、機率性的、無法用提示詞根治的。</a:t>
-            </a:r>
-            <a:endParaRPr lang="en-US" sz="1900" dirty="0"/>
-          </a:p>
-          <a:p>
-            <a:pPr indent="0" marL="0">
-              <a:lnSpc>
-                <a:spcPts val="3400"/>
-              </a:lnSpc>
-              <a:buNone/>
-            </a:pPr>
-            <a:endParaRPr lang="en-US" sz="1900" dirty="0"/>
-          </a:p>
-          <a:p>
-            <a:pPr indent="0" marL="0">
-              <a:lnSpc>
-                <a:spcPts val="3400"/>
-              </a:lnSpc>
-              <a:buNone/>
-            </a:pPr>
-            <a:r>
-              <a:rPr lang="en-US" sz="1900" dirty="0">
-                <a:solidFill>
-                  <a:srgbClr val="EAF0FB"/>
-                </a:solidFill>
-                <a:latin typeface="Microsoft JhengHei" pitchFamily="34" charset="0"/>
-                <a:ea typeface="Microsoft JhengHei" pitchFamily="34" charset="-122"/>
-                <a:cs typeface="Microsoft JhengHei" pitchFamily="34" charset="-120"/>
-              </a:rPr>
-              <a:t>所以我們的分工是：程式負責對，模型負責讓人聽得懂。</a:t>
-            </a:r>
-            <a:endParaRPr lang="en-US" sz="1900" dirty="0"/>
-          </a:p>
-        </p:txBody>
-      </p:sp>
-      <p:sp>
-        <p:nvSpPr>
-          <p:cNvPr id="5" name="Text 3"/>
-          <p:cNvSpPr/>
-          <p:nvPr/>
-        </p:nvSpPr>
-        <p:spPr>
-          <a:xfrm>
-            <a:off x="11457432" y="6446520"/>
-            <a:ext cx="365760" cy="228600"/>
-          </a:xfrm>
-          <a:prstGeom prst="rect">
-            <a:avLst/>
-          </a:prstGeom>
-          <a:noFill/>
-          <a:ln/>
-        </p:spPr>
-        <p:txBody>
-          <a:bodyPr wrap="square" rtlCol="0" anchor="ctr"/>
-          <a:lstStyle/>
-          <a:p>
-            <a:pPr algn="r" indent="0" marL="0">
-              <a:buNone/>
-            </a:pPr>
-            <a:r>
-              <a:rPr lang="en-US" sz="900" dirty="0">
-                <a:solidFill>
-                  <a:srgbClr val="6B7280"/>
-                </a:solidFill>
-                <a:latin typeface="Microsoft JhengHei" pitchFamily="34" charset="0"/>
-                <a:ea typeface="Microsoft JhengHei" pitchFamily="34" charset="-122"/>
-                <a:cs typeface="Microsoft JhengHei" pitchFamily="34" charset="-120"/>
-              </a:rPr>
               <a:t>11</a:t>
             </a:r>
             <a:endParaRPr lang="en-US" sz="900" dirty="0"/>
@@ -3907,7 +5114,7 @@
                 <a:ea typeface="Microsoft JhengHei" pitchFamily="34" charset="-122"/>
                 <a:cs typeface="Microsoft JhengHei" pitchFamily="34" charset="-120"/>
               </a:rPr>
-              <a:t>護欄</a:t>
+              <a:t>AI 設計</a:t>
             </a:r>
             <a:endParaRPr lang="en-US" sz="1200" dirty="0"/>
           </a:p>
@@ -3946,7 +5153,7 @@
                 <a:ea typeface="Microsoft JhengHei" pitchFamily="34" charset="-122"/>
                 <a:cs typeface="Microsoft JhengHei" pitchFamily="34" charset="-120"/>
               </a:rPr>
-              <a:t>四層攔截，任一層可獨立擋住</a:t>
+              <a:t>為什麼金融數字不能讓 LLM 算</a:t>
             </a:r>
             <a:endParaRPr lang="en-US" sz="3000" dirty="0"/>
           </a:p>
@@ -3960,113 +5167,8 @@
         </p:nvSpPr>
         <p:spPr>
           <a:xfrm>
-            <a:off x="640080" y="1709928"/>
-            <a:ext cx="10908792" cy="365760"/>
-          </a:xfrm>
-          <a:prstGeom prst="rect">
-            <a:avLst/>
-          </a:prstGeom>
-          <a:noFill/>
-          <a:ln/>
-        </p:spPr>
-        <p:txBody>
-          <a:bodyPr wrap="square" rtlCol="0" anchor="ctr"/>
-          <a:lstStyle/>
-          <a:p>
-            <a:pPr indent="0" marL="0">
-              <a:buNone/>
-            </a:pPr>
-            <a:r>
-              <a:rPr lang="en-US" sz="1300" dirty="0">
-                <a:solidFill>
-                  <a:srgbClr val="B9C6E0"/>
-                </a:solidFill>
-                <a:latin typeface="Microsoft JhengHei" pitchFamily="34" charset="0"/>
-                <a:ea typeface="Microsoft JhengHei" pitchFamily="34" charset="-122"/>
-                <a:cs typeface="Microsoft JhengHei" pitchFamily="34" charset="-120"/>
-              </a:rPr>
-              <a:t>「不報明牌」不是一句承諾，是四個獨立的攔截點。</a:t>
-            </a:r>
-            <a:endParaRPr lang="en-US" sz="1300" dirty="0"/>
-          </a:p>
-        </p:txBody>
-      </p:sp>
-      <p:sp>
-        <p:nvSpPr>
-          <p:cNvPr id="5" name="Shape 3"/>
-          <p:cNvSpPr/>
-          <p:nvPr/>
-        </p:nvSpPr>
-        <p:spPr>
-          <a:xfrm>
-            <a:off x="640080" y="2212848"/>
-            <a:ext cx="3453384" cy="2743200"/>
-          </a:xfrm>
-          <a:prstGeom prst="roundRect">
-            <a:avLst>
-              <a:gd name="adj" fmla="val 2667"/>
-            </a:avLst>
-          </a:prstGeom>
-          <a:solidFill>
-            <a:srgbClr val="1D2B5C"/>
-          </a:solidFill>
-          <a:ln w="12700">
-            <a:solidFill>
-              <a:srgbClr val="2B3B72"/>
-            </a:solidFill>
-            <a:prstDash val="solid"/>
-          </a:ln>
-        </p:spPr>
-      </p:sp>
-      <p:sp>
-        <p:nvSpPr>
-          <p:cNvPr id="6" name="Text 4"/>
-          <p:cNvSpPr/>
-          <p:nvPr/>
-        </p:nvSpPr>
-        <p:spPr>
-          <a:xfrm>
-            <a:off x="841248" y="2377440"/>
-            <a:ext cx="3051048" cy="502920"/>
-          </a:xfrm>
-          <a:prstGeom prst="rect">
-            <a:avLst/>
-          </a:prstGeom>
-          <a:noFill/>
-          <a:ln/>
-        </p:spPr>
-        <p:txBody>
-          <a:bodyPr wrap="square" rtlCol="0" anchor="ctr"/>
-          <a:lstStyle/>
-          <a:p>
-            <a:pPr indent="0" marL="0">
-              <a:buNone/>
-            </a:pPr>
-            <a:r>
-              <a:rPr lang="en-US" sz="1350" b="1" dirty="0">
-                <a:solidFill>
-                  <a:srgbClr val="E8A13A"/>
-                </a:solidFill>
-                <a:latin typeface="Microsoft JhengHei" pitchFamily="34" charset="0"/>
-                <a:ea typeface="Microsoft JhengHei" pitchFamily="34" charset="-122"/>
-                <a:cs typeface="Microsoft JhengHei" pitchFamily="34" charset="-120"/>
-              </a:rPr>
-              <a:t>① 提示詞 ＋ ② 後端正則</a:t>
-            </a:r>
-            <a:endParaRPr lang="en-US" sz="1350" dirty="0"/>
-          </a:p>
-        </p:txBody>
-      </p:sp>
-      <p:sp>
-        <p:nvSpPr>
-          <p:cNvPr id="7" name="Text 5"/>
-          <p:cNvSpPr/>
-          <p:nvPr/>
-        </p:nvSpPr>
-        <p:spPr>
-          <a:xfrm>
-            <a:off x="841248" y="2944368"/>
-            <a:ext cx="3051048" cy="1600200"/>
+            <a:off x="640080" y="1984248"/>
+            <a:ext cx="10908792" cy="3108960"/>
           </a:xfrm>
           <a:prstGeom prst="rect">
             <a:avLst/>
@@ -4080,403 +5182,106 @@
           <a:p>
             <a:pPr indent="0" marL="0">
               <a:lnSpc>
-                <a:spcPts val="1600"/>
+                <a:spcPts val="3400"/>
               </a:lnSpc>
               <a:buNone/>
             </a:pPr>
             <a:r>
-              <a:rPr lang="en-US" sz="1050" dirty="0">
-                <a:solidFill>
-                  <a:srgbClr val="D5DEF0"/>
-                </a:solidFill>
-                <a:latin typeface="Microsoft JhengHei" pitchFamily="34" charset="0"/>
-                <a:ea typeface="Microsoft JhengHei" pitchFamily="34" charset="-122"/>
-                <a:cs typeface="Microsoft JhengHei" pitchFamily="34" charset="-120"/>
-              </a:rPr>
-              <a:t>系統提示明訂永不建議買賣特定標的；輸出再過一次正則，命中就整段換成安全回覆——不是遮字，因為遮一半會被腦補成建議。</a:t>
-            </a:r>
-            <a:endParaRPr lang="en-US" sz="1050" dirty="0"/>
-          </a:p>
-        </p:txBody>
-      </p:sp>
-      <p:sp>
-        <p:nvSpPr>
-          <p:cNvPr id="8" name="Text 6"/>
-          <p:cNvSpPr/>
-          <p:nvPr/>
-        </p:nvSpPr>
-        <p:spPr>
-          <a:xfrm>
-            <a:off x="841248" y="4590288"/>
-            <a:ext cx="3051048" cy="274320"/>
-          </a:xfrm>
-          <a:prstGeom prst="rect">
-            <a:avLst/>
-          </a:prstGeom>
-          <a:noFill/>
-          <a:ln/>
-        </p:spPr>
-        <p:txBody>
-          <a:bodyPr wrap="square" rtlCol="0" anchor="ctr"/>
-          <a:lstStyle/>
-          <a:p>
-            <a:pPr indent="0" marL="0">
-              <a:buNone/>
-            </a:pPr>
-            <a:r>
-              <a:rPr lang="en-US" sz="800" dirty="0">
-                <a:solidFill>
-                  <a:srgbClr val="7C8CAC"/>
-                </a:solidFill>
-                <a:latin typeface="Consolas" pitchFamily="34" charset="0"/>
-                <a:ea typeface="Consolas" pitchFamily="34" charset="-122"/>
-                <a:cs typeface="Consolas" pitchFamily="34" charset="-120"/>
-              </a:rPr>
-              <a:t>loop.py:20｜guardrails.py:8-13, 79-100</a:t>
-            </a:r>
-            <a:endParaRPr lang="en-US" sz="800" dirty="0"/>
-          </a:p>
-        </p:txBody>
-      </p:sp>
-      <p:sp>
-        <p:nvSpPr>
-          <p:cNvPr id="9" name="Shape 7"/>
-          <p:cNvSpPr/>
-          <p:nvPr/>
-        </p:nvSpPr>
-        <p:spPr>
-          <a:xfrm>
-            <a:off x="4367784" y="2212848"/>
-            <a:ext cx="3453384" cy="2743200"/>
-          </a:xfrm>
-          <a:prstGeom prst="roundRect">
-            <a:avLst>
-              <a:gd name="adj" fmla="val 2667"/>
-            </a:avLst>
-          </a:prstGeom>
-          <a:solidFill>
-            <a:srgbClr val="1D2B5C"/>
-          </a:solidFill>
-          <a:ln w="12700">
-            <a:solidFill>
-              <a:srgbClr val="2B3B72"/>
-            </a:solidFill>
-            <a:prstDash val="solid"/>
-          </a:ln>
-        </p:spPr>
-      </p:sp>
-      <p:sp>
-        <p:nvSpPr>
-          <p:cNvPr id="10" name="Text 8"/>
-          <p:cNvSpPr/>
-          <p:nvPr/>
-        </p:nvSpPr>
-        <p:spPr>
-          <a:xfrm>
-            <a:off x="4568952" y="2377440"/>
-            <a:ext cx="3051048" cy="502920"/>
-          </a:xfrm>
-          <a:prstGeom prst="rect">
-            <a:avLst/>
-          </a:prstGeom>
-          <a:noFill/>
-          <a:ln/>
-        </p:spPr>
-        <p:txBody>
-          <a:bodyPr wrap="square" rtlCol="0" anchor="ctr"/>
-          <a:lstStyle/>
-          <a:p>
-            <a:pPr indent="0" marL="0">
-              <a:buNone/>
-            </a:pPr>
-            <a:r>
-              <a:rPr lang="en-US" sz="1350" b="1" dirty="0">
-                <a:solidFill>
-                  <a:srgbClr val="E8A13A"/>
-                </a:solidFill>
-                <a:latin typeface="Microsoft JhengHei" pitchFamily="34" charset="0"/>
-                <a:ea typeface="Microsoft JhengHei" pitchFamily="34" charset="-122"/>
-                <a:cs typeface="Microsoft JhengHei" pitchFamily="34" charset="-120"/>
-              </a:rPr>
-              <a:t>③ 前端 ＋ ④ Bedrock Guardrails</a:t>
-            </a:r>
-            <a:endParaRPr lang="en-US" sz="1350" dirty="0"/>
-          </a:p>
-        </p:txBody>
-      </p:sp>
-      <p:sp>
-        <p:nvSpPr>
-          <p:cNvPr id="11" name="Text 9"/>
-          <p:cNvSpPr/>
-          <p:nvPr/>
-        </p:nvSpPr>
-        <p:spPr>
-          <a:xfrm>
-            <a:off x="4568952" y="2944368"/>
-            <a:ext cx="3051048" cy="1600200"/>
-          </a:xfrm>
-          <a:prstGeom prst="rect">
-            <a:avLst/>
-          </a:prstGeom>
-          <a:noFill/>
-          <a:ln/>
-        </p:spPr>
-        <p:txBody>
-          <a:bodyPr wrap="square" rtlCol="0" anchor="t"/>
-          <a:lstStyle/>
+              <a:rPr lang="en-US" sz="1900" dirty="0">
+                <a:solidFill>
+                  <a:srgbClr val="EAF0FB"/>
+                </a:solidFill>
+                <a:latin typeface="Microsoft JhengHei" pitchFamily="34" charset="0"/>
+                <a:ea typeface="Microsoft JhengHei" pitchFamily="34" charset="-122"/>
+                <a:cs typeface="Microsoft JhengHei" pitchFamily="34" charset="-120"/>
+              </a:rPr>
+              <a:t>手續費、賣後集中度、機會成本——全部由確定性程式計算。</a:t>
+            </a:r>
+            <a:endParaRPr lang="en-US" sz="1900" dirty="0"/>
+          </a:p>
           <a:p>
             <a:pPr indent="0" marL="0">
               <a:lnSpc>
-                <a:spcPts val="1600"/>
+                <a:spcPts val="3400"/>
               </a:lnSpc>
               <a:buNone/>
             </a:pPr>
-            <a:r>
-              <a:rPr lang="en-US" sz="1050" dirty="0">
-                <a:solidFill>
-                  <a:srgbClr val="D5DEF0"/>
-                </a:solidFill>
-                <a:latin typeface="Microsoft JhengHei" pitchFamily="34" charset="0"/>
-                <a:ea typeface="Microsoft JhengHei" pitchFamily="34" charset="-122"/>
-                <a:cs typeface="Microsoft JhengHei" pitchFamily="34" charset="-120"/>
-              </a:rPr>
-              <a:t>後端萬一漏了，畫面這關再擋一次。Bedrock Guardrails 的接點已就緒，設環境變數即疊加生效。</a:t>
-            </a:r>
-            <a:endParaRPr lang="en-US" sz="1050" dirty="0"/>
-          </a:p>
-        </p:txBody>
-      </p:sp>
-      <p:sp>
-        <p:nvSpPr>
-          <p:cNvPr id="12" name="Text 10"/>
-          <p:cNvSpPr/>
-          <p:nvPr/>
-        </p:nvSpPr>
-        <p:spPr>
-          <a:xfrm>
-            <a:off x="4568952" y="4590288"/>
-            <a:ext cx="3051048" cy="274320"/>
-          </a:xfrm>
-          <a:prstGeom prst="rect">
-            <a:avLst/>
-          </a:prstGeom>
-          <a:noFill/>
-          <a:ln/>
-        </p:spPr>
-        <p:txBody>
-          <a:bodyPr wrap="square" rtlCol="0" anchor="ctr"/>
-          <a:lstStyle/>
-          <a:p>
-            <a:pPr indent="0" marL="0">
-              <a:buNone/>
-            </a:pPr>
-            <a:r>
-              <a:rPr lang="en-US" sz="800" dirty="0">
-                <a:solidFill>
-                  <a:srgbClr val="7C8CAC"/>
-                </a:solidFill>
-                <a:latin typeface="Consolas" pitchFamily="34" charset="0"/>
-                <a:ea typeface="Consolas" pitchFamily="34" charset="-122"/>
-                <a:cs typeface="Consolas" pitchFamily="34" charset="-120"/>
-              </a:rPr>
-              <a:t>chat-core.js:26-31｜loop.py:109-115</a:t>
-            </a:r>
-            <a:endParaRPr lang="en-US" sz="800" dirty="0"/>
-          </a:p>
-        </p:txBody>
-      </p:sp>
-      <p:sp>
-        <p:nvSpPr>
-          <p:cNvPr id="13" name="Shape 11"/>
-          <p:cNvSpPr/>
-          <p:nvPr/>
-        </p:nvSpPr>
-        <p:spPr>
-          <a:xfrm>
-            <a:off x="8095488" y="2212848"/>
-            <a:ext cx="3453384" cy="2743200"/>
-          </a:xfrm>
-          <a:prstGeom prst="roundRect">
-            <a:avLst>
-              <a:gd name="adj" fmla="val 2667"/>
-            </a:avLst>
-          </a:prstGeom>
-          <a:solidFill>
-            <a:srgbClr val="1D2B5C"/>
-          </a:solidFill>
-          <a:ln w="12700">
-            <a:solidFill>
-              <a:srgbClr val="2B3B72"/>
-            </a:solidFill>
-            <a:prstDash val="solid"/>
-          </a:ln>
-        </p:spPr>
-      </p:sp>
-      <p:sp>
-        <p:nvSpPr>
-          <p:cNvPr id="14" name="Text 12"/>
-          <p:cNvSpPr/>
-          <p:nvPr/>
-        </p:nvSpPr>
-        <p:spPr>
-          <a:xfrm>
-            <a:off x="8296656" y="2377440"/>
-            <a:ext cx="3051048" cy="502920"/>
-          </a:xfrm>
-          <a:prstGeom prst="rect">
-            <a:avLst/>
-          </a:prstGeom>
-          <a:noFill/>
-          <a:ln/>
-        </p:spPr>
-        <p:txBody>
-          <a:bodyPr wrap="square" rtlCol="0" anchor="ctr"/>
-          <a:lstStyle/>
-          <a:p>
-            <a:pPr indent="0" marL="0">
-              <a:buNone/>
-            </a:pPr>
-            <a:r>
-              <a:rPr lang="en-US" sz="1350" b="1" dirty="0">
-                <a:solidFill>
-                  <a:srgbClr val="E8A13A"/>
-                </a:solidFill>
-                <a:latin typeface="Microsoft JhengHei" pitchFamily="34" charset="0"/>
-                <a:ea typeface="Microsoft JhengHei" pitchFamily="34" charset="-122"/>
-                <a:cs typeface="Microsoft JhengHei" pitchFamily="34" charset="-120"/>
-              </a:rPr>
-              <a:t>還做了誤判防護</a:t>
-            </a:r>
-            <a:endParaRPr lang="en-US" sz="1350" dirty="0"/>
-          </a:p>
-        </p:txBody>
-      </p:sp>
-      <p:sp>
-        <p:nvSpPr>
-          <p:cNvPr id="15" name="Text 13"/>
-          <p:cNvSpPr/>
-          <p:nvPr/>
-        </p:nvSpPr>
-        <p:spPr>
-          <a:xfrm>
-            <a:off x="8296656" y="2944368"/>
-            <a:ext cx="3051048" cy="1600200"/>
-          </a:xfrm>
-          <a:prstGeom prst="rect">
-            <a:avLst/>
-          </a:prstGeom>
-          <a:noFill/>
-          <a:ln/>
-        </p:spPr>
-        <p:txBody>
-          <a:bodyPr wrap="square" rtlCol="0" anchor="t"/>
-          <a:lstStyle/>
+            <a:endParaRPr lang="en-US" sz="1900" dirty="0"/>
+          </a:p>
           <a:p>
             <a:pPr indent="0" marL="0">
               <a:lnSpc>
-                <a:spcPts val="1600"/>
+                <a:spcPts val="3400"/>
               </a:lnSpc>
               <a:buNone/>
             </a:pPr>
             <a:r>
-              <a:rPr lang="en-US" sz="1050" dirty="0">
-                <a:solidFill>
-                  <a:srgbClr val="D5DEF0"/>
-                </a:solidFill>
-                <a:latin typeface="Microsoft JhengHei" pitchFamily="34" charset="0"/>
-                <a:ea typeface="Microsoft JhengHei" pitchFamily="34" charset="-122"/>
-                <a:cs typeface="Microsoft JhengHei" pitchFamily="34" charset="-120"/>
-              </a:rPr>
-              <a:t>反詐教育內容本來就必須出現「保證獲利」這種詞——那是在教人辨識詐騙。沒有語境排除，護欄會擋掉自家的反詐功能，而且是靜默失敗。</a:t>
-            </a:r>
-            <a:endParaRPr lang="en-US" sz="1050" dirty="0"/>
-          </a:p>
-        </p:txBody>
-      </p:sp>
-      <p:sp>
-        <p:nvSpPr>
-          <p:cNvPr id="16" name="Text 14"/>
-          <p:cNvSpPr/>
-          <p:nvPr/>
-        </p:nvSpPr>
-        <p:spPr>
-          <a:xfrm>
-            <a:off x="8296656" y="4590288"/>
-            <a:ext cx="3051048" cy="274320"/>
-          </a:xfrm>
-          <a:prstGeom prst="rect">
-            <a:avLst/>
-          </a:prstGeom>
-          <a:noFill/>
-          <a:ln/>
-        </p:spPr>
-        <p:txBody>
-          <a:bodyPr wrap="square" rtlCol="0" anchor="ctr"/>
-          <a:lstStyle/>
-          <a:p>
-            <a:pPr indent="0" marL="0">
-              <a:buNone/>
-            </a:pPr>
-            <a:r>
-              <a:rPr lang="en-US" sz="800" dirty="0">
-                <a:solidFill>
-                  <a:srgbClr val="7C8CAC"/>
-                </a:solidFill>
-                <a:latin typeface="Consolas" pitchFamily="34" charset="0"/>
-                <a:ea typeface="Consolas" pitchFamily="34" charset="-122"/>
-                <a:cs typeface="Consolas" pitchFamily="34" charset="-120"/>
-              </a:rPr>
-              <a:t>guardrails.py:24-29</a:t>
-            </a:r>
-            <a:endParaRPr lang="en-US" sz="800" dirty="0"/>
-          </a:p>
-        </p:txBody>
-      </p:sp>
-      <p:sp>
-        <p:nvSpPr>
-          <p:cNvPr id="17" name="Text 15"/>
-          <p:cNvSpPr/>
-          <p:nvPr/>
-        </p:nvSpPr>
-        <p:spPr>
-          <a:xfrm>
-            <a:off x="640080" y="6172200"/>
-            <a:ext cx="10908792" cy="502920"/>
-          </a:xfrm>
-          <a:prstGeom prst="rect">
-            <a:avLst/>
-          </a:prstGeom>
-          <a:noFill/>
-          <a:ln/>
-        </p:spPr>
-        <p:txBody>
-          <a:bodyPr wrap="square" rtlCol="0" anchor="t"/>
-          <a:lstStyle/>
+              <a:rPr lang="en-US" sz="1900" dirty="0">
+                <a:solidFill>
+                  <a:srgbClr val="EAF0FB"/>
+                </a:solidFill>
+                <a:latin typeface="Microsoft JhengHei" pitchFamily="34" charset="0"/>
+                <a:ea typeface="Microsoft JhengHei" pitchFamily="34" charset="-122"/>
+                <a:cs typeface="Microsoft JhengHei" pitchFamily="34" charset="-120"/>
+              </a:rPr>
+              <a:t>LLM 算錯一次數字，使用者可能就照著它下了一筆真錢的單。</a:t>
+            </a:r>
+            <a:endParaRPr lang="en-US" sz="1900" dirty="0"/>
+          </a:p>
           <a:p>
             <a:pPr indent="0" marL="0">
               <a:lnSpc>
-                <a:spcPts val="1400"/>
+                <a:spcPts val="3400"/>
               </a:lnSpc>
               <a:buNone/>
             </a:pPr>
             <a:r>
-              <a:rPr lang="en-US" sz="950" dirty="0">
-                <a:solidFill>
-                  <a:srgbClr val="8FA0C0"/>
-                </a:solidFill>
-                <a:latin typeface="Microsoft JhengHei" pitchFamily="34" charset="0"/>
-                <a:ea typeface="Microsoft JhengHei" pitchFamily="34" charset="-122"/>
-                <a:cs typeface="Microsoft JhengHei" pitchFamily="34" charset="-120"/>
-              </a:rPr>
-              <a:t>護欄設計不只要問「擋不擋得住壞的」，也要問「會不會擋掉好的」。</a:t>
-            </a:r>
-            <a:endParaRPr lang="en-US" sz="950" dirty="0"/>
-          </a:p>
-        </p:txBody>
-      </p:sp>
-      <p:sp>
-        <p:nvSpPr>
-          <p:cNvPr id="18" name="Text 16"/>
+              <a:rPr lang="en-US" sz="1900" dirty="0">
+                <a:solidFill>
+                  <a:srgbClr val="EAF0FB"/>
+                </a:solidFill>
+                <a:latin typeface="Microsoft JhengHei" pitchFamily="34" charset="0"/>
+                <a:ea typeface="Microsoft JhengHei" pitchFamily="34" charset="-122"/>
+                <a:cs typeface="Microsoft JhengHei" pitchFamily="34" charset="-120"/>
+              </a:rPr>
+              <a:t>而 LLM 算術出錯是已知的、機率性的、無法用提示詞根治的。</a:t>
+            </a:r>
+            <a:endParaRPr lang="en-US" sz="1900" dirty="0"/>
+          </a:p>
+          <a:p>
+            <a:pPr indent="0" marL="0">
+              <a:lnSpc>
+                <a:spcPts val="3400"/>
+              </a:lnSpc>
+              <a:buNone/>
+            </a:pPr>
+            <a:endParaRPr lang="en-US" sz="1900" dirty="0"/>
+          </a:p>
+          <a:p>
+            <a:pPr indent="0" marL="0">
+              <a:lnSpc>
+                <a:spcPts val="3400"/>
+              </a:lnSpc>
+              <a:buNone/>
+            </a:pPr>
+            <a:r>
+              <a:rPr lang="en-US" sz="1900" dirty="0">
+                <a:solidFill>
+                  <a:srgbClr val="EAF0FB"/>
+                </a:solidFill>
+                <a:latin typeface="Microsoft JhengHei" pitchFamily="34" charset="0"/>
+                <a:ea typeface="Microsoft JhengHei" pitchFamily="34" charset="-122"/>
+                <a:cs typeface="Microsoft JhengHei" pitchFamily="34" charset="-120"/>
+              </a:rPr>
+              <a:t>所以我們的分工是：程式負責對，模型負責讓人聽得懂。</a:t>
+            </a:r>
+            <a:endParaRPr lang="en-US" sz="1900" dirty="0"/>
+          </a:p>
+        </p:txBody>
+      </p:sp>
+      <p:sp>
+        <p:nvSpPr>
+          <p:cNvPr id="5" name="Text 3"/>
           <p:cNvSpPr/>
           <p:nvPr/>
         </p:nvSpPr>
@@ -4578,7 +5383,7 @@
                 <a:ea typeface="Microsoft JhengHei" pitchFamily="34" charset="-122"/>
                 <a:cs typeface="Microsoft JhengHei" pitchFamily="34" charset="-120"/>
               </a:rPr>
-              <a:t>商業模式</a:t>
+              <a:t>AI-native</a:t>
             </a:r>
             <a:endParaRPr lang="en-US" sz="1200" dirty="0"/>
           </a:p>
@@ -4617,15 +5422,1938 @@
                 <a:ea typeface="Microsoft JhengHei" pitchFamily="34" charset="-122"/>
                 <a:cs typeface="Microsoft JhengHei" pitchFamily="34" charset="-120"/>
               </a:rPr>
-              <a:t>平台怎麼賺錢——不是只幫客戶省錢</a:t>
+              <a:t>沒有生成式 AI，這個產品不存在</a:t>
             </a:r>
             <a:endParaRPr lang="en-US" sz="3000" dirty="0"/>
+          </a:p>
+        </p:txBody>
+      </p:sp>
+      <p:sp>
+        <p:nvSpPr>
+          <p:cNvPr id="4" name="Text 2"/>
+          <p:cNvSpPr/>
+          <p:nvPr/>
+        </p:nvSpPr>
+        <p:spPr>
+          <a:xfrm>
+            <a:off x="640080" y="1709928"/>
+            <a:ext cx="10908792" cy="320040"/>
+          </a:xfrm>
+          <a:prstGeom prst="rect">
+            <a:avLst/>
+          </a:prstGeom>
+          <a:noFill/>
+          <a:ln/>
+        </p:spPr>
+        <p:txBody>
+          <a:bodyPr wrap="square" rtlCol="0" anchor="ctr"/>
+          <a:lstStyle/>
+          <a:p>
+            <a:pPr indent="0" marL="0">
+              <a:buNone/>
+            </a:pPr>
+            <a:r>
+              <a:rPr lang="en-US" sz="1300" dirty="0">
+                <a:solidFill>
+                  <a:srgbClr val="B9C6E0"/>
+                </a:solidFill>
+                <a:latin typeface="Microsoft JhengHei" pitchFamily="34" charset="0"/>
+                <a:ea typeface="Microsoft JhengHei" pitchFamily="34" charset="-122"/>
+                <a:cs typeface="Microsoft JhengHei" pitchFamily="34" charset="-120"/>
+              </a:rPr>
+              <a:t>誠實地逐項問一次：哪些部分其實不需要 AI？</a:t>
+            </a:r>
+            <a:endParaRPr lang="en-US" sz="1300" dirty="0"/>
           </a:p>
         </p:txBody>
       </p:sp>
       <p:graphicFrame>
         <p:nvGraphicFramePr>
           <p:cNvPr id="14" name="Table 0"/>
+          <p:cNvGraphicFramePr>
+            <a:graphicFrameLocks noGrp="1"/>
+          </p:cNvGraphicFramePr>
+          <p:nvPr>
+            <p:extLst>
+              <p:ext uri="{D42A27DB-BD31-4B8C-83A1-F6EECF244321}">
+                <p14:modId xmlns:p14="http://schemas.microsoft.com/office/powerpoint/2010/main" val="1579011935"/>
+              </p:ext>
+            </p:extLst>
+          </p:nvPr>
+        </p:nvGraphicFramePr>
+        <p:xfrm>
+          <a:off x="640080" y="2167128"/>
+          <a:ext cx="10908792" cy="914400"/>
+        </p:xfrm>
+        <a:graphic>
+          <a:graphicData uri="http://schemas.openxmlformats.org/drawingml/2006/table">
+            <a:tbl>
+              <a:tblPr/>
+              <a:tblGrid>
+                <a:gridCol w="5454396"/>
+                <a:gridCol w="5454396"/>
+              </a:tblGrid>
+              <a:tr h="0">
+                <a:tc>
+                  <a:txBody>
+                    <a:bodyPr/>
+                    <a:lstStyle/>
+                    <a:p>
+                      <a:pPr indent="0" marL="0">
+                        <a:buNone/>
+                      </a:pPr>
+                      <a:r>
+                        <a:rPr lang="en-US" sz="1100" b="1" dirty="0">
+                          <a:solidFill>
+                            <a:srgbClr val="E8A13A"/>
+                          </a:solidFill>
+                          <a:latin typeface="Microsoft JhengHei" pitchFamily="34" charset="0"/>
+                          <a:ea typeface="Microsoft JhengHei" pitchFamily="34" charset="-122"/>
+                          <a:cs typeface="Microsoft JhengHei" pitchFamily="34" charset="-120"/>
+                        </a:rPr>
+                        <a:t>產品的一部分</a:t>
+                      </a:r>
+                      <a:endParaRPr lang="en-US" sz="1100" dirty="0">
+                        <a:latin typeface="Microsoft JhengHei" charset="0"/>
+                        <a:ea typeface="Microsoft JhengHei" charset="0"/>
+                        <a:cs typeface="Microsoft JhengHei" charset="0"/>
+                      </a:endParaRPr>
+                    </a:p>
+                  </a:txBody>
+                  <a:tcPr marL="91440" marR="91440" marT="45720" marB="45720" anchor="t">
+                    <a:lnL w="6350" cap="flat" cmpd="sng" algn="ctr">
+                      <a:solidFill>
+                        <a:srgbClr val="2B3B72"/>
+                      </a:solidFill>
+                      <a:prstDash val="solid"/>
+                      <a:round/>
+                      <a:headEnd type="none" w="med" len="med"/>
+                      <a:tailEnd type="none" w="med" len="med"/>
+                    </a:lnL>
+                    <a:lnR w="6350" cap="flat" cmpd="sng" algn="ctr">
+                      <a:solidFill>
+                        <a:srgbClr val="2B3B72"/>
+                      </a:solidFill>
+                      <a:prstDash val="solid"/>
+                      <a:round/>
+                      <a:headEnd type="none" w="med" len="med"/>
+                      <a:tailEnd type="none" w="med" len="med"/>
+                    </a:lnR>
+                    <a:lnT w="6350" cap="flat" cmpd="sng" algn="ctr">
+                      <a:solidFill>
+                        <a:srgbClr val="2B3B72"/>
+                      </a:solidFill>
+                      <a:prstDash val="solid"/>
+                      <a:round/>
+                      <a:headEnd type="none" w="med" len="med"/>
+                      <a:tailEnd type="none" w="med" len="med"/>
+                    </a:lnT>
+                    <a:lnB w="6350" cap="flat" cmpd="sng" algn="ctr">
+                      <a:solidFill>
+                        <a:srgbClr val="2B3B72"/>
+                      </a:solidFill>
+                      <a:prstDash val="solid"/>
+                      <a:round/>
+                      <a:headEnd type="none" w="med" len="med"/>
+                      <a:tailEnd type="none" w="med" len="med"/>
+                    </a:lnB>
+                    <a:solidFill>
+                      <a:srgbClr val="1D2B5C"/>
+                    </a:solidFill>
+                  </a:tcPr>
+                </a:tc>
+                <a:tc>
+                  <a:txBody>
+                    <a:bodyPr/>
+                    <a:lstStyle/>
+                    <a:p>
+                      <a:pPr indent="0" marL="0">
+                        <a:buNone/>
+                      </a:pPr>
+                      <a:r>
+                        <a:rPr lang="en-US" sz="1100" b="1" dirty="0">
+                          <a:solidFill>
+                            <a:srgbClr val="E8A13A"/>
+                          </a:solidFill>
+                          <a:latin typeface="Microsoft JhengHei" pitchFamily="34" charset="0"/>
+                          <a:ea typeface="Microsoft JhengHei" pitchFamily="34" charset="-122"/>
+                          <a:cs typeface="Microsoft JhengHei" pitchFamily="34" charset="-120"/>
+                        </a:rPr>
+                        <a:t>沒有生成式 AI 做得到嗎</a:t>
+                      </a:r>
+                      <a:endParaRPr lang="en-US" sz="1100" dirty="0">
+                        <a:latin typeface="Microsoft JhengHei" charset="0"/>
+                        <a:ea typeface="Microsoft JhengHei" charset="0"/>
+                        <a:cs typeface="Microsoft JhengHei" charset="0"/>
+                      </a:endParaRPr>
+                    </a:p>
+                  </a:txBody>
+                  <a:tcPr marL="91440" marR="91440" marT="45720" marB="45720" anchor="t">
+                    <a:lnL w="6350" cap="flat" cmpd="sng" algn="ctr">
+                      <a:solidFill>
+                        <a:srgbClr val="2B3B72"/>
+                      </a:solidFill>
+                      <a:prstDash val="solid"/>
+                      <a:round/>
+                      <a:headEnd type="none" w="med" len="med"/>
+                      <a:tailEnd type="none" w="med" len="med"/>
+                    </a:lnL>
+                    <a:lnR w="6350" cap="flat" cmpd="sng" algn="ctr">
+                      <a:solidFill>
+                        <a:srgbClr val="2B3B72"/>
+                      </a:solidFill>
+                      <a:prstDash val="solid"/>
+                      <a:round/>
+                      <a:headEnd type="none" w="med" len="med"/>
+                      <a:tailEnd type="none" w="med" len="med"/>
+                    </a:lnR>
+                    <a:lnT w="6350" cap="flat" cmpd="sng" algn="ctr">
+                      <a:solidFill>
+                        <a:srgbClr val="2B3B72"/>
+                      </a:solidFill>
+                      <a:prstDash val="solid"/>
+                      <a:round/>
+                      <a:headEnd type="none" w="med" len="med"/>
+                      <a:tailEnd type="none" w="med" len="med"/>
+                    </a:lnT>
+                    <a:lnB w="6350" cap="flat" cmpd="sng" algn="ctr">
+                      <a:solidFill>
+                        <a:srgbClr val="2B3B72"/>
+                      </a:solidFill>
+                      <a:prstDash val="solid"/>
+                      <a:round/>
+                      <a:headEnd type="none" w="med" len="med"/>
+                      <a:tailEnd type="none" w="med" len="med"/>
+                    </a:lnB>
+                    <a:solidFill>
+                      <a:srgbClr val="1D2B5C"/>
+                    </a:solidFill>
+                  </a:tcPr>
+                </a:tc>
+              </a:tr>
+              <a:tr h="0">
+                <a:tc>
+                  <a:txBody>
+                    <a:bodyPr/>
+                    <a:lstStyle/>
+                    <a:p>
+                      <a:pPr indent="0" marL="0">
+                        <a:buNone/>
+                      </a:pPr>
+                      <a:r>
+                        <a:rPr lang="en-US" sz="1100" dirty="0">
+                          <a:solidFill>
+                            <a:srgbClr val="EAF0FB"/>
+                          </a:solidFill>
+                          <a:latin typeface="Microsoft JhengHei" pitchFamily="34" charset="0"/>
+                          <a:ea typeface="Microsoft JhengHei" pitchFamily="34" charset="-122"/>
+                          <a:cs typeface="Microsoft JhengHei" pitchFamily="34" charset="-120"/>
+                        </a:rPr>
+                        <a:t>行為健檢的數字（追高 65%、機會成本 26.6M）</a:t>
+                      </a:r>
+                      <a:endParaRPr lang="en-US" sz="1100" dirty="0">
+                        <a:latin typeface="Microsoft JhengHei" charset="0"/>
+                        <a:ea typeface="Microsoft JhengHei" charset="0"/>
+                        <a:cs typeface="Microsoft JhengHei" charset="0"/>
+                      </a:endParaRPr>
+                    </a:p>
+                  </a:txBody>
+                  <a:tcPr marL="91440" marR="91440" marT="45720" marB="45720" anchor="t">
+                    <a:lnL w="6350" cap="flat" cmpd="sng" algn="ctr">
+                      <a:solidFill>
+                        <a:srgbClr val="2B3B72"/>
+                      </a:solidFill>
+                      <a:prstDash val="solid"/>
+                      <a:round/>
+                      <a:headEnd type="none" w="med" len="med"/>
+                      <a:tailEnd type="none" w="med" len="med"/>
+                    </a:lnL>
+                    <a:lnR w="6350" cap="flat" cmpd="sng" algn="ctr">
+                      <a:solidFill>
+                        <a:srgbClr val="2B3B72"/>
+                      </a:solidFill>
+                      <a:prstDash val="solid"/>
+                      <a:round/>
+                      <a:headEnd type="none" w="med" len="med"/>
+                      <a:tailEnd type="none" w="med" len="med"/>
+                    </a:lnR>
+                    <a:lnT w="6350" cap="flat" cmpd="sng" algn="ctr">
+                      <a:solidFill>
+                        <a:srgbClr val="2B3B72"/>
+                      </a:solidFill>
+                      <a:prstDash val="solid"/>
+                      <a:round/>
+                      <a:headEnd type="none" w="med" len="med"/>
+                      <a:tailEnd type="none" w="med" len="med"/>
+                    </a:lnT>
+                    <a:lnB w="6350" cap="flat" cmpd="sng" algn="ctr">
+                      <a:solidFill>
+                        <a:srgbClr val="2B3B72"/>
+                      </a:solidFill>
+                      <a:prstDash val="solid"/>
+                      <a:round/>
+                      <a:headEnd type="none" w="med" len="med"/>
+                      <a:tailEnd type="none" w="med" len="med"/>
+                    </a:lnB>
+                  </a:tcPr>
+                </a:tc>
+                <a:tc>
+                  <a:txBody>
+                    <a:bodyPr/>
+                    <a:lstStyle/>
+                    <a:p>
+                      <a:pPr indent="0" marL="0">
+                        <a:buNone/>
+                      </a:pPr>
+                      <a:r>
+                        <a:rPr lang="en-US" sz="1100" dirty="0">
+                          <a:solidFill>
+                            <a:srgbClr val="EAF0FB"/>
+                          </a:solidFill>
+                          <a:latin typeface="Microsoft JhengHei" pitchFamily="34" charset="0"/>
+                          <a:ea typeface="Microsoft JhengHei" pitchFamily="34" charset="-122"/>
+                          <a:cs typeface="Microsoft JhengHei" pitchFamily="34" charset="-120"/>
+                        </a:rPr>
+                        <a:t>✅ 做得到 —— 那是 analysis/precompute.py 算的統計</a:t>
+                      </a:r>
+                      <a:endParaRPr lang="en-US" sz="1100" dirty="0">
+                        <a:latin typeface="Microsoft JhengHei" charset="0"/>
+                        <a:ea typeface="Microsoft JhengHei" charset="0"/>
+                        <a:cs typeface="Microsoft JhengHei" charset="0"/>
+                      </a:endParaRPr>
+                    </a:p>
+                  </a:txBody>
+                  <a:tcPr marL="91440" marR="91440" marT="45720" marB="45720" anchor="t">
+                    <a:lnL w="6350" cap="flat" cmpd="sng" algn="ctr">
+                      <a:solidFill>
+                        <a:srgbClr val="2B3B72"/>
+                      </a:solidFill>
+                      <a:prstDash val="solid"/>
+                      <a:round/>
+                      <a:headEnd type="none" w="med" len="med"/>
+                      <a:tailEnd type="none" w="med" len="med"/>
+                    </a:lnL>
+                    <a:lnR w="6350" cap="flat" cmpd="sng" algn="ctr">
+                      <a:solidFill>
+                        <a:srgbClr val="2B3B72"/>
+                      </a:solidFill>
+                      <a:prstDash val="solid"/>
+                      <a:round/>
+                      <a:headEnd type="none" w="med" len="med"/>
+                      <a:tailEnd type="none" w="med" len="med"/>
+                    </a:lnR>
+                    <a:lnT w="6350" cap="flat" cmpd="sng" algn="ctr">
+                      <a:solidFill>
+                        <a:srgbClr val="2B3B72"/>
+                      </a:solidFill>
+                      <a:prstDash val="solid"/>
+                      <a:round/>
+                      <a:headEnd type="none" w="med" len="med"/>
+                      <a:tailEnd type="none" w="med" len="med"/>
+                    </a:lnT>
+                    <a:lnB w="6350" cap="flat" cmpd="sng" algn="ctr">
+                      <a:solidFill>
+                        <a:srgbClr val="2B3B72"/>
+                      </a:solidFill>
+                      <a:prstDash val="solid"/>
+                      <a:round/>
+                      <a:headEnd type="none" w="med" len="med"/>
+                      <a:tailEnd type="none" w="med" len="med"/>
+                    </a:lnB>
+                  </a:tcPr>
+                </a:tc>
+              </a:tr>
+              <a:tr h="0">
+                <a:tc>
+                  <a:txBody>
+                    <a:bodyPr/>
+                    <a:lstStyle/>
+                    <a:p>
+                      <a:pPr indent="0" marL="0">
+                        <a:buNone/>
+                      </a:pPr>
+                      <a:r>
+                        <a:rPr lang="en-US" sz="1100" dirty="0">
+                          <a:solidFill>
+                            <a:srgbClr val="EAF0FB"/>
+                          </a:solidFill>
+                          <a:latin typeface="Microsoft JhengHei" pitchFamily="34" charset="0"/>
+                          <a:ea typeface="Microsoft JhengHei" pitchFamily="34" charset="-122"/>
+                          <a:cs typeface="Microsoft JhengHei" pitchFamily="34" charset="-120"/>
+                        </a:rPr>
+                        <a:t>三方案的金額、手續費、賣後集中度</a:t>
+                      </a:r>
+                      <a:endParaRPr lang="en-US" sz="1100" dirty="0">
+                        <a:latin typeface="Microsoft JhengHei" charset="0"/>
+                        <a:ea typeface="Microsoft JhengHei" charset="0"/>
+                        <a:cs typeface="Microsoft JhengHei" charset="0"/>
+                      </a:endParaRPr>
+                    </a:p>
+                  </a:txBody>
+                  <a:tcPr marL="91440" marR="91440" marT="45720" marB="45720" anchor="t">
+                    <a:lnL w="6350" cap="flat" cmpd="sng" algn="ctr">
+                      <a:solidFill>
+                        <a:srgbClr val="2B3B72"/>
+                      </a:solidFill>
+                      <a:prstDash val="solid"/>
+                      <a:round/>
+                      <a:headEnd type="none" w="med" len="med"/>
+                      <a:tailEnd type="none" w="med" len="med"/>
+                    </a:lnL>
+                    <a:lnR w="6350" cap="flat" cmpd="sng" algn="ctr">
+                      <a:solidFill>
+                        <a:srgbClr val="2B3B72"/>
+                      </a:solidFill>
+                      <a:prstDash val="solid"/>
+                      <a:round/>
+                      <a:headEnd type="none" w="med" len="med"/>
+                      <a:tailEnd type="none" w="med" len="med"/>
+                    </a:lnR>
+                    <a:lnT w="6350" cap="flat" cmpd="sng" algn="ctr">
+                      <a:solidFill>
+                        <a:srgbClr val="2B3B72"/>
+                      </a:solidFill>
+                      <a:prstDash val="solid"/>
+                      <a:round/>
+                      <a:headEnd type="none" w="med" len="med"/>
+                      <a:tailEnd type="none" w="med" len="med"/>
+                    </a:lnT>
+                    <a:lnB w="6350" cap="flat" cmpd="sng" algn="ctr">
+                      <a:solidFill>
+                        <a:srgbClr val="2B3B72"/>
+                      </a:solidFill>
+                      <a:prstDash val="solid"/>
+                      <a:round/>
+                      <a:headEnd type="none" w="med" len="med"/>
+                      <a:tailEnd type="none" w="med" len="med"/>
+                    </a:lnB>
+                  </a:tcPr>
+                </a:tc>
+                <a:tc>
+                  <a:txBody>
+                    <a:bodyPr/>
+                    <a:lstStyle/>
+                    <a:p>
+                      <a:pPr indent="0" marL="0">
+                        <a:buNone/>
+                      </a:pPr>
+                      <a:r>
+                        <a:rPr lang="en-US" sz="1100" dirty="0">
+                          <a:solidFill>
+                            <a:srgbClr val="EAF0FB"/>
+                          </a:solidFill>
+                          <a:latin typeface="Microsoft JhengHei" pitchFamily="34" charset="0"/>
+                          <a:ea typeface="Microsoft JhengHei" pitchFamily="34" charset="-122"/>
+                          <a:cs typeface="Microsoft JhengHei" pitchFamily="34" charset="-120"/>
+                        </a:rPr>
+                        <a:t>✅ 做得到 —— scenarios.py 的確定性計算</a:t>
+                      </a:r>
+                      <a:endParaRPr lang="en-US" sz="1100" dirty="0">
+                        <a:latin typeface="Microsoft JhengHei" charset="0"/>
+                        <a:ea typeface="Microsoft JhengHei" charset="0"/>
+                        <a:cs typeface="Microsoft JhengHei" charset="0"/>
+                      </a:endParaRPr>
+                    </a:p>
+                  </a:txBody>
+                  <a:tcPr marL="91440" marR="91440" marT="45720" marB="45720" anchor="t">
+                    <a:lnL w="6350" cap="flat" cmpd="sng" algn="ctr">
+                      <a:solidFill>
+                        <a:srgbClr val="2B3B72"/>
+                      </a:solidFill>
+                      <a:prstDash val="solid"/>
+                      <a:round/>
+                      <a:headEnd type="none" w="med" len="med"/>
+                      <a:tailEnd type="none" w="med" len="med"/>
+                    </a:lnL>
+                    <a:lnR w="6350" cap="flat" cmpd="sng" algn="ctr">
+                      <a:solidFill>
+                        <a:srgbClr val="2B3B72"/>
+                      </a:solidFill>
+                      <a:prstDash val="solid"/>
+                      <a:round/>
+                      <a:headEnd type="none" w="med" len="med"/>
+                      <a:tailEnd type="none" w="med" len="med"/>
+                    </a:lnR>
+                    <a:lnT w="6350" cap="flat" cmpd="sng" algn="ctr">
+                      <a:solidFill>
+                        <a:srgbClr val="2B3B72"/>
+                      </a:solidFill>
+                      <a:prstDash val="solid"/>
+                      <a:round/>
+                      <a:headEnd type="none" w="med" len="med"/>
+                      <a:tailEnd type="none" w="med" len="med"/>
+                    </a:lnT>
+                    <a:lnB w="6350" cap="flat" cmpd="sng" algn="ctr">
+                      <a:solidFill>
+                        <a:srgbClr val="2B3B72"/>
+                      </a:solidFill>
+                      <a:prstDash val="solid"/>
+                      <a:round/>
+                      <a:headEnd type="none" w="med" len="med"/>
+                      <a:tailEnd type="none" w="med" len="med"/>
+                    </a:lnB>
+                  </a:tcPr>
+                </a:tc>
+              </a:tr>
+              <a:tr h="0">
+                <a:tc>
+                  <a:txBody>
+                    <a:bodyPr/>
+                    <a:lstStyle/>
+                    <a:p>
+                      <a:pPr indent="0" marL="0">
+                        <a:buNone/>
+                      </a:pPr>
+                      <a:r>
+                        <a:rPr lang="en-US" sz="1100" dirty="0">
+                          <a:solidFill>
+                            <a:srgbClr val="EAF0FB"/>
+                          </a:solidFill>
+                          <a:latin typeface="Microsoft JhengHei" pitchFamily="34" charset="0"/>
+                          <a:ea typeface="Microsoft JhengHei" pitchFamily="34" charset="-122"/>
+                          <a:cs typeface="Microsoft JhengHei" pitchFamily="34" charset="-120"/>
+                        </a:rPr>
+                        <a:t>聽懂「ETH 跌太多幫我全部賣掉」</a:t>
+                      </a:r>
+                      <a:endParaRPr lang="en-US" sz="1100" dirty="0">
+                        <a:latin typeface="Microsoft JhengHei" charset="0"/>
+                        <a:ea typeface="Microsoft JhengHei" charset="0"/>
+                        <a:cs typeface="Microsoft JhengHei" charset="0"/>
+                      </a:endParaRPr>
+                    </a:p>
+                  </a:txBody>
+                  <a:tcPr marL="91440" marR="91440" marT="45720" marB="45720" anchor="t">
+                    <a:lnL w="6350" cap="flat" cmpd="sng" algn="ctr">
+                      <a:solidFill>
+                        <a:srgbClr val="2B3B72"/>
+                      </a:solidFill>
+                      <a:prstDash val="solid"/>
+                      <a:round/>
+                      <a:headEnd type="none" w="med" len="med"/>
+                      <a:tailEnd type="none" w="med" len="med"/>
+                    </a:lnL>
+                    <a:lnR w="6350" cap="flat" cmpd="sng" algn="ctr">
+                      <a:solidFill>
+                        <a:srgbClr val="2B3B72"/>
+                      </a:solidFill>
+                      <a:prstDash val="solid"/>
+                      <a:round/>
+                      <a:headEnd type="none" w="med" len="med"/>
+                      <a:tailEnd type="none" w="med" len="med"/>
+                    </a:lnR>
+                    <a:lnT w="6350" cap="flat" cmpd="sng" algn="ctr">
+                      <a:solidFill>
+                        <a:srgbClr val="2B3B72"/>
+                      </a:solidFill>
+                      <a:prstDash val="solid"/>
+                      <a:round/>
+                      <a:headEnd type="none" w="med" len="med"/>
+                      <a:tailEnd type="none" w="med" len="med"/>
+                    </a:lnT>
+                    <a:lnB w="6350" cap="flat" cmpd="sng" algn="ctr">
+                      <a:solidFill>
+                        <a:srgbClr val="2B3B72"/>
+                      </a:solidFill>
+                      <a:prstDash val="solid"/>
+                      <a:round/>
+                      <a:headEnd type="none" w="med" len="med"/>
+                      <a:tailEnd type="none" w="med" len="med"/>
+                    </a:lnB>
+                  </a:tcPr>
+                </a:tc>
+                <a:tc>
+                  <a:txBody>
+                    <a:bodyPr/>
+                    <a:lstStyle/>
+                    <a:p>
+                      <a:pPr indent="0" marL="0">
+                        <a:buNone/>
+                      </a:pPr>
+                      <a:r>
+                        <a:rPr lang="en-US" sz="1100" dirty="0">
+                          <a:solidFill>
+                            <a:srgbClr val="EAF0FB"/>
+                          </a:solidFill>
+                          <a:latin typeface="Microsoft JhengHei" pitchFamily="34" charset="0"/>
+                          <a:ea typeface="Microsoft JhengHei" pitchFamily="34" charset="-122"/>
+                          <a:cs typeface="Microsoft JhengHei" pitchFamily="34" charset="-120"/>
+                        </a:rPr>
+                        <a:t>❌ 那是自由語句，不是選單上的選項</a:t>
+                      </a:r>
+                      <a:endParaRPr lang="en-US" sz="1100" dirty="0">
+                        <a:latin typeface="Microsoft JhengHei" charset="0"/>
+                        <a:ea typeface="Microsoft JhengHei" charset="0"/>
+                        <a:cs typeface="Microsoft JhengHei" charset="0"/>
+                      </a:endParaRPr>
+                    </a:p>
+                  </a:txBody>
+                  <a:tcPr marL="91440" marR="91440" marT="45720" marB="45720" anchor="t">
+                    <a:lnL w="6350" cap="flat" cmpd="sng" algn="ctr">
+                      <a:solidFill>
+                        <a:srgbClr val="2B3B72"/>
+                      </a:solidFill>
+                      <a:prstDash val="solid"/>
+                      <a:round/>
+                      <a:headEnd type="none" w="med" len="med"/>
+                      <a:tailEnd type="none" w="med" len="med"/>
+                    </a:lnL>
+                    <a:lnR w="6350" cap="flat" cmpd="sng" algn="ctr">
+                      <a:solidFill>
+                        <a:srgbClr val="2B3B72"/>
+                      </a:solidFill>
+                      <a:prstDash val="solid"/>
+                      <a:round/>
+                      <a:headEnd type="none" w="med" len="med"/>
+                      <a:tailEnd type="none" w="med" len="med"/>
+                    </a:lnR>
+                    <a:lnT w="6350" cap="flat" cmpd="sng" algn="ctr">
+                      <a:solidFill>
+                        <a:srgbClr val="2B3B72"/>
+                      </a:solidFill>
+                      <a:prstDash val="solid"/>
+                      <a:round/>
+                      <a:headEnd type="none" w="med" len="med"/>
+                      <a:tailEnd type="none" w="med" len="med"/>
+                    </a:lnT>
+                    <a:lnB w="6350" cap="flat" cmpd="sng" algn="ctr">
+                      <a:solidFill>
+                        <a:srgbClr val="2B3B72"/>
+                      </a:solidFill>
+                      <a:prstDash val="solid"/>
+                      <a:round/>
+                      <a:headEnd type="none" w="med" len="med"/>
+                      <a:tailEnd type="none" w="med" len="med"/>
+                    </a:lnB>
+                  </a:tcPr>
+                </a:tc>
+              </a:tr>
+              <a:tr h="0">
+                <a:tc>
+                  <a:txBody>
+                    <a:bodyPr/>
+                    <a:lstStyle/>
+                    <a:p>
+                      <a:pPr indent="0" marL="0">
+                        <a:buNone/>
+                      </a:pPr>
+                      <a:r>
+                        <a:rPr lang="en-US" sz="1100" dirty="0">
+                          <a:solidFill>
+                            <a:srgbClr val="EAF0FB"/>
+                          </a:solidFill>
+                          <a:latin typeface="Microsoft JhengHei" pitchFamily="34" charset="0"/>
+                          <a:ea typeface="Microsoft JhengHei" pitchFamily="34" charset="-122"/>
+                          <a:cs typeface="Microsoft JhengHei" pitchFamily="34" charset="-120"/>
+                        </a:rPr>
+                        <a:t>在恐慌當下，把他自己的紀錄講成一句聽得進去的話</a:t>
+                      </a:r>
+                      <a:endParaRPr lang="en-US" sz="1100" dirty="0">
+                        <a:latin typeface="Microsoft JhengHei" charset="0"/>
+                        <a:ea typeface="Microsoft JhengHei" charset="0"/>
+                        <a:cs typeface="Microsoft JhengHei" charset="0"/>
+                      </a:endParaRPr>
+                    </a:p>
+                  </a:txBody>
+                  <a:tcPr marL="91440" marR="91440" marT="45720" marB="45720" anchor="t">
+                    <a:lnL w="6350" cap="flat" cmpd="sng" algn="ctr">
+                      <a:solidFill>
+                        <a:srgbClr val="2B3B72"/>
+                      </a:solidFill>
+                      <a:prstDash val="solid"/>
+                      <a:round/>
+                      <a:headEnd type="none" w="med" len="med"/>
+                      <a:tailEnd type="none" w="med" len="med"/>
+                    </a:lnL>
+                    <a:lnR w="6350" cap="flat" cmpd="sng" algn="ctr">
+                      <a:solidFill>
+                        <a:srgbClr val="2B3B72"/>
+                      </a:solidFill>
+                      <a:prstDash val="solid"/>
+                      <a:round/>
+                      <a:headEnd type="none" w="med" len="med"/>
+                      <a:tailEnd type="none" w="med" len="med"/>
+                    </a:lnR>
+                    <a:lnT w="6350" cap="flat" cmpd="sng" algn="ctr">
+                      <a:solidFill>
+                        <a:srgbClr val="2B3B72"/>
+                      </a:solidFill>
+                      <a:prstDash val="solid"/>
+                      <a:round/>
+                      <a:headEnd type="none" w="med" len="med"/>
+                      <a:tailEnd type="none" w="med" len="med"/>
+                    </a:lnT>
+                    <a:lnB w="6350" cap="flat" cmpd="sng" algn="ctr">
+                      <a:solidFill>
+                        <a:srgbClr val="2B3B72"/>
+                      </a:solidFill>
+                      <a:prstDash val="solid"/>
+                      <a:round/>
+                      <a:headEnd type="none" w="med" len="med"/>
+                      <a:tailEnd type="none" w="med" len="med"/>
+                    </a:lnB>
+                  </a:tcPr>
+                </a:tc>
+                <a:tc>
+                  <a:txBody>
+                    <a:bodyPr/>
+                    <a:lstStyle/>
+                    <a:p>
+                      <a:pPr indent="0" marL="0">
+                        <a:buNone/>
+                      </a:pPr>
+                      <a:r>
+                        <a:rPr lang="en-US" sz="1100" dirty="0">
+                          <a:solidFill>
+                            <a:srgbClr val="EAF0FB"/>
+                          </a:solidFill>
+                          <a:latin typeface="Microsoft JhengHei" pitchFamily="34" charset="0"/>
+                          <a:ea typeface="Microsoft JhengHei" pitchFamily="34" charset="-122"/>
+                          <a:cs typeface="Microsoft JhengHei" pitchFamily="34" charset="-120"/>
+                        </a:rPr>
+                        <a:t>❌ 要把數據、個人歷史、當下情境編織成人話</a:t>
+                      </a:r>
+                      <a:endParaRPr lang="en-US" sz="1100" dirty="0">
+                        <a:latin typeface="Microsoft JhengHei" charset="0"/>
+                        <a:ea typeface="Microsoft JhengHei" charset="0"/>
+                        <a:cs typeface="Microsoft JhengHei" charset="0"/>
+                      </a:endParaRPr>
+                    </a:p>
+                  </a:txBody>
+                  <a:tcPr marL="91440" marR="91440" marT="45720" marB="45720" anchor="t">
+                    <a:lnL w="6350" cap="flat" cmpd="sng" algn="ctr">
+                      <a:solidFill>
+                        <a:srgbClr val="2B3B72"/>
+                      </a:solidFill>
+                      <a:prstDash val="solid"/>
+                      <a:round/>
+                      <a:headEnd type="none" w="med" len="med"/>
+                      <a:tailEnd type="none" w="med" len="med"/>
+                    </a:lnL>
+                    <a:lnR w="6350" cap="flat" cmpd="sng" algn="ctr">
+                      <a:solidFill>
+                        <a:srgbClr val="2B3B72"/>
+                      </a:solidFill>
+                      <a:prstDash val="solid"/>
+                      <a:round/>
+                      <a:headEnd type="none" w="med" len="med"/>
+                      <a:tailEnd type="none" w="med" len="med"/>
+                    </a:lnR>
+                    <a:lnT w="6350" cap="flat" cmpd="sng" algn="ctr">
+                      <a:solidFill>
+                        <a:srgbClr val="2B3B72"/>
+                      </a:solidFill>
+                      <a:prstDash val="solid"/>
+                      <a:round/>
+                      <a:headEnd type="none" w="med" len="med"/>
+                      <a:tailEnd type="none" w="med" len="med"/>
+                    </a:lnT>
+                    <a:lnB w="6350" cap="flat" cmpd="sng" algn="ctr">
+                      <a:solidFill>
+                        <a:srgbClr val="2B3B72"/>
+                      </a:solidFill>
+                      <a:prstDash val="solid"/>
+                      <a:round/>
+                      <a:headEnd type="none" w="med" len="med"/>
+                      <a:tailEnd type="none" w="med" len="med"/>
+                    </a:lnB>
+                  </a:tcPr>
+                </a:tc>
+              </a:tr>
+              <a:tr h="0">
+                <a:tc>
+                  <a:txBody>
+                    <a:bodyPr/>
+                    <a:lstStyle/>
+                    <a:p>
+                      <a:pPr indent="0" marL="0">
+                        <a:buNone/>
+                      </a:pPr>
+                      <a:r>
+                        <a:rPr lang="en-US" sz="1100" dirty="0">
+                          <a:solidFill>
+                            <a:srgbClr val="EAF0FB"/>
+                          </a:solidFill>
+                          <a:latin typeface="Microsoft JhengHei" pitchFamily="34" charset="0"/>
+                          <a:ea typeface="Microsoft JhengHei" pitchFamily="34" charset="-122"/>
+                          <a:cs typeface="Microsoft JhengHei" pitchFamily="34" charset="-120"/>
+                        </a:rPr>
+                        <a:t>同一組數字換三種語氣（陪伴／簡潔／分析）</a:t>
+                      </a:r>
+                      <a:endParaRPr lang="en-US" sz="1100" dirty="0">
+                        <a:latin typeface="Microsoft JhengHei" charset="0"/>
+                        <a:ea typeface="Microsoft JhengHei" charset="0"/>
+                        <a:cs typeface="Microsoft JhengHei" charset="0"/>
+                      </a:endParaRPr>
+                    </a:p>
+                  </a:txBody>
+                  <a:tcPr marL="91440" marR="91440" marT="45720" marB="45720" anchor="t">
+                    <a:lnL w="6350" cap="flat" cmpd="sng" algn="ctr">
+                      <a:solidFill>
+                        <a:srgbClr val="2B3B72"/>
+                      </a:solidFill>
+                      <a:prstDash val="solid"/>
+                      <a:round/>
+                      <a:headEnd type="none" w="med" len="med"/>
+                      <a:tailEnd type="none" w="med" len="med"/>
+                    </a:lnL>
+                    <a:lnR w="6350" cap="flat" cmpd="sng" algn="ctr">
+                      <a:solidFill>
+                        <a:srgbClr val="2B3B72"/>
+                      </a:solidFill>
+                      <a:prstDash val="solid"/>
+                      <a:round/>
+                      <a:headEnd type="none" w="med" len="med"/>
+                      <a:tailEnd type="none" w="med" len="med"/>
+                    </a:lnR>
+                    <a:lnT w="6350" cap="flat" cmpd="sng" algn="ctr">
+                      <a:solidFill>
+                        <a:srgbClr val="2B3B72"/>
+                      </a:solidFill>
+                      <a:prstDash val="solid"/>
+                      <a:round/>
+                      <a:headEnd type="none" w="med" len="med"/>
+                      <a:tailEnd type="none" w="med" len="med"/>
+                    </a:lnT>
+                    <a:lnB w="6350" cap="flat" cmpd="sng" algn="ctr">
+                      <a:solidFill>
+                        <a:srgbClr val="2B3B72"/>
+                      </a:solidFill>
+                      <a:prstDash val="solid"/>
+                      <a:round/>
+                      <a:headEnd type="none" w="med" len="med"/>
+                      <a:tailEnd type="none" w="med" len="med"/>
+                    </a:lnB>
+                  </a:tcPr>
+                </a:tc>
+                <a:tc>
+                  <a:txBody>
+                    <a:bodyPr/>
+                    <a:lstStyle/>
+                    <a:p>
+                      <a:pPr indent="0" marL="0">
+                        <a:buNone/>
+                      </a:pPr>
+                      <a:r>
+                        <a:rPr lang="en-US" sz="1100" dirty="0">
+                          <a:solidFill>
+                            <a:srgbClr val="EAF0FB"/>
+                          </a:solidFill>
+                          <a:latin typeface="Microsoft JhengHei" pitchFamily="34" charset="0"/>
+                          <a:ea typeface="Microsoft JhengHei" pitchFamily="34" charset="-122"/>
+                          <a:cs typeface="Microsoft JhengHei" pitchFamily="34" charset="-120"/>
+                        </a:rPr>
+                        <a:t>❌ 數字不變，說法要變</a:t>
+                      </a:r>
+                      <a:endParaRPr lang="en-US" sz="1100" dirty="0">
+                        <a:latin typeface="Microsoft JhengHei" charset="0"/>
+                        <a:ea typeface="Microsoft JhengHei" charset="0"/>
+                        <a:cs typeface="Microsoft JhengHei" charset="0"/>
+                      </a:endParaRPr>
+                    </a:p>
+                  </a:txBody>
+                  <a:tcPr marL="91440" marR="91440" marT="45720" marB="45720" anchor="t">
+                    <a:lnL w="6350" cap="flat" cmpd="sng" algn="ctr">
+                      <a:solidFill>
+                        <a:srgbClr val="2B3B72"/>
+                      </a:solidFill>
+                      <a:prstDash val="solid"/>
+                      <a:round/>
+                      <a:headEnd type="none" w="med" len="med"/>
+                      <a:tailEnd type="none" w="med" len="med"/>
+                    </a:lnL>
+                    <a:lnR w="6350" cap="flat" cmpd="sng" algn="ctr">
+                      <a:solidFill>
+                        <a:srgbClr val="2B3B72"/>
+                      </a:solidFill>
+                      <a:prstDash val="solid"/>
+                      <a:round/>
+                      <a:headEnd type="none" w="med" len="med"/>
+                      <a:tailEnd type="none" w="med" len="med"/>
+                    </a:lnR>
+                    <a:lnT w="6350" cap="flat" cmpd="sng" algn="ctr">
+                      <a:solidFill>
+                        <a:srgbClr val="2B3B72"/>
+                      </a:solidFill>
+                      <a:prstDash val="solid"/>
+                      <a:round/>
+                      <a:headEnd type="none" w="med" len="med"/>
+                      <a:tailEnd type="none" w="med" len="med"/>
+                    </a:lnT>
+                    <a:lnB w="6350" cap="flat" cmpd="sng" algn="ctr">
+                      <a:solidFill>
+                        <a:srgbClr val="2B3B72"/>
+                      </a:solidFill>
+                      <a:prstDash val="solid"/>
+                      <a:round/>
+                      <a:headEnd type="none" w="med" len="med"/>
+                      <a:tailEnd type="none" w="med" len="med"/>
+                    </a:lnB>
+                  </a:tcPr>
+                </a:tc>
+              </a:tr>
+              <a:tr h="0">
+                <a:tc>
+                  <a:txBody>
+                    <a:bodyPr/>
+                    <a:lstStyle/>
+                    <a:p>
+                      <a:pPr indent="0" marL="0">
+                        <a:buNone/>
+                      </a:pPr>
+                      <a:r>
+                        <a:rPr lang="en-US" sz="1100" dirty="0">
+                          <a:solidFill>
+                            <a:srgbClr val="EAF0FB"/>
+                          </a:solidFill>
+                          <a:latin typeface="Microsoft JhengHei" pitchFamily="34" charset="0"/>
+                          <a:ea typeface="Microsoft JhengHei" pitchFamily="34" charset="-122"/>
+                          <a:cs typeface="Microsoft JhengHei" pitchFamily="34" charset="-120"/>
+                        </a:rPr>
+                        <a:t>「這是不是詐騙話術」的語意理解與語料檢索</a:t>
+                      </a:r>
+                      <a:endParaRPr lang="en-US" sz="1100" dirty="0">
+                        <a:latin typeface="Microsoft JhengHei" charset="0"/>
+                        <a:ea typeface="Microsoft JhengHei" charset="0"/>
+                        <a:cs typeface="Microsoft JhengHei" charset="0"/>
+                      </a:endParaRPr>
+                    </a:p>
+                  </a:txBody>
+                  <a:tcPr marL="91440" marR="91440" marT="45720" marB="45720" anchor="t">
+                    <a:lnL w="6350" cap="flat" cmpd="sng" algn="ctr">
+                      <a:solidFill>
+                        <a:srgbClr val="2B3B72"/>
+                      </a:solidFill>
+                      <a:prstDash val="solid"/>
+                      <a:round/>
+                      <a:headEnd type="none" w="med" len="med"/>
+                      <a:tailEnd type="none" w="med" len="med"/>
+                    </a:lnL>
+                    <a:lnR w="6350" cap="flat" cmpd="sng" algn="ctr">
+                      <a:solidFill>
+                        <a:srgbClr val="2B3B72"/>
+                      </a:solidFill>
+                      <a:prstDash val="solid"/>
+                      <a:round/>
+                      <a:headEnd type="none" w="med" len="med"/>
+                      <a:tailEnd type="none" w="med" len="med"/>
+                    </a:lnR>
+                    <a:lnT w="6350" cap="flat" cmpd="sng" algn="ctr">
+                      <a:solidFill>
+                        <a:srgbClr val="2B3B72"/>
+                      </a:solidFill>
+                      <a:prstDash val="solid"/>
+                      <a:round/>
+                      <a:headEnd type="none" w="med" len="med"/>
+                      <a:tailEnd type="none" w="med" len="med"/>
+                    </a:lnT>
+                    <a:lnB w="6350" cap="flat" cmpd="sng" algn="ctr">
+                      <a:solidFill>
+                        <a:srgbClr val="2B3B72"/>
+                      </a:solidFill>
+                      <a:prstDash val="solid"/>
+                      <a:round/>
+                      <a:headEnd type="none" w="med" len="med"/>
+                      <a:tailEnd type="none" w="med" len="med"/>
+                    </a:lnB>
+                  </a:tcPr>
+                </a:tc>
+                <a:tc>
+                  <a:txBody>
+                    <a:bodyPr/>
+                    <a:lstStyle/>
+                    <a:p>
+                      <a:pPr indent="0" marL="0">
+                        <a:buNone/>
+                      </a:pPr>
+                      <a:r>
+                        <a:rPr lang="en-US" sz="1100" dirty="0">
+                          <a:solidFill>
+                            <a:srgbClr val="EAF0FB"/>
+                          </a:solidFill>
+                          <a:latin typeface="Microsoft JhengHei" pitchFamily="34" charset="0"/>
+                          <a:ea typeface="Microsoft JhengHei" pitchFamily="34" charset="-122"/>
+                          <a:cs typeface="Microsoft JhengHei" pitchFamily="34" charset="-120"/>
+                        </a:rPr>
+                        <a:t>❌ 意圖判讀 ＋ RAG</a:t>
+                      </a:r>
+                      <a:endParaRPr lang="en-US" sz="1100" dirty="0">
+                        <a:latin typeface="Microsoft JhengHei" charset="0"/>
+                        <a:ea typeface="Microsoft JhengHei" charset="0"/>
+                        <a:cs typeface="Microsoft JhengHei" charset="0"/>
+                      </a:endParaRPr>
+                    </a:p>
+                  </a:txBody>
+                  <a:tcPr marL="91440" marR="91440" marT="45720" marB="45720" anchor="t">
+                    <a:lnL w="6350" cap="flat" cmpd="sng" algn="ctr">
+                      <a:solidFill>
+                        <a:srgbClr val="2B3B72"/>
+                      </a:solidFill>
+                      <a:prstDash val="solid"/>
+                      <a:round/>
+                      <a:headEnd type="none" w="med" len="med"/>
+                      <a:tailEnd type="none" w="med" len="med"/>
+                    </a:lnL>
+                    <a:lnR w="6350" cap="flat" cmpd="sng" algn="ctr">
+                      <a:solidFill>
+                        <a:srgbClr val="2B3B72"/>
+                      </a:solidFill>
+                      <a:prstDash val="solid"/>
+                      <a:round/>
+                      <a:headEnd type="none" w="med" len="med"/>
+                      <a:tailEnd type="none" w="med" len="med"/>
+                    </a:lnR>
+                    <a:lnT w="6350" cap="flat" cmpd="sng" algn="ctr">
+                      <a:solidFill>
+                        <a:srgbClr val="2B3B72"/>
+                      </a:solidFill>
+                      <a:prstDash val="solid"/>
+                      <a:round/>
+                      <a:headEnd type="none" w="med" len="med"/>
+                      <a:tailEnd type="none" w="med" len="med"/>
+                    </a:lnT>
+                    <a:lnB w="6350" cap="flat" cmpd="sng" algn="ctr">
+                      <a:solidFill>
+                        <a:srgbClr val="2B3B72"/>
+                      </a:solidFill>
+                      <a:prstDash val="solid"/>
+                      <a:round/>
+                      <a:headEnd type="none" w="med" len="med"/>
+                      <a:tailEnd type="none" w="med" len="med"/>
+                    </a:lnB>
+                  </a:tcPr>
+                </a:tc>
+              </a:tr>
+            </a:tbl>
+          </a:graphicData>
+        </a:graphic>
+      </p:graphicFrame>
+      <p:sp>
+        <p:nvSpPr>
+          <p:cNvPr id="6" name="Shape 3"/>
+          <p:cNvSpPr/>
+          <p:nvPr/>
+        </p:nvSpPr>
+        <p:spPr>
+          <a:xfrm>
+            <a:off x="640080" y="5394960"/>
+            <a:ext cx="41148" cy="685800"/>
+          </a:xfrm>
+          <a:prstGeom prst="rect">
+            <a:avLst/>
+          </a:prstGeom>
+          <a:solidFill>
+            <a:srgbClr val="E8A13A"/>
+          </a:solidFill>
+          <a:ln/>
+        </p:spPr>
+      </p:sp>
+      <p:sp>
+        <p:nvSpPr>
+          <p:cNvPr id="7" name="Text 4"/>
+          <p:cNvSpPr/>
+          <p:nvPr/>
+        </p:nvSpPr>
+        <p:spPr>
+          <a:xfrm>
+            <a:off x="804672" y="5394960"/>
+            <a:ext cx="10744200" cy="822960"/>
+          </a:xfrm>
+          <a:prstGeom prst="rect">
+            <a:avLst/>
+          </a:prstGeom>
+          <a:noFill/>
+          <a:ln/>
+        </p:spPr>
+        <p:txBody>
+          <a:bodyPr wrap="square" rtlCol="0" anchor="t"/>
+          <a:lstStyle/>
+          <a:p>
+            <a:pPr indent="0" marL="0">
+              <a:lnSpc>
+                <a:spcPts val="1800"/>
+              </a:lnSpc>
+              <a:buNone/>
+            </a:pPr>
+            <a:r>
+              <a:rPr lang="en-US" sz="1150" dirty="0">
+                <a:solidFill>
+                  <a:srgbClr val="B9C6E0"/>
+                </a:solidFill>
+                <a:latin typeface="Microsoft JhengHei" pitchFamily="34" charset="0"/>
+                <a:ea typeface="Microsoft JhengHei" pitchFamily="34" charset="-122"/>
+                <a:cs typeface="Microsoft JhengHei" pitchFamily="34" charset="-120"/>
+              </a:rPr>
+              <a:t>所以我們沒有把 AI 用在算數字上——數字全部由程式算。AI 只做程式做不到的那一半。</a:t>
+            </a:r>
+            <a:endParaRPr lang="en-US" sz="1150" dirty="0"/>
+          </a:p>
+        </p:txBody>
+      </p:sp>
+      <p:sp>
+        <p:nvSpPr>
+          <p:cNvPr id="8" name="Text 5"/>
+          <p:cNvSpPr/>
+          <p:nvPr/>
+        </p:nvSpPr>
+        <p:spPr>
+          <a:xfrm>
+            <a:off x="640080" y="6172200"/>
+            <a:ext cx="10908792" cy="502920"/>
+          </a:xfrm>
+          <a:prstGeom prst="rect">
+            <a:avLst/>
+          </a:prstGeom>
+          <a:noFill/>
+          <a:ln/>
+        </p:spPr>
+        <p:txBody>
+          <a:bodyPr wrap="square" rtlCol="0" anchor="t"/>
+          <a:lstStyle/>
+          <a:p>
+            <a:pPr indent="0" marL="0">
+              <a:lnSpc>
+                <a:spcPts val="1400"/>
+              </a:lnSpc>
+              <a:buNone/>
+            </a:pPr>
+            <a:r>
+              <a:rPr lang="en-US" sz="950" dirty="0">
+                <a:solidFill>
+                  <a:srgbClr val="8FA0C0"/>
+                </a:solidFill>
+                <a:latin typeface="Microsoft JhengHei" pitchFamily="34" charset="0"/>
+                <a:ea typeface="Microsoft JhengHei" pitchFamily="34" charset="-122"/>
+                <a:cs typeface="Microsoft JhengHei" pitchFamily="34" charset="-120"/>
+              </a:rPr>
+              <a:t>沒有生成式 AI，這產品會退化成一個儀表板。而儀表板攔不住正在恐慌的人——那個人不會在按下全賣之前先去看圖表。</a:t>
+            </a:r>
+            <a:endParaRPr lang="en-US" sz="950" dirty="0"/>
+          </a:p>
+        </p:txBody>
+      </p:sp>
+      <p:sp>
+        <p:nvSpPr>
+          <p:cNvPr id="9" name="Text 6"/>
+          <p:cNvSpPr/>
+          <p:nvPr/>
+        </p:nvSpPr>
+        <p:spPr>
+          <a:xfrm>
+            <a:off x="11457432" y="6446520"/>
+            <a:ext cx="365760" cy="228600"/>
+          </a:xfrm>
+          <a:prstGeom prst="rect">
+            <a:avLst/>
+          </a:prstGeom>
+          <a:noFill/>
+          <a:ln/>
+        </p:spPr>
+        <p:txBody>
+          <a:bodyPr wrap="square" rtlCol="0" anchor="ctr"/>
+          <a:lstStyle/>
+          <a:p>
+            <a:pPr algn="r" indent="0" marL="0">
+              <a:buNone/>
+            </a:pPr>
+            <a:r>
+              <a:rPr lang="en-US" sz="900" dirty="0">
+                <a:solidFill>
+                  <a:srgbClr val="6B7280"/>
+                </a:solidFill>
+                <a:latin typeface="Microsoft JhengHei" pitchFamily="34" charset="0"/>
+                <a:ea typeface="Microsoft JhengHei" pitchFamily="34" charset="-122"/>
+                <a:cs typeface="Microsoft JhengHei" pitchFamily="34" charset="-120"/>
+              </a:rPr>
+              <a:t>13</a:t>
+            </a:r>
+            <a:endParaRPr lang="en-US" sz="900" dirty="0"/>
+          </a:p>
+        </p:txBody>
+      </p:sp>
+    </p:spTree>
+  </p:cSld>
+  <p:clrMapOvr>
+    <a:masterClrMapping/>
+  </p:clrMapOvr>
+</p:sld>
+</file>
+
+<file path=ppt/slides/slide14.xml><?xml version="1.0" encoding="utf-8"?>
+<p:sld xmlns:a="http://schemas.openxmlformats.org/drawingml/2006/main" xmlns:r="http://schemas.openxmlformats.org/officeDocument/2006/relationships" xmlns:p="http://schemas.openxmlformats.org/presentationml/2006/main">
+  <p:cSld name="Slide 14">
+    <p:bg>
+      <p:bgPr>
+        <a:solidFill>
+          <a:srgbClr val="16224D"/>
+        </a:solidFill>
+      </p:bgPr>
+    </p:bg>
+    <p:spTree>
+      <p:nvGrpSpPr>
+        <p:cNvPr id="1" name=""/>
+        <p:cNvGrpSpPr/>
+        <p:nvPr/>
+      </p:nvGrpSpPr>
+      <p:grpSpPr>
+        <a:xfrm>
+          <a:off x="0" y="0"/>
+          <a:ext cx="0" cy="0"/>
+          <a:chOff x="0" y="0"/>
+          <a:chExt cx="0" cy="0"/>
+        </a:xfrm>
+      </p:grpSpPr>
+      <p:sp>
+        <p:nvSpPr>
+          <p:cNvPr id="2" name="Text 0"/>
+          <p:cNvSpPr/>
+          <p:nvPr/>
+        </p:nvSpPr>
+        <p:spPr>
+          <a:xfrm>
+            <a:off x="640080" y="411480"/>
+            <a:ext cx="10908792" cy="274320"/>
+          </a:xfrm>
+          <a:prstGeom prst="rect">
+            <a:avLst/>
+          </a:prstGeom>
+          <a:noFill/>
+          <a:ln/>
+        </p:spPr>
+        <p:txBody>
+          <a:bodyPr wrap="square" rtlCol="0" anchor="ctr"/>
+          <a:lstStyle/>
+          <a:p>
+            <a:pPr indent="0" marL="0">
+              <a:buNone/>
+            </a:pPr>
+            <a:r>
+              <a:rPr lang="en-US" sz="1200" b="1" spc="150" kern="0" dirty="0">
+                <a:solidFill>
+                  <a:srgbClr val="E8A13A"/>
+                </a:solidFill>
+                <a:latin typeface="Microsoft JhengHei" pitchFamily="34" charset="0"/>
+                <a:ea typeface="Microsoft JhengHei" pitchFamily="34" charset="-122"/>
+                <a:cs typeface="Microsoft JhengHei" pitchFamily="34" charset="-120"/>
+              </a:rPr>
+              <a:t>護欄</a:t>
+            </a:r>
+            <a:endParaRPr lang="en-US" sz="1200" dirty="0"/>
+          </a:p>
+        </p:txBody>
+      </p:sp>
+      <p:sp>
+        <p:nvSpPr>
+          <p:cNvPr id="3" name="Text 1"/>
+          <p:cNvSpPr/>
+          <p:nvPr/>
+        </p:nvSpPr>
+        <p:spPr>
+          <a:xfrm>
+            <a:off x="640080" y="795528"/>
+            <a:ext cx="10908792" cy="777240"/>
+          </a:xfrm>
+          <a:prstGeom prst="rect">
+            <a:avLst/>
+          </a:prstGeom>
+          <a:noFill/>
+          <a:ln/>
+        </p:spPr>
+        <p:txBody>
+          <a:bodyPr wrap="square" rtlCol="0" anchor="t"/>
+          <a:lstStyle/>
+          <a:p>
+            <a:pPr indent="0" marL="0">
+              <a:buNone/>
+            </a:pPr>
+            <a:r>
+              <a:rPr lang="en-US" sz="3000" b="1" dirty="0">
+                <a:solidFill>
+                  <a:srgbClr val="FFFFFF"/>
+                </a:solidFill>
+                <a:latin typeface="Microsoft JhengHei" pitchFamily="34" charset="0"/>
+                <a:ea typeface="Microsoft JhengHei" pitchFamily="34" charset="-122"/>
+                <a:cs typeface="Microsoft JhengHei" pitchFamily="34" charset="-120"/>
+              </a:rPr>
+              <a:t>四層攔截，任一層可獨立擋住</a:t>
+            </a:r>
+            <a:endParaRPr lang="en-US" sz="3000" dirty="0"/>
+          </a:p>
+        </p:txBody>
+      </p:sp>
+      <p:sp>
+        <p:nvSpPr>
+          <p:cNvPr id="4" name="Text 2"/>
+          <p:cNvSpPr/>
+          <p:nvPr/>
+        </p:nvSpPr>
+        <p:spPr>
+          <a:xfrm>
+            <a:off x="640080" y="1709928"/>
+            <a:ext cx="10908792" cy="365760"/>
+          </a:xfrm>
+          <a:prstGeom prst="rect">
+            <a:avLst/>
+          </a:prstGeom>
+          <a:noFill/>
+          <a:ln/>
+        </p:spPr>
+        <p:txBody>
+          <a:bodyPr wrap="square" rtlCol="0" anchor="ctr"/>
+          <a:lstStyle/>
+          <a:p>
+            <a:pPr indent="0" marL="0">
+              <a:buNone/>
+            </a:pPr>
+            <a:r>
+              <a:rPr lang="en-US" sz="1300" dirty="0">
+                <a:solidFill>
+                  <a:srgbClr val="B9C6E0"/>
+                </a:solidFill>
+                <a:latin typeface="Microsoft JhengHei" pitchFamily="34" charset="0"/>
+                <a:ea typeface="Microsoft JhengHei" pitchFamily="34" charset="-122"/>
+                <a:cs typeface="Microsoft JhengHei" pitchFamily="34" charset="-120"/>
+              </a:rPr>
+              <a:t>「不報明牌」不是一句承諾，是四個獨立的攔截點。</a:t>
+            </a:r>
+            <a:endParaRPr lang="en-US" sz="1300" dirty="0"/>
+          </a:p>
+        </p:txBody>
+      </p:sp>
+      <p:sp>
+        <p:nvSpPr>
+          <p:cNvPr id="5" name="Shape 3"/>
+          <p:cNvSpPr/>
+          <p:nvPr/>
+        </p:nvSpPr>
+        <p:spPr>
+          <a:xfrm>
+            <a:off x="640080" y="2212848"/>
+            <a:ext cx="3453384" cy="2743200"/>
+          </a:xfrm>
+          <a:prstGeom prst="roundRect">
+            <a:avLst>
+              <a:gd name="adj" fmla="val 2667"/>
+            </a:avLst>
+          </a:prstGeom>
+          <a:solidFill>
+            <a:srgbClr val="1D2B5C"/>
+          </a:solidFill>
+          <a:ln w="12700">
+            <a:solidFill>
+              <a:srgbClr val="2B3B72"/>
+            </a:solidFill>
+            <a:prstDash val="solid"/>
+          </a:ln>
+        </p:spPr>
+      </p:sp>
+      <p:sp>
+        <p:nvSpPr>
+          <p:cNvPr id="6" name="Text 4"/>
+          <p:cNvSpPr/>
+          <p:nvPr/>
+        </p:nvSpPr>
+        <p:spPr>
+          <a:xfrm>
+            <a:off x="841248" y="2377440"/>
+            <a:ext cx="3051048" cy="502920"/>
+          </a:xfrm>
+          <a:prstGeom prst="rect">
+            <a:avLst/>
+          </a:prstGeom>
+          <a:noFill/>
+          <a:ln/>
+        </p:spPr>
+        <p:txBody>
+          <a:bodyPr wrap="square" rtlCol="0" anchor="ctr"/>
+          <a:lstStyle/>
+          <a:p>
+            <a:pPr indent="0" marL="0">
+              <a:buNone/>
+            </a:pPr>
+            <a:r>
+              <a:rPr lang="en-US" sz="1350" b="1" dirty="0">
+                <a:solidFill>
+                  <a:srgbClr val="E8A13A"/>
+                </a:solidFill>
+                <a:latin typeface="Microsoft JhengHei" pitchFamily="34" charset="0"/>
+                <a:ea typeface="Microsoft JhengHei" pitchFamily="34" charset="-122"/>
+                <a:cs typeface="Microsoft JhengHei" pitchFamily="34" charset="-120"/>
+              </a:rPr>
+              <a:t>① 提示詞 ＋ ② 後端正則</a:t>
+            </a:r>
+            <a:endParaRPr lang="en-US" sz="1350" dirty="0"/>
+          </a:p>
+        </p:txBody>
+      </p:sp>
+      <p:sp>
+        <p:nvSpPr>
+          <p:cNvPr id="7" name="Text 5"/>
+          <p:cNvSpPr/>
+          <p:nvPr/>
+        </p:nvSpPr>
+        <p:spPr>
+          <a:xfrm>
+            <a:off x="841248" y="2944368"/>
+            <a:ext cx="3051048" cy="1600200"/>
+          </a:xfrm>
+          <a:prstGeom prst="rect">
+            <a:avLst/>
+          </a:prstGeom>
+          <a:noFill/>
+          <a:ln/>
+        </p:spPr>
+        <p:txBody>
+          <a:bodyPr wrap="square" rtlCol="0" anchor="t"/>
+          <a:lstStyle/>
+          <a:p>
+            <a:pPr indent="0" marL="0">
+              <a:lnSpc>
+                <a:spcPts val="1600"/>
+              </a:lnSpc>
+              <a:buNone/>
+            </a:pPr>
+            <a:r>
+              <a:rPr lang="en-US" sz="1050" dirty="0">
+                <a:solidFill>
+                  <a:srgbClr val="D5DEF0"/>
+                </a:solidFill>
+                <a:latin typeface="Microsoft JhengHei" pitchFamily="34" charset="0"/>
+                <a:ea typeface="Microsoft JhengHei" pitchFamily="34" charset="-122"/>
+                <a:cs typeface="Microsoft JhengHei" pitchFamily="34" charset="-120"/>
+              </a:rPr>
+              <a:t>系統提示明訂永不建議買賣特定標的；輸出再過一次正則，命中就整段換成安全回覆——不是遮字，因為遮一半會被腦補成建議。</a:t>
+            </a:r>
+            <a:endParaRPr lang="en-US" sz="1050" dirty="0"/>
+          </a:p>
+        </p:txBody>
+      </p:sp>
+      <p:sp>
+        <p:nvSpPr>
+          <p:cNvPr id="8" name="Text 6"/>
+          <p:cNvSpPr/>
+          <p:nvPr/>
+        </p:nvSpPr>
+        <p:spPr>
+          <a:xfrm>
+            <a:off x="841248" y="4590288"/>
+            <a:ext cx="3051048" cy="274320"/>
+          </a:xfrm>
+          <a:prstGeom prst="rect">
+            <a:avLst/>
+          </a:prstGeom>
+          <a:noFill/>
+          <a:ln/>
+        </p:spPr>
+        <p:txBody>
+          <a:bodyPr wrap="square" rtlCol="0" anchor="ctr"/>
+          <a:lstStyle/>
+          <a:p>
+            <a:pPr indent="0" marL="0">
+              <a:buNone/>
+            </a:pPr>
+            <a:r>
+              <a:rPr lang="en-US" sz="800" dirty="0">
+                <a:solidFill>
+                  <a:srgbClr val="7C8CAC"/>
+                </a:solidFill>
+                <a:latin typeface="Consolas" pitchFamily="34" charset="0"/>
+                <a:ea typeface="Consolas" pitchFamily="34" charset="-122"/>
+                <a:cs typeface="Consolas" pitchFamily="34" charset="-120"/>
+              </a:rPr>
+              <a:t>loop.py:20｜guardrails.py:8-13, 79-100</a:t>
+            </a:r>
+            <a:endParaRPr lang="en-US" sz="800" dirty="0"/>
+          </a:p>
+        </p:txBody>
+      </p:sp>
+      <p:sp>
+        <p:nvSpPr>
+          <p:cNvPr id="9" name="Shape 7"/>
+          <p:cNvSpPr/>
+          <p:nvPr/>
+        </p:nvSpPr>
+        <p:spPr>
+          <a:xfrm>
+            <a:off x="4367784" y="2212848"/>
+            <a:ext cx="3453384" cy="2743200"/>
+          </a:xfrm>
+          <a:prstGeom prst="roundRect">
+            <a:avLst>
+              <a:gd name="adj" fmla="val 2667"/>
+            </a:avLst>
+          </a:prstGeom>
+          <a:solidFill>
+            <a:srgbClr val="1D2B5C"/>
+          </a:solidFill>
+          <a:ln w="12700">
+            <a:solidFill>
+              <a:srgbClr val="2B3B72"/>
+            </a:solidFill>
+            <a:prstDash val="solid"/>
+          </a:ln>
+        </p:spPr>
+      </p:sp>
+      <p:sp>
+        <p:nvSpPr>
+          <p:cNvPr id="10" name="Text 8"/>
+          <p:cNvSpPr/>
+          <p:nvPr/>
+        </p:nvSpPr>
+        <p:spPr>
+          <a:xfrm>
+            <a:off x="4568952" y="2377440"/>
+            <a:ext cx="3051048" cy="502920"/>
+          </a:xfrm>
+          <a:prstGeom prst="rect">
+            <a:avLst/>
+          </a:prstGeom>
+          <a:noFill/>
+          <a:ln/>
+        </p:spPr>
+        <p:txBody>
+          <a:bodyPr wrap="square" rtlCol="0" anchor="ctr"/>
+          <a:lstStyle/>
+          <a:p>
+            <a:pPr indent="0" marL="0">
+              <a:buNone/>
+            </a:pPr>
+            <a:r>
+              <a:rPr lang="en-US" sz="1350" b="1" dirty="0">
+                <a:solidFill>
+                  <a:srgbClr val="E8A13A"/>
+                </a:solidFill>
+                <a:latin typeface="Microsoft JhengHei" pitchFamily="34" charset="0"/>
+                <a:ea typeface="Microsoft JhengHei" pitchFamily="34" charset="-122"/>
+                <a:cs typeface="Microsoft JhengHei" pitchFamily="34" charset="-120"/>
+              </a:rPr>
+              <a:t>③ 前端 ＋ ④ Bedrock Guardrails</a:t>
+            </a:r>
+            <a:endParaRPr lang="en-US" sz="1350" dirty="0"/>
+          </a:p>
+        </p:txBody>
+      </p:sp>
+      <p:sp>
+        <p:nvSpPr>
+          <p:cNvPr id="11" name="Text 9"/>
+          <p:cNvSpPr/>
+          <p:nvPr/>
+        </p:nvSpPr>
+        <p:spPr>
+          <a:xfrm>
+            <a:off x="4568952" y="2944368"/>
+            <a:ext cx="3051048" cy="1600200"/>
+          </a:xfrm>
+          <a:prstGeom prst="rect">
+            <a:avLst/>
+          </a:prstGeom>
+          <a:noFill/>
+          <a:ln/>
+        </p:spPr>
+        <p:txBody>
+          <a:bodyPr wrap="square" rtlCol="0" anchor="t"/>
+          <a:lstStyle/>
+          <a:p>
+            <a:pPr indent="0" marL="0">
+              <a:lnSpc>
+                <a:spcPts val="1600"/>
+              </a:lnSpc>
+              <a:buNone/>
+            </a:pPr>
+            <a:r>
+              <a:rPr lang="en-US" sz="1050" dirty="0">
+                <a:solidFill>
+                  <a:srgbClr val="D5DEF0"/>
+                </a:solidFill>
+                <a:latin typeface="Microsoft JhengHei" pitchFamily="34" charset="0"/>
+                <a:ea typeface="Microsoft JhengHei" pitchFamily="34" charset="-122"/>
+                <a:cs typeface="Microsoft JhengHei" pitchFamily="34" charset="-120"/>
+              </a:rPr>
+              <a:t>後端萬一漏了，畫面這關再擋一次。Bedrock Guardrails 的接點已就緒，設環境變數即疊加生效。</a:t>
+            </a:r>
+            <a:endParaRPr lang="en-US" sz="1050" dirty="0"/>
+          </a:p>
+        </p:txBody>
+      </p:sp>
+      <p:sp>
+        <p:nvSpPr>
+          <p:cNvPr id="12" name="Text 10"/>
+          <p:cNvSpPr/>
+          <p:nvPr/>
+        </p:nvSpPr>
+        <p:spPr>
+          <a:xfrm>
+            <a:off x="4568952" y="4590288"/>
+            <a:ext cx="3051048" cy="274320"/>
+          </a:xfrm>
+          <a:prstGeom prst="rect">
+            <a:avLst/>
+          </a:prstGeom>
+          <a:noFill/>
+          <a:ln/>
+        </p:spPr>
+        <p:txBody>
+          <a:bodyPr wrap="square" rtlCol="0" anchor="ctr"/>
+          <a:lstStyle/>
+          <a:p>
+            <a:pPr indent="0" marL="0">
+              <a:buNone/>
+            </a:pPr>
+            <a:r>
+              <a:rPr lang="en-US" sz="800" dirty="0">
+                <a:solidFill>
+                  <a:srgbClr val="7C8CAC"/>
+                </a:solidFill>
+                <a:latin typeface="Consolas" pitchFamily="34" charset="0"/>
+                <a:ea typeface="Consolas" pitchFamily="34" charset="-122"/>
+                <a:cs typeface="Consolas" pitchFamily="34" charset="-120"/>
+              </a:rPr>
+              <a:t>chat-core.js:26-31｜loop.py:109-115</a:t>
+            </a:r>
+            <a:endParaRPr lang="en-US" sz="800" dirty="0"/>
+          </a:p>
+        </p:txBody>
+      </p:sp>
+      <p:sp>
+        <p:nvSpPr>
+          <p:cNvPr id="13" name="Shape 11"/>
+          <p:cNvSpPr/>
+          <p:nvPr/>
+        </p:nvSpPr>
+        <p:spPr>
+          <a:xfrm>
+            <a:off x="8095488" y="2212848"/>
+            <a:ext cx="3453384" cy="2743200"/>
+          </a:xfrm>
+          <a:prstGeom prst="roundRect">
+            <a:avLst>
+              <a:gd name="adj" fmla="val 2667"/>
+            </a:avLst>
+          </a:prstGeom>
+          <a:solidFill>
+            <a:srgbClr val="1D2B5C"/>
+          </a:solidFill>
+          <a:ln w="12700">
+            <a:solidFill>
+              <a:srgbClr val="2B3B72"/>
+            </a:solidFill>
+            <a:prstDash val="solid"/>
+          </a:ln>
+        </p:spPr>
+      </p:sp>
+      <p:sp>
+        <p:nvSpPr>
+          <p:cNvPr id="14" name="Text 12"/>
+          <p:cNvSpPr/>
+          <p:nvPr/>
+        </p:nvSpPr>
+        <p:spPr>
+          <a:xfrm>
+            <a:off x="8296656" y="2377440"/>
+            <a:ext cx="3051048" cy="502920"/>
+          </a:xfrm>
+          <a:prstGeom prst="rect">
+            <a:avLst/>
+          </a:prstGeom>
+          <a:noFill/>
+          <a:ln/>
+        </p:spPr>
+        <p:txBody>
+          <a:bodyPr wrap="square" rtlCol="0" anchor="ctr"/>
+          <a:lstStyle/>
+          <a:p>
+            <a:pPr indent="0" marL="0">
+              <a:buNone/>
+            </a:pPr>
+            <a:r>
+              <a:rPr lang="en-US" sz="1350" b="1" dirty="0">
+                <a:solidFill>
+                  <a:srgbClr val="E8A13A"/>
+                </a:solidFill>
+                <a:latin typeface="Microsoft JhengHei" pitchFamily="34" charset="0"/>
+                <a:ea typeface="Microsoft JhengHei" pitchFamily="34" charset="-122"/>
+                <a:cs typeface="Microsoft JhengHei" pitchFamily="34" charset="-120"/>
+              </a:rPr>
+              <a:t>還做了誤判防護</a:t>
+            </a:r>
+            <a:endParaRPr lang="en-US" sz="1350" dirty="0"/>
+          </a:p>
+        </p:txBody>
+      </p:sp>
+      <p:sp>
+        <p:nvSpPr>
+          <p:cNvPr id="15" name="Text 13"/>
+          <p:cNvSpPr/>
+          <p:nvPr/>
+        </p:nvSpPr>
+        <p:spPr>
+          <a:xfrm>
+            <a:off x="8296656" y="2944368"/>
+            <a:ext cx="3051048" cy="1600200"/>
+          </a:xfrm>
+          <a:prstGeom prst="rect">
+            <a:avLst/>
+          </a:prstGeom>
+          <a:noFill/>
+          <a:ln/>
+        </p:spPr>
+        <p:txBody>
+          <a:bodyPr wrap="square" rtlCol="0" anchor="t"/>
+          <a:lstStyle/>
+          <a:p>
+            <a:pPr indent="0" marL="0">
+              <a:lnSpc>
+                <a:spcPts val="1600"/>
+              </a:lnSpc>
+              <a:buNone/>
+            </a:pPr>
+            <a:r>
+              <a:rPr lang="en-US" sz="1050" dirty="0">
+                <a:solidFill>
+                  <a:srgbClr val="D5DEF0"/>
+                </a:solidFill>
+                <a:latin typeface="Microsoft JhengHei" pitchFamily="34" charset="0"/>
+                <a:ea typeface="Microsoft JhengHei" pitchFamily="34" charset="-122"/>
+                <a:cs typeface="Microsoft JhengHei" pitchFamily="34" charset="-120"/>
+              </a:rPr>
+              <a:t>反詐教育內容本來就必須出現「保證獲利」這種詞——那是在教人辨識詐騙。沒有語境排除，護欄會擋掉自家的反詐功能，而且是靜默失敗。</a:t>
+            </a:r>
+            <a:endParaRPr lang="en-US" sz="1050" dirty="0"/>
+          </a:p>
+        </p:txBody>
+      </p:sp>
+      <p:sp>
+        <p:nvSpPr>
+          <p:cNvPr id="16" name="Text 14"/>
+          <p:cNvSpPr/>
+          <p:nvPr/>
+        </p:nvSpPr>
+        <p:spPr>
+          <a:xfrm>
+            <a:off x="8296656" y="4590288"/>
+            <a:ext cx="3051048" cy="274320"/>
+          </a:xfrm>
+          <a:prstGeom prst="rect">
+            <a:avLst/>
+          </a:prstGeom>
+          <a:noFill/>
+          <a:ln/>
+        </p:spPr>
+        <p:txBody>
+          <a:bodyPr wrap="square" rtlCol="0" anchor="ctr"/>
+          <a:lstStyle/>
+          <a:p>
+            <a:pPr indent="0" marL="0">
+              <a:buNone/>
+            </a:pPr>
+            <a:r>
+              <a:rPr lang="en-US" sz="800" dirty="0">
+                <a:solidFill>
+                  <a:srgbClr val="7C8CAC"/>
+                </a:solidFill>
+                <a:latin typeface="Consolas" pitchFamily="34" charset="0"/>
+                <a:ea typeface="Consolas" pitchFamily="34" charset="-122"/>
+                <a:cs typeface="Consolas" pitchFamily="34" charset="-120"/>
+              </a:rPr>
+              <a:t>guardrails.py:24-29</a:t>
+            </a:r>
+            <a:endParaRPr lang="en-US" sz="800" dirty="0"/>
+          </a:p>
+        </p:txBody>
+      </p:sp>
+      <p:sp>
+        <p:nvSpPr>
+          <p:cNvPr id="17" name="Text 15"/>
+          <p:cNvSpPr/>
+          <p:nvPr/>
+        </p:nvSpPr>
+        <p:spPr>
+          <a:xfrm>
+            <a:off x="640080" y="6172200"/>
+            <a:ext cx="10908792" cy="502920"/>
+          </a:xfrm>
+          <a:prstGeom prst="rect">
+            <a:avLst/>
+          </a:prstGeom>
+          <a:noFill/>
+          <a:ln/>
+        </p:spPr>
+        <p:txBody>
+          <a:bodyPr wrap="square" rtlCol="0" anchor="t"/>
+          <a:lstStyle/>
+          <a:p>
+            <a:pPr indent="0" marL="0">
+              <a:lnSpc>
+                <a:spcPts val="1400"/>
+              </a:lnSpc>
+              <a:buNone/>
+            </a:pPr>
+            <a:r>
+              <a:rPr lang="en-US" sz="950" dirty="0">
+                <a:solidFill>
+                  <a:srgbClr val="8FA0C0"/>
+                </a:solidFill>
+                <a:latin typeface="Microsoft JhengHei" pitchFamily="34" charset="0"/>
+                <a:ea typeface="Microsoft JhengHei" pitchFamily="34" charset="-122"/>
+                <a:cs typeface="Microsoft JhengHei" pitchFamily="34" charset="-120"/>
+              </a:rPr>
+              <a:t>護欄設計不只要問「擋不擋得住壞的」，也要問「會不會擋掉好的」。</a:t>
+            </a:r>
+            <a:endParaRPr lang="en-US" sz="950" dirty="0"/>
+          </a:p>
+        </p:txBody>
+      </p:sp>
+      <p:sp>
+        <p:nvSpPr>
+          <p:cNvPr id="18" name="Text 16"/>
+          <p:cNvSpPr/>
+          <p:nvPr/>
+        </p:nvSpPr>
+        <p:spPr>
+          <a:xfrm>
+            <a:off x="11457432" y="6446520"/>
+            <a:ext cx="365760" cy="228600"/>
+          </a:xfrm>
+          <a:prstGeom prst="rect">
+            <a:avLst/>
+          </a:prstGeom>
+          <a:noFill/>
+          <a:ln/>
+        </p:spPr>
+        <p:txBody>
+          <a:bodyPr wrap="square" rtlCol="0" anchor="ctr"/>
+          <a:lstStyle/>
+          <a:p>
+            <a:pPr algn="r" indent="0" marL="0">
+              <a:buNone/>
+            </a:pPr>
+            <a:r>
+              <a:rPr lang="en-US" sz="900" dirty="0">
+                <a:solidFill>
+                  <a:srgbClr val="6B7280"/>
+                </a:solidFill>
+                <a:latin typeface="Microsoft JhengHei" pitchFamily="34" charset="0"/>
+                <a:ea typeface="Microsoft JhengHei" pitchFamily="34" charset="-122"/>
+                <a:cs typeface="Microsoft JhengHei" pitchFamily="34" charset="-120"/>
+              </a:rPr>
+              <a:t>14</a:t>
+            </a:r>
+            <a:endParaRPr lang="en-US" sz="900" dirty="0"/>
+          </a:p>
+        </p:txBody>
+      </p:sp>
+    </p:spTree>
+  </p:cSld>
+  <p:clrMapOvr>
+    <a:masterClrMapping/>
+  </p:clrMapOvr>
+</p:sld>
+</file>
+
+<file path=ppt/slides/slide15.xml><?xml version="1.0" encoding="utf-8"?>
+<p:sld xmlns:a="http://schemas.openxmlformats.org/drawingml/2006/main" xmlns:r="http://schemas.openxmlformats.org/officeDocument/2006/relationships" xmlns:p="http://schemas.openxmlformats.org/presentationml/2006/main">
+  <p:cSld name="Slide 15">
+    <p:bg>
+      <p:bgPr>
+        <a:solidFill>
+          <a:srgbClr val="16224D"/>
+        </a:solidFill>
+      </p:bgPr>
+    </p:bg>
+    <p:spTree>
+      <p:nvGrpSpPr>
+        <p:cNvPr id="1" name=""/>
+        <p:cNvGrpSpPr/>
+        <p:nvPr/>
+      </p:nvGrpSpPr>
+      <p:grpSpPr>
+        <a:xfrm>
+          <a:off x="0" y="0"/>
+          <a:ext cx="0" cy="0"/>
+          <a:chOff x="0" y="0"/>
+          <a:chExt cx="0" cy="0"/>
+        </a:xfrm>
+      </p:grpSpPr>
+      <p:sp>
+        <p:nvSpPr>
+          <p:cNvPr id="2" name="Text 0"/>
+          <p:cNvSpPr/>
+          <p:nvPr/>
+        </p:nvSpPr>
+        <p:spPr>
+          <a:xfrm>
+            <a:off x="640080" y="411480"/>
+            <a:ext cx="10908792" cy="274320"/>
+          </a:xfrm>
+          <a:prstGeom prst="rect">
+            <a:avLst/>
+          </a:prstGeom>
+          <a:noFill/>
+          <a:ln/>
+        </p:spPr>
+        <p:txBody>
+          <a:bodyPr wrap="square" rtlCol="0" anchor="ctr"/>
+          <a:lstStyle/>
+          <a:p>
+            <a:pPr indent="0" marL="0">
+              <a:buNone/>
+            </a:pPr>
+            <a:r>
+              <a:rPr lang="en-US" sz="1200" b="1" spc="150" kern="0" dirty="0">
+                <a:solidFill>
+                  <a:srgbClr val="E8A13A"/>
+                </a:solidFill>
+                <a:latin typeface="Microsoft JhengHei" pitchFamily="34" charset="0"/>
+                <a:ea typeface="Microsoft JhengHei" pitchFamily="34" charset="-122"/>
+                <a:cs typeface="Microsoft JhengHei" pitchFamily="34" charset="-120"/>
+              </a:rPr>
+              <a:t>商業模式</a:t>
+            </a:r>
+            <a:endParaRPr lang="en-US" sz="1200" dirty="0"/>
+          </a:p>
+        </p:txBody>
+      </p:sp>
+      <p:sp>
+        <p:nvSpPr>
+          <p:cNvPr id="3" name="Text 1"/>
+          <p:cNvSpPr/>
+          <p:nvPr/>
+        </p:nvSpPr>
+        <p:spPr>
+          <a:xfrm>
+            <a:off x="640080" y="795528"/>
+            <a:ext cx="10908792" cy="777240"/>
+          </a:xfrm>
+          <a:prstGeom prst="rect">
+            <a:avLst/>
+          </a:prstGeom>
+          <a:noFill/>
+          <a:ln/>
+        </p:spPr>
+        <p:txBody>
+          <a:bodyPr wrap="square" rtlCol="0" anchor="t"/>
+          <a:lstStyle/>
+          <a:p>
+            <a:pPr indent="0" marL="0">
+              <a:buNone/>
+            </a:pPr>
+            <a:r>
+              <a:rPr lang="en-US" sz="3000" b="1" dirty="0">
+                <a:solidFill>
+                  <a:srgbClr val="FFFFFF"/>
+                </a:solidFill>
+                <a:latin typeface="Microsoft JhengHei" pitchFamily="34" charset="0"/>
+                <a:ea typeface="Microsoft JhengHei" pitchFamily="34" charset="-122"/>
+                <a:cs typeface="Microsoft JhengHei" pitchFamily="34" charset="-120"/>
+              </a:rPr>
+              <a:t>平台怎麼賺錢——不是只幫客戶省錢</a:t>
+            </a:r>
+            <a:endParaRPr lang="en-US" sz="3000" dirty="0"/>
+          </a:p>
+        </p:txBody>
+      </p:sp>
+      <p:graphicFrame>
+        <p:nvGraphicFramePr>
+          <p:cNvPr id="16" name="Table 0"/>
           <p:cNvGraphicFramePr>
             <a:graphicFrameLocks noGrp="1"/>
           </p:cNvGraphicFramePr>
@@ -5764,7 +8492,7 @@
                 <a:ea typeface="Microsoft JhengHei" pitchFamily="34" charset="-122"/>
                 <a:cs typeface="Microsoft JhengHei" pitchFamily="34" charset="-120"/>
               </a:rPr>
-              <a:t>13</a:t>
+              <a:t>15</a:t>
             </a:r>
             <a:endParaRPr lang="en-US" sz="900" dirty="0"/>
           </a:p>
@@ -5778,9 +8506,9 @@
 </p:sld>
 </file>
 
-<file path=ppt/slides/slide14.xml><?xml version="1.0" encoding="utf-8"?>
+<file path=ppt/slides/slide16.xml><?xml version="1.0" encoding="utf-8"?>
 <p:sld xmlns:a="http://schemas.openxmlformats.org/drawingml/2006/main" xmlns:r="http://schemas.openxmlformats.org/officeDocument/2006/relationships" xmlns:p="http://schemas.openxmlformats.org/presentationml/2006/main">
-  <p:cSld name="Slide 14">
+  <p:cSld name="Slide 16">
     <p:bg>
       <p:bgPr>
         <a:solidFill>
@@ -5999,7 +8727,7 @@
       </p:sp>
       <p:graphicFrame>
         <p:nvGraphicFramePr>
-          <p:cNvPr id="15" name="Table 0"/>
+          <p:cNvPr id="17" name="Table 0"/>
           <p:cNvGraphicFramePr>
             <a:graphicFrameLocks noGrp="1"/>
           </p:cNvGraphicFramePr>
@@ -6518,7 +9246,7 @@
                 <a:ea typeface="Microsoft JhengHei" pitchFamily="34" charset="-122"/>
                 <a:cs typeface="Microsoft JhengHei" pitchFamily="34" charset="-120"/>
               </a:rPr>
-              <a:t>14</a:t>
+              <a:t>16</a:t>
             </a:r>
             <a:endParaRPr lang="en-US" sz="900" dirty="0"/>
           </a:p>
@@ -6532,9 +9260,9 @@
 </p:sld>
 </file>
 
-<file path=ppt/slides/slide15.xml><?xml version="1.0" encoding="utf-8"?>
+<file path=ppt/slides/slide17.xml><?xml version="1.0" encoding="utf-8"?>
 <p:sld xmlns:a="http://schemas.openxmlformats.org/drawingml/2006/main" xmlns:r="http://schemas.openxmlformats.org/officeDocument/2006/relationships" xmlns:p="http://schemas.openxmlformats.org/presentationml/2006/main">
-  <p:cSld name="Slide 15">
+  <p:cSld name="Slide 17">
     <p:bg>
       <p:bgPr>
         <a:solidFill>
@@ -6636,7 +9364,7 @@
       </p:sp>
       <p:graphicFrame>
         <p:nvGraphicFramePr>
-          <p:cNvPr id="16" name="Table 0"/>
+          <p:cNvPr id="18" name="Table 0"/>
           <p:cNvGraphicFramePr>
             <a:graphicFrameLocks noGrp="1"/>
           </p:cNvGraphicFramePr>
@@ -7883,7 +10611,7 @@
                 <a:ea typeface="Microsoft JhengHei" pitchFamily="34" charset="-122"/>
                 <a:cs typeface="Microsoft JhengHei" pitchFamily="34" charset="-120"/>
               </a:rPr>
-              <a:t>15</a:t>
+              <a:t>17</a:t>
             </a:r>
             <a:endParaRPr lang="en-US" sz="900" dirty="0"/>
           </a:p>
@@ -7897,9 +10625,9 @@
 </p:sld>
 </file>
 
-<file path=ppt/slides/slide16.xml><?xml version="1.0" encoding="utf-8"?>
+<file path=ppt/slides/slide18.xml><?xml version="1.0" encoding="utf-8"?>
 <p:sld xmlns:a="http://schemas.openxmlformats.org/drawingml/2006/main" xmlns:r="http://schemas.openxmlformats.org/officeDocument/2006/relationships" xmlns:p="http://schemas.openxmlformats.org/presentationml/2006/main">
-  <p:cSld name="Slide 16">
+  <p:cSld name="Slide 18">
     <p:bg>
       <p:bgPr>
         <a:solidFill>
@@ -8650,7 +11378,7 @@
                 <a:ea typeface="Microsoft JhengHei" pitchFamily="34" charset="-122"/>
                 <a:cs typeface="Microsoft JhengHei" pitchFamily="34" charset="-120"/>
               </a:rPr>
-              <a:t>16</a:t>
+              <a:t>18</a:t>
             </a:r>
             <a:endParaRPr lang="en-US" sz="900" dirty="0"/>
           </a:p>
@@ -8664,9 +11392,9 @@
 </p:sld>
 </file>
 
-<file path=ppt/slides/slide17.xml><?xml version="1.0" encoding="utf-8"?>
+<file path=ppt/slides/slide19.xml><?xml version="1.0" encoding="utf-8"?>
 <p:sld xmlns:a="http://schemas.openxmlformats.org/drawingml/2006/main" xmlns:r="http://schemas.openxmlformats.org/officeDocument/2006/relationships" xmlns:p="http://schemas.openxmlformats.org/presentationml/2006/main">
-  <p:cSld name="Slide 17">
+  <p:cSld name="Slide 19">
     <p:bg>
       <p:bgPr>
         <a:solidFill>
@@ -9204,158 +11932,9 @@
                 <a:ea typeface="Microsoft JhengHei" pitchFamily="34" charset="-122"/>
                 <a:cs typeface="Microsoft JhengHei" pitchFamily="34" charset="-120"/>
               </a:rPr>
-              <a:t>17</a:t>
+              <a:t>19</a:t>
             </a:r>
             <a:endParaRPr lang="en-US" sz="900" dirty="0"/>
-          </a:p>
-        </p:txBody>
-      </p:sp>
-    </p:spTree>
-  </p:cSld>
-  <p:clrMapOvr>
-    <a:masterClrMapping/>
-  </p:clrMapOvr>
-</p:sld>
-</file>
-
-<file path=ppt/slides/slide18.xml><?xml version="1.0" encoding="utf-8"?>
-<p:sld xmlns:a="http://schemas.openxmlformats.org/drawingml/2006/main" xmlns:r="http://schemas.openxmlformats.org/officeDocument/2006/relationships" xmlns:p="http://schemas.openxmlformats.org/presentationml/2006/main">
-  <p:cSld name="Slide 18">
-    <p:bg>
-      <p:bgPr>
-        <a:solidFill>
-          <a:srgbClr val="0D1530"/>
-        </a:solidFill>
-      </p:bgPr>
-    </p:bg>
-    <p:spTree>
-      <p:nvGrpSpPr>
-        <p:cNvPr id="1" name=""/>
-        <p:cNvGrpSpPr/>
-        <p:nvPr/>
-      </p:nvGrpSpPr>
-      <p:grpSpPr>
-        <a:xfrm>
-          <a:off x="0" y="0"/>
-          <a:ext cx="0" cy="0"/>
-          <a:chOff x="0" y="0"/>
-          <a:chExt cx="0" cy="0"/>
-        </a:xfrm>
-      </p:grpSpPr>
-      <p:sp>
-        <p:nvSpPr>
-          <p:cNvPr id="2" name="Text 0"/>
-          <p:cNvSpPr/>
-          <p:nvPr/>
-        </p:nvSpPr>
-        <p:spPr>
-          <a:xfrm>
-            <a:off x="640080" y="2103120"/>
-            <a:ext cx="10908792" cy="1280160"/>
-          </a:xfrm>
-          <a:prstGeom prst="rect">
-            <a:avLst/>
-          </a:prstGeom>
-          <a:noFill/>
-          <a:ln/>
-        </p:spPr>
-        <p:txBody>
-          <a:bodyPr wrap="square" rtlCol="0" anchor="ctr"/>
-          <a:lstStyle/>
-          <a:p>
-            <a:pPr indent="0" marL="0">
-              <a:buNone/>
-            </a:pPr>
-            <a:r>
-              <a:rPr lang="en-US" sz="5400" b="1" dirty="0">
-                <a:solidFill>
-                  <a:srgbClr val="FFFFFF"/>
-                </a:solidFill>
-                <a:latin typeface="Microsoft JhengHei" pitchFamily="34" charset="0"/>
-                <a:ea typeface="Microsoft JhengHei" pitchFamily="34" charset="-122"/>
-                <a:cs typeface="Microsoft JhengHei" pitchFamily="34" charset="-120"/>
-              </a:rPr>
-              <a:t>洞察 → 對話 → 行動</a:t>
-            </a:r>
-            <a:endParaRPr lang="en-US" sz="5400" dirty="0"/>
-          </a:p>
-        </p:txBody>
-      </p:sp>
-      <p:sp>
-        <p:nvSpPr>
-          <p:cNvPr id="3" name="Text 1"/>
-          <p:cNvSpPr/>
-          <p:nvPr/>
-        </p:nvSpPr>
-        <p:spPr>
-          <a:xfrm>
-            <a:off x="640080" y="3383280"/>
-            <a:ext cx="10908792" cy="731520"/>
-          </a:xfrm>
-          <a:prstGeom prst="rect">
-            <a:avLst/>
-          </a:prstGeom>
-          <a:noFill/>
-          <a:ln/>
-        </p:spPr>
-        <p:txBody>
-          <a:bodyPr wrap="square" rtlCol="0" anchor="ctr"/>
-          <a:lstStyle/>
-          <a:p>
-            <a:pPr indent="0" marL="0">
-              <a:buNone/>
-            </a:pPr>
-            <a:r>
-              <a:rPr lang="en-US" sz="2200" dirty="0">
-                <a:solidFill>
-                  <a:srgbClr val="E8A13A"/>
-                </a:solidFill>
-                <a:latin typeface="Microsoft JhengHei" pitchFamily="34" charset="0"/>
-                <a:ea typeface="Microsoft JhengHei" pitchFamily="34" charset="-122"/>
-                <a:cs typeface="Microsoft JhengHei" pitchFamily="34" charset="-120"/>
-              </a:rPr>
-              <a:t>AI 有手，方向盤在人手上</a:t>
-            </a:r>
-            <a:endParaRPr lang="en-US" sz="2200" dirty="0"/>
-          </a:p>
-        </p:txBody>
-      </p:sp>
-      <p:sp>
-        <p:nvSpPr>
-          <p:cNvPr id="4" name="Text 2"/>
-          <p:cNvSpPr/>
-          <p:nvPr/>
-        </p:nvSpPr>
-        <p:spPr>
-          <a:xfrm>
-            <a:off x="640080" y="5394960"/>
-            <a:ext cx="10908792" cy="365760"/>
-          </a:xfrm>
-          <a:prstGeom prst="rect">
-            <a:avLst/>
-          </a:prstGeom>
-          <a:noFill/>
-          <a:ln/>
-        </p:spPr>
-        <p:txBody>
-          <a:bodyPr wrap="square" rtlCol="0" anchor="ctr"/>
-          <a:lstStyle/>
-          <a:p>
-            <a:pPr indent="0" marL="0">
-              <a:buNone/>
-            </a:pPr>
-            <a:r>
-              <a:rPr lang="en-US" sz="1200" dirty="0">
-                <a:solidFill>
-                  <a:srgbClr val="6B7280"/>
-                </a:solidFill>
-                <a:latin typeface="Microsoft JhengHei" pitchFamily="34" charset="0"/>
-                <a:ea typeface="Microsoft JhengHei" pitchFamily="34" charset="-122"/>
-                <a:cs typeface="Microsoft JhengHei" pitchFamily="34" charset="-120"/>
-              </a:rPr>
-              <a:t>github.com/giont565/MaiMate</a:t>
-            </a:r>
-            <a:endParaRPr lang="en-US" sz="1200" dirty="0"/>
           </a:p>
         </p:txBody>
       </p:sp>
@@ -9596,6 +12175,155 @@
               <a:t>2</a:t>
             </a:r>
             <a:endParaRPr lang="en-US" sz="900" dirty="0"/>
+          </a:p>
+        </p:txBody>
+      </p:sp>
+    </p:spTree>
+  </p:cSld>
+  <p:clrMapOvr>
+    <a:masterClrMapping/>
+  </p:clrMapOvr>
+</p:sld>
+</file>
+
+<file path=ppt/slides/slide20.xml><?xml version="1.0" encoding="utf-8"?>
+<p:sld xmlns:a="http://schemas.openxmlformats.org/drawingml/2006/main" xmlns:r="http://schemas.openxmlformats.org/officeDocument/2006/relationships" xmlns:p="http://schemas.openxmlformats.org/presentationml/2006/main">
+  <p:cSld name="Slide 20">
+    <p:bg>
+      <p:bgPr>
+        <a:solidFill>
+          <a:srgbClr val="0D1530"/>
+        </a:solidFill>
+      </p:bgPr>
+    </p:bg>
+    <p:spTree>
+      <p:nvGrpSpPr>
+        <p:cNvPr id="1" name=""/>
+        <p:cNvGrpSpPr/>
+        <p:nvPr/>
+      </p:nvGrpSpPr>
+      <p:grpSpPr>
+        <a:xfrm>
+          <a:off x="0" y="0"/>
+          <a:ext cx="0" cy="0"/>
+          <a:chOff x="0" y="0"/>
+          <a:chExt cx="0" cy="0"/>
+        </a:xfrm>
+      </p:grpSpPr>
+      <p:sp>
+        <p:nvSpPr>
+          <p:cNvPr id="2" name="Text 0"/>
+          <p:cNvSpPr/>
+          <p:nvPr/>
+        </p:nvSpPr>
+        <p:spPr>
+          <a:xfrm>
+            <a:off x="640080" y="2103120"/>
+            <a:ext cx="10908792" cy="1280160"/>
+          </a:xfrm>
+          <a:prstGeom prst="rect">
+            <a:avLst/>
+          </a:prstGeom>
+          <a:noFill/>
+          <a:ln/>
+        </p:spPr>
+        <p:txBody>
+          <a:bodyPr wrap="square" rtlCol="0" anchor="ctr"/>
+          <a:lstStyle/>
+          <a:p>
+            <a:pPr indent="0" marL="0">
+              <a:buNone/>
+            </a:pPr>
+            <a:r>
+              <a:rPr lang="en-US" sz="5400" b="1" dirty="0">
+                <a:solidFill>
+                  <a:srgbClr val="FFFFFF"/>
+                </a:solidFill>
+                <a:latin typeface="Microsoft JhengHei" pitchFamily="34" charset="0"/>
+                <a:ea typeface="Microsoft JhengHei" pitchFamily="34" charset="-122"/>
+                <a:cs typeface="Microsoft JhengHei" pitchFamily="34" charset="-120"/>
+              </a:rPr>
+              <a:t>洞察 → 對話 → 行動</a:t>
+            </a:r>
+            <a:endParaRPr lang="en-US" sz="5400" dirty="0"/>
+          </a:p>
+        </p:txBody>
+      </p:sp>
+      <p:sp>
+        <p:nvSpPr>
+          <p:cNvPr id="3" name="Text 1"/>
+          <p:cNvSpPr/>
+          <p:nvPr/>
+        </p:nvSpPr>
+        <p:spPr>
+          <a:xfrm>
+            <a:off x="640080" y="3383280"/>
+            <a:ext cx="10908792" cy="731520"/>
+          </a:xfrm>
+          <a:prstGeom prst="rect">
+            <a:avLst/>
+          </a:prstGeom>
+          <a:noFill/>
+          <a:ln/>
+        </p:spPr>
+        <p:txBody>
+          <a:bodyPr wrap="square" rtlCol="0" anchor="ctr"/>
+          <a:lstStyle/>
+          <a:p>
+            <a:pPr indent="0" marL="0">
+              <a:buNone/>
+            </a:pPr>
+            <a:r>
+              <a:rPr lang="en-US" sz="2200" dirty="0">
+                <a:solidFill>
+                  <a:srgbClr val="E8A13A"/>
+                </a:solidFill>
+                <a:latin typeface="Microsoft JhengHei" pitchFamily="34" charset="0"/>
+                <a:ea typeface="Microsoft JhengHei" pitchFamily="34" charset="-122"/>
+                <a:cs typeface="Microsoft JhengHei" pitchFamily="34" charset="-120"/>
+              </a:rPr>
+              <a:t>AI 有手，方向盤在人手上</a:t>
+            </a:r>
+            <a:endParaRPr lang="en-US" sz="2200" dirty="0"/>
+          </a:p>
+        </p:txBody>
+      </p:sp>
+      <p:sp>
+        <p:nvSpPr>
+          <p:cNvPr id="4" name="Text 2"/>
+          <p:cNvSpPr/>
+          <p:nvPr/>
+        </p:nvSpPr>
+        <p:spPr>
+          <a:xfrm>
+            <a:off x="640080" y="5394960"/>
+            <a:ext cx="10908792" cy="365760"/>
+          </a:xfrm>
+          <a:prstGeom prst="rect">
+            <a:avLst/>
+          </a:prstGeom>
+          <a:noFill/>
+          <a:ln/>
+        </p:spPr>
+        <p:txBody>
+          <a:bodyPr wrap="square" rtlCol="0" anchor="ctr"/>
+          <a:lstStyle/>
+          <a:p>
+            <a:pPr indent="0" marL="0">
+              <a:buNone/>
+            </a:pPr>
+            <a:r>
+              <a:rPr lang="en-US" sz="1200" dirty="0">
+                <a:solidFill>
+                  <a:srgbClr val="6B7280"/>
+                </a:solidFill>
+                <a:latin typeface="Microsoft JhengHei" pitchFamily="34" charset="0"/>
+                <a:ea typeface="Microsoft JhengHei" pitchFamily="34" charset="-122"/>
+                <a:cs typeface="Microsoft JhengHei" pitchFamily="34" charset="-120"/>
+              </a:rPr>
+              <a:t>github.com/giont565/MaiMate</a:t>
+            </a:r>
+            <a:endParaRPr lang="en-US" sz="1200" dirty="0"/>
           </a:p>
         </p:txBody>
       </p:sp>

</xml_diff>